<commit_message>
Rebuild intro timeline from sprint schedule
Co-Authored-By: Claude Opus 5.5 <noreply@anthropic.com>
Claude-Session: https://claude.ai/code/session_011iFrL2Hfizgp6kYckDtNGc
</commit_message>
<xml_diff>
--- a/答辩PPT.pptx
+++ b/答辩PPT.pptx
@@ -18329,8 +18329,8 @@
         </p:nvSpPr>
         <p:spPr>
           <a:xfrm>
-            <a:off x="4434840" y="1481328"/>
-            <a:ext cx="4417916" cy="384048"/>
+            <a:off x="4343400" y="1481328"/>
+            <a:ext cx="3977639" cy="384048"/>
           </a:xfrm>
           <a:prstGeom prst="roundRect">
             <a:avLst>
@@ -18373,8 +18373,8 @@
         </p:nvSpPr>
         <p:spPr>
           <a:xfrm>
-            <a:off x="4434840" y="1481328"/>
-            <a:ext cx="4417916" cy="384048"/>
+            <a:off x="4343400" y="1481328"/>
+            <a:ext cx="3977639" cy="384048"/>
           </a:xfrm>
           <a:prstGeom prst="rect">
             <a:avLst/>
@@ -18410,8 +18410,8 @@
         </p:nvSpPr>
         <p:spPr>
           <a:xfrm>
-            <a:off x="8370801" y="1481328"/>
-            <a:ext cx="3379238" cy="384048"/>
+            <a:off x="7680959" y="1481328"/>
+            <a:ext cx="3985014" cy="384048"/>
           </a:xfrm>
           <a:prstGeom prst="homePlate">
             <a:avLst/>
@@ -18452,8 +18452,8 @@
         </p:nvSpPr>
         <p:spPr>
           <a:xfrm>
-            <a:off x="8370801" y="1481328"/>
-            <a:ext cx="3333518" cy="384048"/>
+            <a:off x="7680959" y="1481328"/>
+            <a:ext cx="3985014" cy="384048"/>
           </a:xfrm>
           <a:prstGeom prst="rect">
             <a:avLst/>
@@ -18489,8 +18489,8 @@
         </p:nvCxnSpPr>
         <p:spPr>
           <a:xfrm>
-            <a:off x="4434840" y="2240280"/>
-            <a:ext cx="7269480" cy="0"/>
+            <a:off x="4343400" y="2240280"/>
+            <a:ext cx="7322574" cy="0"/>
           </a:xfrm>
           <a:prstGeom prst="line">
             <a:avLst/>
@@ -18524,7 +18524,7 @@
         </p:nvSpPr>
         <p:spPr>
           <a:xfrm>
-            <a:off x="4229731" y="1938528"/>
+            <a:off x="4023359" y="1938528"/>
             <a:ext cx="731520" cy="237744"/>
           </a:xfrm>
           <a:prstGeom prst="rect">
@@ -18561,7 +18561,7 @@
         </p:nvSpPr>
         <p:spPr>
           <a:xfrm>
-            <a:off x="4549771" y="2194560"/>
+            <a:off x="4343400" y="2194560"/>
             <a:ext cx="91440" cy="91440"/>
           </a:xfrm>
           <a:prstGeom prst="ellipse">
@@ -18605,8 +18605,8 @@
         </p:nvCxnSpPr>
         <p:spPr>
           <a:xfrm>
-            <a:off x="4595491" y="2313432"/>
-            <a:ext cx="0" cy="3739896"/>
+            <a:off x="4389120" y="2313432"/>
+            <a:ext cx="0" cy="3721608"/>
           </a:xfrm>
           <a:prstGeom prst="line">
             <a:avLst/>
@@ -18641,7 +18641,7 @@
         </p:nvSpPr>
         <p:spPr>
           <a:xfrm>
-            <a:off x="5474780" y="1938528"/>
+            <a:off x="5074919" y="1938528"/>
             <a:ext cx="731520" cy="237744"/>
           </a:xfrm>
           <a:prstGeom prst="rect">
@@ -18678,7 +18678,7 @@
         </p:nvSpPr>
         <p:spPr>
           <a:xfrm>
-            <a:off x="5794820" y="2194560"/>
+            <a:off x="5394959" y="2194560"/>
             <a:ext cx="91440" cy="91440"/>
           </a:xfrm>
           <a:prstGeom prst="ellipse">
@@ -18722,8 +18722,8 @@
         </p:nvCxnSpPr>
         <p:spPr>
           <a:xfrm>
-            <a:off x="5840540" y="2313432"/>
-            <a:ext cx="0" cy="3739896"/>
+            <a:off x="5440679" y="2313432"/>
+            <a:ext cx="0" cy="3721608"/>
           </a:xfrm>
           <a:prstGeom prst="line">
             <a:avLst/>
@@ -18758,7 +18758,7 @@
         </p:nvSpPr>
         <p:spPr>
           <a:xfrm>
-            <a:off x="6679666" y="1938528"/>
+            <a:off x="6263639" y="1938528"/>
             <a:ext cx="731520" cy="237744"/>
           </a:xfrm>
           <a:prstGeom prst="rect">
@@ -18795,7 +18795,7 @@
         </p:nvSpPr>
         <p:spPr>
           <a:xfrm>
-            <a:off x="6999706" y="2194560"/>
+            <a:off x="6583679" y="2194560"/>
             <a:ext cx="91440" cy="91440"/>
           </a:xfrm>
           <a:prstGeom prst="ellipse">
@@ -18839,8 +18839,8 @@
         </p:nvCxnSpPr>
         <p:spPr>
           <a:xfrm>
-            <a:off x="7045426" y="2313432"/>
-            <a:ext cx="0" cy="3739896"/>
+            <a:off x="6629399" y="2313432"/>
+            <a:ext cx="0" cy="3721608"/>
           </a:xfrm>
           <a:prstGeom prst="line">
             <a:avLst/>
@@ -18875,7 +18875,7 @@
         </p:nvSpPr>
         <p:spPr>
           <a:xfrm>
-            <a:off x="7924715" y="1938528"/>
+            <a:off x="7315199" y="1938528"/>
             <a:ext cx="731520" cy="237744"/>
           </a:xfrm>
           <a:prstGeom prst="rect">
@@ -18912,7 +18912,7 @@
         </p:nvSpPr>
         <p:spPr>
           <a:xfrm>
-            <a:off x="8244755" y="2194560"/>
+            <a:off x="7635239" y="2194560"/>
             <a:ext cx="91440" cy="91440"/>
           </a:xfrm>
           <a:prstGeom prst="ellipse">
@@ -18956,8 +18956,8 @@
         </p:nvCxnSpPr>
         <p:spPr>
           <a:xfrm>
-            <a:off x="8290475" y="2313432"/>
-            <a:ext cx="0" cy="3739896"/>
+            <a:off x="7680959" y="2313432"/>
+            <a:ext cx="0" cy="3721608"/>
           </a:xfrm>
           <a:prstGeom prst="line">
             <a:avLst/>
@@ -18992,7 +18992,7 @@
         </p:nvSpPr>
         <p:spPr>
           <a:xfrm>
-            <a:off x="9169764" y="1938528"/>
+            <a:off x="8732519" y="1938528"/>
             <a:ext cx="731520" cy="237744"/>
           </a:xfrm>
           <a:prstGeom prst="rect">
@@ -19029,7 +19029,7 @@
         </p:nvSpPr>
         <p:spPr>
           <a:xfrm>
-            <a:off x="9489804" y="2194560"/>
+            <a:off x="9052559" y="2194560"/>
             <a:ext cx="91440" cy="91440"/>
           </a:xfrm>
           <a:prstGeom prst="ellipse">
@@ -19073,8 +19073,8 @@
         </p:nvCxnSpPr>
         <p:spPr>
           <a:xfrm>
-            <a:off x="9535524" y="2313432"/>
-            <a:ext cx="0" cy="3739896"/>
+            <a:off x="9098280" y="2313432"/>
+            <a:ext cx="0" cy="3721608"/>
           </a:xfrm>
           <a:prstGeom prst="line">
             <a:avLst/>
@@ -19109,7 +19109,7 @@
         </p:nvSpPr>
         <p:spPr>
           <a:xfrm>
-            <a:off x="10374651" y="1938528"/>
+            <a:off x="10149840" y="1938528"/>
             <a:ext cx="731520" cy="237744"/>
           </a:xfrm>
           <a:prstGeom prst="rect">
@@ -19146,7 +19146,7 @@
         </p:nvSpPr>
         <p:spPr>
           <a:xfrm>
-            <a:off x="10694691" y="2194560"/>
+            <a:off x="10469880" y="2194560"/>
             <a:ext cx="91440" cy="91440"/>
           </a:xfrm>
           <a:prstGeom prst="ellipse">
@@ -19190,8 +19190,8 @@
         </p:nvCxnSpPr>
         <p:spPr>
           <a:xfrm>
-            <a:off x="10740411" y="2313432"/>
-            <a:ext cx="0" cy="3739896"/>
+            <a:off x="10515600" y="2313432"/>
+            <a:ext cx="0" cy="3721608"/>
           </a:xfrm>
           <a:prstGeom prst="line">
             <a:avLst/>
@@ -19226,8 +19226,8 @@
         </p:nvSpPr>
         <p:spPr>
           <a:xfrm>
-            <a:off x="3200400" y="2395728"/>
-            <a:ext cx="1097280" cy="566928"/>
+            <a:off x="3200400" y="2450592"/>
+            <a:ext cx="1005840" cy="1060704"/>
           </a:xfrm>
           <a:prstGeom prst="roundRect">
             <a:avLst>
@@ -19235,7 +19235,7 @@
             </a:avLst>
           </a:prstGeom>
           <a:solidFill>
-            <a:srgbClr val="FF7A1A"/>
+            <a:srgbClr val="287DFA"/>
           </a:solidFill>
           <a:ln>
             <a:noFill/>
@@ -19270,8 +19270,8 @@
         </p:nvSpPr>
         <p:spPr>
           <a:xfrm>
-            <a:off x="3200400" y="2395728"/>
-            <a:ext cx="1097280" cy="566928"/>
+            <a:off x="3200400" y="2450592"/>
+            <a:ext cx="1005840" cy="1060704"/>
           </a:xfrm>
           <a:prstGeom prst="rect">
             <a:avLst/>
@@ -19286,7 +19286,7 @@
           <a:p>
             <a:pPr algn="ctr"/>
             <a:r>
-              <a:rPr sz="1200" b="1">
+              <a:rPr sz="1300" b="1">
                 <a:solidFill>
                   <a:srgbClr val="FFFFFF"/>
                 </a:solidFill>
@@ -19294,187 +19294,43 @@
                 <a:ea typeface="微软雅黑"/>
                 <a:cs typeface="微软雅黑"/>
               </a:rPr>
-              <a:t>业务学习</a:t>
+              <a:t>火车票</a:t>
             </a:r>
           </a:p>
-        </p:txBody>
-      </p:sp>
-      <p:sp>
-        <p:nvSpPr>
-          <p:cNvPr id="39" name="Rounded Rectangle 38"/>
-          <p:cNvSpPr/>
-          <p:nvPr/>
-        </p:nvSpPr>
-        <p:spPr>
-          <a:xfrm>
-            <a:off x="4434840" y="2395728"/>
-            <a:ext cx="1084397" cy="237744"/>
-          </a:xfrm>
-          <a:prstGeom prst="roundRect">
-            <a:avLst>
-              <a:gd name="adj" fmla="val 30000"/>
-            </a:avLst>
-          </a:prstGeom>
-          <a:solidFill>
-            <a:srgbClr val="FF7A1A"/>
-          </a:solidFill>
-          <a:ln>
-            <a:noFill/>
-          </a:ln>
-          <a:effectLst/>
-        </p:spPr>
-        <p:style>
-          <a:lnRef idx="1">
-            <a:schemeClr val="accent1"/>
-          </a:lnRef>
-          <a:fillRef idx="3">
-            <a:schemeClr val="accent1"/>
-          </a:fillRef>
-          <a:effectRef idx="2">
-            <a:schemeClr val="accent1"/>
-          </a:effectRef>
-          <a:fontRef idx="minor">
-            <a:schemeClr val="lt1"/>
-          </a:fontRef>
-        </p:style>
-        <p:txBody>
-          <a:bodyPr rtlCol="0" anchor="ctr"/>
-          <a:lstStyle/>
-          <a:p/>
-        </p:txBody>
-      </p:sp>
-      <p:sp>
-        <p:nvSpPr>
-          <p:cNvPr id="40" name="TextBox 39"/>
-          <p:cNvSpPr txBox="1"/>
-          <p:nvPr/>
-        </p:nvSpPr>
-        <p:spPr>
-          <a:xfrm>
-            <a:off x="5574101" y="2395728"/>
-            <a:ext cx="1728216" cy="237744"/>
-          </a:xfrm>
-          <a:prstGeom prst="rect">
-            <a:avLst/>
-          </a:prstGeom>
-          <a:noFill/>
-        </p:spPr>
-        <p:txBody>
-          <a:bodyPr wrap="square" lIns="0" rIns="0" tIns="0" bIns="0" anchor="ctr">
-            <a:spAutoFit/>
-          </a:bodyPr>
-          <a:lstStyle/>
           <a:p>
-            <a:pPr algn="l"/>
+            <a:pPr algn="ctr">
+              <a:spcBef>
+                <a:spcPts val="0"/>
+              </a:spcBef>
+            </a:pPr>
             <a:r>
-              <a:rPr sz="1100" b="1">
+              <a:rPr sz="1300" b="1">
                 <a:solidFill>
-                  <a:srgbClr val="FF7A1A"/>
+                  <a:srgbClr val="FFFFFF"/>
                 </a:solidFill>
                 <a:latin typeface="微软雅黑"/>
                 <a:ea typeface="微软雅黑"/>
                 <a:cs typeface="微软雅黑"/>
               </a:rPr>
-              <a:t>竞品分析与业务熟悉</a:t>
+              <a:t>Agent</a:t>
             </a:r>
           </a:p>
         </p:txBody>
       </p:sp>
       <p:sp>
         <p:nvSpPr>
-          <p:cNvPr id="41" name="Rounded Rectangle 40"/>
+          <p:cNvPr id="39" name="Rounded Rectangle 38"/>
           <p:cNvSpPr/>
           <p:nvPr/>
         </p:nvSpPr>
         <p:spPr>
           <a:xfrm>
-            <a:off x="8370801" y="2706624"/>
-            <a:ext cx="361465" cy="237744"/>
+            <a:off x="4343400" y="2450592"/>
+            <a:ext cx="1063358" cy="292607"/>
           </a:xfrm>
           <a:prstGeom prst="roundRect">
             <a:avLst>
               <a:gd name="adj" fmla="val 30000"/>
-            </a:avLst>
-          </a:prstGeom>
-          <a:solidFill>
-            <a:srgbClr val="FF7A1A"/>
-          </a:solidFill>
-          <a:ln>
-            <a:noFill/>
-          </a:ln>
-          <a:effectLst/>
-        </p:spPr>
-        <p:style>
-          <a:lnRef idx="1">
-            <a:schemeClr val="accent1"/>
-          </a:lnRef>
-          <a:fillRef idx="3">
-            <a:schemeClr val="accent1"/>
-          </a:fillRef>
-          <a:effectRef idx="2">
-            <a:schemeClr val="accent1"/>
-          </a:effectRef>
-          <a:fontRef idx="minor">
-            <a:schemeClr val="lt1"/>
-          </a:fontRef>
-        </p:style>
-        <p:txBody>
-          <a:bodyPr rtlCol="0" anchor="ctr"/>
-          <a:lstStyle/>
-          <a:p/>
-        </p:txBody>
-      </p:sp>
-      <p:sp>
-        <p:nvSpPr>
-          <p:cNvPr id="42" name="TextBox 41"/>
-          <p:cNvSpPr txBox="1"/>
-          <p:nvPr/>
-        </p:nvSpPr>
-        <p:spPr>
-          <a:xfrm>
-            <a:off x="8787131" y="2706624"/>
-            <a:ext cx="1728216" cy="237744"/>
-          </a:xfrm>
-          <a:prstGeom prst="rect">
-            <a:avLst/>
-          </a:prstGeom>
-          <a:noFill/>
-        </p:spPr>
-        <p:txBody>
-          <a:bodyPr wrap="square" lIns="0" rIns="0" tIns="0" bIns="0" anchor="ctr">
-            <a:spAutoFit/>
-          </a:bodyPr>
-          <a:lstStyle/>
-          <a:p>
-            <a:pPr algn="l"/>
-            <a:r>
-              <a:rPr sz="1100" b="1">
-                <a:solidFill>
-                  <a:srgbClr val="FF7A1A"/>
-                </a:solidFill>
-                <a:latin typeface="微软雅黑"/>
-                <a:ea typeface="微软雅黑"/>
-                <a:cs typeface="微软雅黑"/>
-              </a:rPr>
-              <a:t>抢票 &amp; 收益交接</a:t>
-            </a:r>
-          </a:p>
-        </p:txBody>
-      </p:sp>
-      <p:sp>
-        <p:nvSpPr>
-          <p:cNvPr id="43" name="Rounded Rectangle 42"/>
-          <p:cNvSpPr/>
-          <p:nvPr/>
-        </p:nvSpPr>
-        <p:spPr>
-          <a:xfrm>
-            <a:off x="3200400" y="3127248"/>
-            <a:ext cx="1097280" cy="877824"/>
-          </a:xfrm>
-          <a:prstGeom prst="roundRect">
-            <a:avLst>
-              <a:gd name="adj" fmla="val 12000"/>
             </a:avLst>
           </a:prstGeom>
           <a:solidFill>
@@ -19507,14 +19363,14 @@
       </p:sp>
       <p:sp>
         <p:nvSpPr>
-          <p:cNvPr id="44" name="TextBox 43"/>
+          <p:cNvPr id="40" name="TextBox 39"/>
           <p:cNvSpPr txBox="1"/>
           <p:nvPr/>
         </p:nvSpPr>
         <p:spPr>
           <a:xfrm>
-            <a:off x="3200400" y="3127248"/>
-            <a:ext cx="1097280" cy="877824"/>
+            <a:off x="4343400" y="2450592"/>
+            <a:ext cx="1063358" cy="292607"/>
           </a:xfrm>
           <a:prstGeom prst="rect">
             <a:avLst/>
@@ -19529,7 +19385,7 @@
           <a:p>
             <a:pPr algn="ctr"/>
             <a:r>
-              <a:rPr sz="1200" b="1">
+              <a:rPr sz="1100" b="1">
                 <a:solidFill>
                   <a:srgbClr val="FFFFFF"/>
                 </a:solidFill>
@@ -19537,21 +19393,21 @@
                 <a:ea typeface="微软雅黑"/>
                 <a:cs typeface="微软雅黑"/>
               </a:rPr>
-              <a:t>火车票 Agent</a:t>
+              <a:t>竞品分析</a:t>
             </a:r>
           </a:p>
         </p:txBody>
       </p:sp>
       <p:sp>
         <p:nvSpPr>
-          <p:cNvPr id="45" name="Rounded Rectangle 44"/>
+          <p:cNvPr id="41" name="Rounded Rectangle 40"/>
           <p:cNvSpPr/>
           <p:nvPr/>
         </p:nvSpPr>
         <p:spPr>
           <a:xfrm>
-            <a:off x="5278260" y="3127248"/>
-            <a:ext cx="1004071" cy="237744"/>
+            <a:off x="5440679" y="2834640"/>
+            <a:ext cx="1426169" cy="292607"/>
           </a:xfrm>
           <a:prstGeom prst="roundRect">
             <a:avLst>
@@ -19588,14 +19444,14 @@
       </p:sp>
       <p:sp>
         <p:nvSpPr>
-          <p:cNvPr id="46" name="TextBox 45"/>
+          <p:cNvPr id="42" name="TextBox 41"/>
           <p:cNvSpPr txBox="1"/>
           <p:nvPr/>
         </p:nvSpPr>
         <p:spPr>
           <a:xfrm>
-            <a:off x="6337196" y="3127248"/>
-            <a:ext cx="2167127" cy="237744"/>
+            <a:off x="5440679" y="2834640"/>
+            <a:ext cx="1426169" cy="292607"/>
           </a:xfrm>
           <a:prstGeom prst="rect">
             <a:avLst/>
@@ -19608,31 +19464,31 @@
           </a:bodyPr>
           <a:lstStyle/>
           <a:p>
-            <a:pPr algn="l"/>
+            <a:pPr algn="ctr"/>
             <a:r>
               <a:rPr sz="1100" b="1">
                 <a:solidFill>
-                  <a:srgbClr val="287DFA"/>
+                  <a:srgbClr val="FFFFFF"/>
                 </a:solidFill>
                 <a:latin typeface="微软雅黑"/>
                 <a:ea typeface="微软雅黑"/>
                 <a:cs typeface="微软雅黑"/>
               </a:rPr>
-              <a:t>一期：意图识别与上线验收</a:t>
+              <a:t>一期：意图识别</a:t>
             </a:r>
           </a:p>
         </p:txBody>
       </p:sp>
       <p:sp>
         <p:nvSpPr>
-          <p:cNvPr id="47" name="Rounded Rectangle 46"/>
+          <p:cNvPr id="43" name="Rounded Rectangle 42"/>
           <p:cNvSpPr/>
           <p:nvPr/>
         </p:nvSpPr>
         <p:spPr>
           <a:xfrm>
-            <a:off x="7406892" y="3438144"/>
-            <a:ext cx="843420" cy="237744"/>
+            <a:off x="6900770" y="3218688"/>
+            <a:ext cx="1648869" cy="292607"/>
           </a:xfrm>
           <a:prstGeom prst="roundRect">
             <a:avLst>
@@ -19669,14 +19525,14 @@
       </p:sp>
       <p:sp>
         <p:nvSpPr>
-          <p:cNvPr id="48" name="TextBox 47"/>
+          <p:cNvPr id="44" name="TextBox 43"/>
           <p:cNvSpPr txBox="1"/>
           <p:nvPr/>
         </p:nvSpPr>
         <p:spPr>
           <a:xfrm>
-            <a:off x="8305176" y="3438144"/>
-            <a:ext cx="2606039" cy="237744"/>
+            <a:off x="6900770" y="3218688"/>
+            <a:ext cx="1648869" cy="292607"/>
           </a:xfrm>
           <a:prstGeom prst="rect">
             <a:avLst/>
@@ -19689,112 +19545,31 @@
           </a:bodyPr>
           <a:lstStyle/>
           <a:p>
-            <a:pPr algn="l"/>
+            <a:pPr algn="ctr"/>
             <a:r>
               <a:rPr sz="1100" b="1">
                 <a:solidFill>
-                  <a:srgbClr val="287DFA"/>
+                  <a:srgbClr val="FFFFFF"/>
                 </a:solidFill>
                 <a:latin typeface="微软雅黑"/>
                 <a:ea typeface="微软雅黑"/>
                 <a:cs typeface="微软雅黑"/>
               </a:rPr>
-              <a:t>二期：验收与 GUI 实验分析</a:t>
+              <a:t>二期：验收与拒答治理</a:t>
             </a:r>
           </a:p>
         </p:txBody>
       </p:sp>
       <p:sp>
         <p:nvSpPr>
-          <p:cNvPr id="49" name="Rounded Rectangle 48"/>
+          <p:cNvPr id="45" name="Rounded Rectangle 44"/>
           <p:cNvSpPr/>
           <p:nvPr/>
         </p:nvSpPr>
         <p:spPr>
           <a:xfrm>
-            <a:off x="8410964" y="3749039"/>
-            <a:ext cx="642605" cy="237744"/>
-          </a:xfrm>
-          <a:prstGeom prst="roundRect">
-            <a:avLst>
-              <a:gd name="adj" fmla="val 30000"/>
-            </a:avLst>
-          </a:prstGeom>
-          <a:solidFill>
-            <a:srgbClr val="287DFA"/>
-          </a:solidFill>
-          <a:ln>
-            <a:noFill/>
-          </a:ln>
-          <a:effectLst/>
-        </p:spPr>
-        <p:style>
-          <a:lnRef idx="1">
-            <a:schemeClr val="accent1"/>
-          </a:lnRef>
-          <a:fillRef idx="3">
-            <a:schemeClr val="accent1"/>
-          </a:fillRef>
-          <a:effectRef idx="2">
-            <a:schemeClr val="accent1"/>
-          </a:effectRef>
-          <a:fontRef idx="minor">
-            <a:schemeClr val="lt1"/>
-          </a:fontRef>
-        </p:style>
-        <p:txBody>
-          <a:bodyPr rtlCol="0" anchor="ctr"/>
-          <a:lstStyle/>
-          <a:p/>
-        </p:txBody>
-      </p:sp>
-      <p:sp>
-        <p:nvSpPr>
-          <p:cNvPr id="50" name="TextBox 49"/>
-          <p:cNvSpPr txBox="1"/>
-          <p:nvPr/>
-        </p:nvSpPr>
-        <p:spPr>
-          <a:xfrm>
-            <a:off x="9108434" y="3749039"/>
-            <a:ext cx="1435608" cy="237744"/>
-          </a:xfrm>
-          <a:prstGeom prst="rect">
-            <a:avLst/>
-          </a:prstGeom>
-          <a:noFill/>
-        </p:spPr>
-        <p:txBody>
-          <a:bodyPr wrap="square" lIns="0" rIns="0" tIns="0" bIns="0" anchor="ctr">
-            <a:spAutoFit/>
-          </a:bodyPr>
-          <a:lstStyle/>
-          <a:p>
-            <a:pPr algn="l"/>
-            <a:r>
-              <a:rPr sz="1100" b="1">
-                <a:solidFill>
-                  <a:srgbClr val="287DFA"/>
-                </a:solidFill>
-                <a:latin typeface="微软雅黑"/>
-                <a:ea typeface="微软雅黑"/>
-                <a:cs typeface="微软雅黑"/>
-              </a:rPr>
-              <a:t>拒答治理与交接</a:t>
-            </a:r>
-          </a:p>
-        </p:txBody>
-      </p:sp>
-      <p:sp>
-        <p:nvSpPr>
-          <p:cNvPr id="51" name="Rounded Rectangle 50"/>
-          <p:cNvSpPr/>
-          <p:nvPr/>
-        </p:nvSpPr>
-        <p:spPr>
-          <a:xfrm>
-            <a:off x="3200400" y="4169664"/>
-            <a:ext cx="1097280" cy="1188720"/>
+            <a:off x="3200400" y="3803904"/>
+            <a:ext cx="1005840" cy="2212848"/>
           </a:xfrm>
           <a:prstGeom prst="roundRect">
             <a:avLst>
@@ -19831,14 +19606,14 @@
       </p:sp>
       <p:sp>
         <p:nvSpPr>
-          <p:cNvPr id="52" name="TextBox 51"/>
+          <p:cNvPr id="46" name="TextBox 45"/>
           <p:cNvSpPr txBox="1"/>
           <p:nvPr/>
         </p:nvSpPr>
         <p:spPr>
           <a:xfrm>
-            <a:off x="3200400" y="4169664"/>
-            <a:ext cx="1097280" cy="1188720"/>
+            <a:off x="3200400" y="3803904"/>
+            <a:ext cx="1005840" cy="2212848"/>
           </a:xfrm>
           <a:prstGeom prst="rect">
             <a:avLst/>
@@ -19853,7 +19628,7 @@
           <a:p>
             <a:pPr algn="ctr"/>
             <a:r>
-              <a:rPr sz="1200" b="1">
+              <a:rPr sz="1300" b="1">
                 <a:solidFill>
                   <a:srgbClr val="FFFFFF"/>
                 </a:solidFill>
@@ -19868,14 +19643,14 @@
       </p:sp>
       <p:sp>
         <p:nvSpPr>
-          <p:cNvPr id="53" name="Rounded Rectangle 52"/>
+          <p:cNvPr id="47" name="Rounded Rectangle 46"/>
           <p:cNvSpPr/>
           <p:nvPr/>
         </p:nvSpPr>
         <p:spPr>
           <a:xfrm>
-            <a:off x="8651941" y="4169664"/>
-            <a:ext cx="1486026" cy="237744"/>
+            <a:off x="7138219" y="3803904"/>
+            <a:ext cx="2054548" cy="292607"/>
           </a:xfrm>
           <a:prstGeom prst="roundRect">
             <a:avLst>
@@ -19912,14 +19687,176 @@
       </p:sp>
       <p:sp>
         <p:nvSpPr>
-          <p:cNvPr id="54" name="TextBox 53"/>
+          <p:cNvPr id="48" name="TextBox 47"/>
           <p:cNvSpPr txBox="1"/>
           <p:nvPr/>
         </p:nvSpPr>
         <p:spPr>
           <a:xfrm>
-            <a:off x="8651941" y="4169664"/>
-            <a:ext cx="1486026" cy="237744"/>
+            <a:off x="7138219" y="3803904"/>
+            <a:ext cx="2054548" cy="292607"/>
+          </a:xfrm>
+          <a:prstGeom prst="rect">
+            <a:avLst/>
+          </a:prstGeom>
+          <a:noFill/>
+        </p:spPr>
+        <p:txBody>
+          <a:bodyPr wrap="square" lIns="0" rIns="0" tIns="0" bIns="0" anchor="ctr">
+            <a:spAutoFit/>
+          </a:bodyPr>
+          <a:lstStyle/>
+          <a:p>
+            <a:pPr algn="ctr"/>
+            <a:r>
+              <a:rPr sz="1100" b="1">
+                <a:solidFill>
+                  <a:srgbClr val="FFFFFF"/>
+                </a:solidFill>
+                <a:latin typeface="微软雅黑"/>
+                <a:ea typeface="微软雅黑"/>
+                <a:cs typeface="微软雅黑"/>
+              </a:rPr>
+              <a:t>支付失败小场景修复</a:t>
+            </a:r>
+          </a:p>
+        </p:txBody>
+      </p:sp>
+      <p:sp>
+        <p:nvSpPr>
+          <p:cNvPr id="49" name="Rounded Rectangle 48"/>
+          <p:cNvSpPr/>
+          <p:nvPr/>
+        </p:nvSpPr>
+        <p:spPr>
+          <a:xfrm>
+            <a:off x="7680959" y="4187952"/>
+            <a:ext cx="2409444" cy="292607"/>
+          </a:xfrm>
+          <a:prstGeom prst="roundRect">
+            <a:avLst>
+              <a:gd name="adj" fmla="val 30000"/>
+            </a:avLst>
+          </a:prstGeom>
+          <a:solidFill>
+            <a:srgbClr val="15315E"/>
+          </a:solidFill>
+          <a:ln>
+            <a:noFill/>
+          </a:ln>
+          <a:effectLst/>
+        </p:spPr>
+        <p:style>
+          <a:lnRef idx="1">
+            <a:schemeClr val="accent1"/>
+          </a:lnRef>
+          <a:fillRef idx="3">
+            <a:schemeClr val="accent1"/>
+          </a:fillRef>
+          <a:effectRef idx="2">
+            <a:schemeClr val="accent1"/>
+          </a:effectRef>
+          <a:fontRef idx="minor">
+            <a:schemeClr val="lt1"/>
+          </a:fontRef>
+        </p:style>
+        <p:txBody>
+          <a:bodyPr rtlCol="0" anchor="ctr"/>
+          <a:lstStyle/>
+          <a:p/>
+        </p:txBody>
+      </p:sp>
+      <p:sp>
+        <p:nvSpPr>
+          <p:cNvPr id="50" name="TextBox 49"/>
+          <p:cNvSpPr txBox="1"/>
+          <p:nvPr/>
+        </p:nvSpPr>
+        <p:spPr>
+          <a:xfrm>
+            <a:off x="7680959" y="4187952"/>
+            <a:ext cx="2409444" cy="292607"/>
+          </a:xfrm>
+          <a:prstGeom prst="rect">
+            <a:avLst/>
+          </a:prstGeom>
+          <a:noFill/>
+        </p:spPr>
+        <p:txBody>
+          <a:bodyPr wrap="square" lIns="0" rIns="0" tIns="0" bIns="0" anchor="ctr">
+            <a:spAutoFit/>
+          </a:bodyPr>
+          <a:lstStyle/>
+          <a:p>
+            <a:pPr algn="ctr"/>
+            <a:r>
+              <a:rPr sz="1100" b="1">
+                <a:solidFill>
+                  <a:srgbClr val="FFFFFF"/>
+                </a:solidFill>
+                <a:latin typeface="微软雅黑"/>
+                <a:ea typeface="微软雅黑"/>
+                <a:cs typeface="微软雅黑"/>
+              </a:rPr>
+              <a:t>智能第二程接直付 · 口径修正</a:t>
+            </a:r>
+          </a:p>
+        </p:txBody>
+      </p:sp>
+      <p:sp>
+        <p:nvSpPr>
+          <p:cNvPr id="51" name="Rounded Rectangle 50"/>
+          <p:cNvSpPr/>
+          <p:nvPr/>
+        </p:nvSpPr>
+        <p:spPr>
+          <a:xfrm>
+            <a:off x="7909559" y="4572000"/>
+            <a:ext cx="1897380" cy="292607"/>
+          </a:xfrm>
+          <a:prstGeom prst="roundRect">
+            <a:avLst>
+              <a:gd name="adj" fmla="val 30000"/>
+            </a:avLst>
+          </a:prstGeom>
+          <a:solidFill>
+            <a:srgbClr val="15315E"/>
+          </a:solidFill>
+          <a:ln>
+            <a:noFill/>
+          </a:ln>
+          <a:effectLst/>
+        </p:spPr>
+        <p:style>
+          <a:lnRef idx="1">
+            <a:schemeClr val="accent1"/>
+          </a:lnRef>
+          <a:fillRef idx="3">
+            <a:schemeClr val="accent1"/>
+          </a:fillRef>
+          <a:effectRef idx="2">
+            <a:schemeClr val="accent1"/>
+          </a:effectRef>
+          <a:fontRef idx="minor">
+            <a:schemeClr val="lt1"/>
+          </a:fontRef>
+        </p:style>
+        <p:txBody>
+          <a:bodyPr rtlCol="0" anchor="ctr"/>
+          <a:lstStyle/>
+          <a:p/>
+        </p:txBody>
+      </p:sp>
+      <p:sp>
+        <p:nvSpPr>
+          <p:cNvPr id="52" name="TextBox 51"/>
+          <p:cNvSpPr txBox="1"/>
+          <p:nvPr/>
+        </p:nvSpPr>
+        <p:spPr>
+          <a:xfrm>
+            <a:off x="7909559" y="4572000"/>
+            <a:ext cx="1897380" cy="292607"/>
           </a:xfrm>
           <a:prstGeom prst="rect">
             <a:avLst/>
@@ -19949,14 +19886,14 @@
       </p:sp>
       <p:sp>
         <p:nvSpPr>
-          <p:cNvPr id="55" name="Rounded Rectangle 54"/>
+          <p:cNvPr id="53" name="Rounded Rectangle 52"/>
           <p:cNvSpPr/>
           <p:nvPr/>
         </p:nvSpPr>
         <p:spPr>
           <a:xfrm>
-            <a:off x="9254384" y="4480560"/>
-            <a:ext cx="682768" cy="237744"/>
+            <a:off x="8412480" y="4956048"/>
+            <a:ext cx="2055875" cy="292607"/>
           </a:xfrm>
           <a:prstGeom prst="roundRect">
             <a:avLst>
@@ -19993,14 +19930,14 @@
       </p:sp>
       <p:sp>
         <p:nvSpPr>
-          <p:cNvPr id="56" name="TextBox 55"/>
+          <p:cNvPr id="54" name="TextBox 53"/>
           <p:cNvSpPr txBox="1"/>
           <p:nvPr/>
         </p:nvSpPr>
         <p:spPr>
           <a:xfrm>
-            <a:off x="9992017" y="4480560"/>
-            <a:ext cx="1581912" cy="237744"/>
+            <a:off x="8412480" y="4956048"/>
+            <a:ext cx="2055875" cy="292607"/>
           </a:xfrm>
           <a:prstGeom prst="rect">
             <a:avLst/>
@@ -20013,31 +19950,31 @@
           </a:bodyPr>
           <a:lstStyle/>
           <a:p>
-            <a:pPr algn="l"/>
+            <a:pPr algn="ctr"/>
             <a:r>
               <a:rPr sz="1100" b="1">
                 <a:solidFill>
-                  <a:srgbClr val="15315E"/>
+                  <a:srgbClr val="FFFFFF"/>
                 </a:solidFill>
                 <a:latin typeface="微软雅黑"/>
                 <a:ea typeface="微软雅黑"/>
                 <a:cs typeface="微软雅黑"/>
               </a:rPr>
-              <a:t>默认截止时间优化</a:t>
+              <a:t>默认截止时间设置优化</a:t>
             </a:r>
           </a:p>
         </p:txBody>
       </p:sp>
       <p:sp>
         <p:nvSpPr>
-          <p:cNvPr id="57" name="Rounded Rectangle 56"/>
+          <p:cNvPr id="55" name="Rounded Rectangle 54"/>
           <p:cNvSpPr/>
           <p:nvPr/>
         </p:nvSpPr>
         <p:spPr>
           <a:xfrm>
-            <a:off x="9535524" y="4791456"/>
-            <a:ext cx="1727003" cy="237744"/>
+            <a:off x="9523476" y="5340096"/>
+            <a:ext cx="1490619" cy="292607"/>
           </a:xfrm>
           <a:prstGeom prst="roundRect">
             <a:avLst>
@@ -20074,14 +20011,14 @@
       </p:sp>
       <p:sp>
         <p:nvSpPr>
-          <p:cNvPr id="58" name="TextBox 57"/>
+          <p:cNvPr id="56" name="TextBox 55"/>
           <p:cNvSpPr txBox="1"/>
           <p:nvPr/>
         </p:nvSpPr>
         <p:spPr>
           <a:xfrm>
-            <a:off x="9535524" y="4791456"/>
-            <a:ext cx="1727003" cy="237744"/>
+            <a:off x="9523476" y="5340096"/>
+            <a:ext cx="1490619" cy="292607"/>
           </a:xfrm>
           <a:prstGeom prst="rect">
             <a:avLst/>
@@ -20111,14 +20048,14 @@
       </p:sp>
       <p:sp>
         <p:nvSpPr>
-          <p:cNvPr id="59" name="Rounded Rectangle 58"/>
+          <p:cNvPr id="57" name="Rounded Rectangle 56"/>
           <p:cNvSpPr/>
           <p:nvPr/>
         </p:nvSpPr>
         <p:spPr>
           <a:xfrm>
-            <a:off x="9896990" y="5102352"/>
-            <a:ext cx="1365537" cy="237744"/>
+            <a:off x="9712452" y="5724144"/>
+            <a:ext cx="1362456" cy="292607"/>
           </a:xfrm>
           <a:prstGeom prst="roundRect">
             <a:avLst>
@@ -20155,14 +20092,14 @@
       </p:sp>
       <p:sp>
         <p:nvSpPr>
-          <p:cNvPr id="60" name="TextBox 59"/>
+          <p:cNvPr id="58" name="TextBox 57"/>
           <p:cNvSpPr txBox="1"/>
           <p:nvPr/>
         </p:nvSpPr>
         <p:spPr>
           <a:xfrm>
-            <a:off x="9896990" y="5102352"/>
-            <a:ext cx="1365537" cy="237744"/>
+            <a:off x="9712452" y="5724144"/>
+            <a:ext cx="1362456" cy="292607"/>
           </a:xfrm>
           <a:prstGeom prst="rect">
             <a:avLst/>
@@ -20186,249 +20123,6 @@
                 <a:cs typeface="微软雅黑"/>
               </a:rPr>
               <a:t>在线换座体验优化</a:t>
-            </a:r>
-          </a:p>
-        </p:txBody>
-      </p:sp>
-      <p:sp>
-        <p:nvSpPr>
-          <p:cNvPr id="61" name="Rounded Rectangle 60"/>
-          <p:cNvSpPr/>
-          <p:nvPr/>
-        </p:nvSpPr>
-        <p:spPr>
-          <a:xfrm>
-            <a:off x="3200400" y="5522976"/>
-            <a:ext cx="1097280" cy="566928"/>
-          </a:xfrm>
-          <a:prstGeom prst="roundRect">
-            <a:avLst>
-              <a:gd name="adj" fmla="val 12000"/>
-            </a:avLst>
-          </a:prstGeom>
-          <a:solidFill>
-            <a:srgbClr val="4F8DF5"/>
-          </a:solidFill>
-          <a:ln>
-            <a:noFill/>
-          </a:ln>
-          <a:effectLst/>
-        </p:spPr>
-        <p:style>
-          <a:lnRef idx="1">
-            <a:schemeClr val="accent1"/>
-          </a:lnRef>
-          <a:fillRef idx="3">
-            <a:schemeClr val="accent1"/>
-          </a:fillRef>
-          <a:effectRef idx="2">
-            <a:schemeClr val="accent1"/>
-          </a:effectRef>
-          <a:fontRef idx="minor">
-            <a:schemeClr val="lt1"/>
-          </a:fontRef>
-        </p:style>
-        <p:txBody>
-          <a:bodyPr rtlCol="0" anchor="ctr"/>
-          <a:lstStyle/>
-          <a:p/>
-        </p:txBody>
-      </p:sp>
-      <p:sp>
-        <p:nvSpPr>
-          <p:cNvPr id="62" name="TextBox 61"/>
-          <p:cNvSpPr txBox="1"/>
-          <p:nvPr/>
-        </p:nvSpPr>
-        <p:spPr>
-          <a:xfrm>
-            <a:off x="3200400" y="5522976"/>
-            <a:ext cx="1097280" cy="566928"/>
-          </a:xfrm>
-          <a:prstGeom prst="rect">
-            <a:avLst/>
-          </a:prstGeom>
-          <a:noFill/>
-        </p:spPr>
-        <p:txBody>
-          <a:bodyPr wrap="square" lIns="0" rIns="0" tIns="0" bIns="0" anchor="ctr">
-            <a:spAutoFit/>
-          </a:bodyPr>
-          <a:lstStyle/>
-          <a:p>
-            <a:pPr algn="ctr"/>
-            <a:r>
-              <a:rPr sz="1200" b="1">
-                <a:solidFill>
-                  <a:srgbClr val="FFFFFF"/>
-                </a:solidFill>
-                <a:latin typeface="微软雅黑"/>
-                <a:ea typeface="微软雅黑"/>
-                <a:cs typeface="微软雅黑"/>
-              </a:rPr>
-              <a:t>专题跟进</a:t>
-            </a:r>
-          </a:p>
-        </p:txBody>
-      </p:sp>
-      <p:sp>
-        <p:nvSpPr>
-          <p:cNvPr id="63" name="Rounded Rectangle 62"/>
-          <p:cNvSpPr/>
-          <p:nvPr/>
-        </p:nvSpPr>
-        <p:spPr>
-          <a:xfrm>
-            <a:off x="8410964" y="5522976"/>
-            <a:ext cx="1967980" cy="237744"/>
-          </a:xfrm>
-          <a:prstGeom prst="roundRect">
-            <a:avLst>
-              <a:gd name="adj" fmla="val 30000"/>
-            </a:avLst>
-          </a:prstGeom>
-          <a:solidFill>
-            <a:srgbClr val="4F8DF5"/>
-          </a:solidFill>
-          <a:ln>
-            <a:noFill/>
-          </a:ln>
-          <a:effectLst/>
-        </p:spPr>
-        <p:style>
-          <a:lnRef idx="1">
-            <a:schemeClr val="accent1"/>
-          </a:lnRef>
-          <a:fillRef idx="3">
-            <a:schemeClr val="accent1"/>
-          </a:fillRef>
-          <a:effectRef idx="2">
-            <a:schemeClr val="accent1"/>
-          </a:effectRef>
-          <a:fontRef idx="minor">
-            <a:schemeClr val="lt1"/>
-          </a:fontRef>
-        </p:style>
-        <p:txBody>
-          <a:bodyPr rtlCol="0" anchor="ctr"/>
-          <a:lstStyle/>
-          <a:p/>
-        </p:txBody>
-      </p:sp>
-      <p:sp>
-        <p:nvSpPr>
-          <p:cNvPr id="64" name="TextBox 63"/>
-          <p:cNvSpPr txBox="1"/>
-          <p:nvPr/>
-        </p:nvSpPr>
-        <p:spPr>
-          <a:xfrm>
-            <a:off x="6042668" y="5522976"/>
-            <a:ext cx="2313432" cy="237744"/>
-          </a:xfrm>
-          <a:prstGeom prst="rect">
-            <a:avLst/>
-          </a:prstGeom>
-          <a:noFill/>
-        </p:spPr>
-        <p:txBody>
-          <a:bodyPr wrap="square" lIns="0" rIns="0" tIns="0" bIns="0" anchor="ctr">
-            <a:spAutoFit/>
-          </a:bodyPr>
-          <a:lstStyle/>
-          <a:p>
-            <a:pPr algn="r"/>
-            <a:r>
-              <a:rPr sz="1100" b="1">
-                <a:solidFill>
-                  <a:srgbClr val="4F8DF5"/>
-                </a:solidFill>
-                <a:latin typeface="微软雅黑"/>
-                <a:ea typeface="微软雅黑"/>
-                <a:cs typeface="微软雅黑"/>
-              </a:rPr>
-              <a:t>支付需求数据回收与口径修正</a:t>
-            </a:r>
-          </a:p>
-        </p:txBody>
-      </p:sp>
-      <p:sp>
-        <p:nvSpPr>
-          <p:cNvPr id="65" name="Rounded Rectangle 64"/>
-          <p:cNvSpPr/>
-          <p:nvPr/>
-        </p:nvSpPr>
-        <p:spPr>
-          <a:xfrm>
-            <a:off x="11061714" y="5833872"/>
-            <a:ext cx="441791" cy="237744"/>
-          </a:xfrm>
-          <a:prstGeom prst="roundRect">
-            <a:avLst>
-              <a:gd name="adj" fmla="val 30000"/>
-            </a:avLst>
-          </a:prstGeom>
-          <a:solidFill>
-            <a:srgbClr val="4F8DF5"/>
-          </a:solidFill>
-          <a:ln>
-            <a:noFill/>
-          </a:ln>
-          <a:effectLst/>
-        </p:spPr>
-        <p:style>
-          <a:lnRef idx="1">
-            <a:schemeClr val="accent1"/>
-          </a:lnRef>
-          <a:fillRef idx="3">
-            <a:schemeClr val="accent1"/>
-          </a:fillRef>
-          <a:effectRef idx="2">
-            <a:schemeClr val="accent1"/>
-          </a:effectRef>
-          <a:fontRef idx="minor">
-            <a:schemeClr val="lt1"/>
-          </a:fontRef>
-        </p:style>
-        <p:txBody>
-          <a:bodyPr rtlCol="0" anchor="ctr"/>
-          <a:lstStyle/>
-          <a:p/>
-        </p:txBody>
-      </p:sp>
-      <p:sp>
-        <p:nvSpPr>
-          <p:cNvPr id="66" name="TextBox 65"/>
-          <p:cNvSpPr txBox="1"/>
-          <p:nvPr/>
-        </p:nvSpPr>
-        <p:spPr>
-          <a:xfrm>
-            <a:off x="9717546" y="5833872"/>
-            <a:ext cx="1289304" cy="237744"/>
-          </a:xfrm>
-          <a:prstGeom prst="rect">
-            <a:avLst/>
-          </a:prstGeom>
-          <a:noFill/>
-        </p:spPr>
-        <p:txBody>
-          <a:bodyPr wrap="square" lIns="0" rIns="0" tIns="0" bIns="0" anchor="ctr">
-            <a:spAutoFit/>
-          </a:bodyPr>
-          <a:lstStyle/>
-          <a:p>
-            <a:pPr algn="r"/>
-            <a:r>
-              <a:rPr sz="1100" b="1">
-                <a:solidFill>
-                  <a:srgbClr val="4F8DF5"/>
-                </a:solidFill>
-                <a:latin typeface="微软雅黑"/>
-                <a:ea typeface="微软雅黑"/>
-                <a:cs typeface="微软雅黑"/>
-              </a:rPr>
-              <a:t>消息模板整改</a:t>
             </a:r>
           </a:p>
         </p:txBody>

</xml_diff>

<commit_message>
Update train-ticket Agent slide to match revised script
Co-Authored-By: Claude Opus 5.5 <noreply@anthropic.com>
Claude-Session: https://claude.ai/code/session_011iFrL2Hfizgp6kYckDtNGc
</commit_message>
<xml_diff>
--- a/答辩PPT.pptx
+++ b/答辩PPT.pptx
@@ -7905,7 +7905,7 @@
                 <a:ea typeface="微软雅黑"/>
                 <a:cs typeface="微软雅黑"/>
               </a:rPr>
-              <a:t>Agent 能不能答好，前提是先判断对：该不该由火车来答、属于哪一类</a:t>
+              <a:t>Agent 最基础的能力，是正确理解用户的问题：该不该由火车来答、属于哪一类</a:t>
             </a:r>
           </a:p>
         </p:txBody>
@@ -7918,8 +7918,8 @@
         </p:nvSpPr>
         <p:spPr>
           <a:xfrm>
-            <a:off x="457200" y="1508760"/>
-            <a:ext cx="5486400" cy="548640"/>
+            <a:off x="457200" y="1481328"/>
+            <a:ext cx="5486400" cy="502920"/>
           </a:xfrm>
           <a:prstGeom prst="roundRect">
             <a:avLst>
@@ -7962,8 +7962,8 @@
         </p:nvSpPr>
         <p:spPr>
           <a:xfrm>
-            <a:off x="457200" y="1508760"/>
-            <a:ext cx="5486400" cy="548640"/>
+            <a:off x="457200" y="1481328"/>
+            <a:ext cx="5486400" cy="502920"/>
           </a:xfrm>
           <a:prstGeom prst="rect">
             <a:avLst/>
@@ -7986,7 +7986,7 @@
                 <a:ea typeface="微软雅黑"/>
                 <a:cs typeface="微软雅黑"/>
               </a:rPr>
-              <a:t>一期 · 界定什么属于火车</a:t>
+              <a:t>意图识别优化：界定什么属于火车</a:t>
             </a:r>
           </a:p>
         </p:txBody>
@@ -7999,7 +7999,7 @@
         </p:nvSpPr>
         <p:spPr>
           <a:xfrm>
-            <a:off x="548640" y="2331720"/>
+            <a:off x="502920" y="2176272"/>
             <a:ext cx="502920" cy="502920"/>
           </a:xfrm>
           <a:prstGeom prst="ellipse">
@@ -8049,7 +8049,7 @@
         </p:blipFill>
         <p:spPr>
           <a:xfrm>
-            <a:off x="674370" y="2457450"/>
+            <a:off x="628650" y="2302002"/>
             <a:ext cx="251460" cy="251460"/>
           </a:xfrm>
           <a:prstGeom prst="rect">
@@ -8065,8 +8065,8 @@
         </p:nvSpPr>
         <p:spPr>
           <a:xfrm>
-            <a:off x="1234440" y="2286000"/>
-            <a:ext cx="4663440" cy="320040"/>
+            <a:off x="1188720" y="2157984"/>
+            <a:ext cx="4709160" cy="329184"/>
           </a:xfrm>
           <a:prstGeom prst="rect">
             <a:avLst/>
@@ -8081,7 +8081,7 @@
           <a:p>
             <a:pPr algn="l"/>
             <a:r>
-              <a:rPr sz="1400" b="1">
+              <a:rPr sz="1500" b="1">
                 <a:solidFill>
                   <a:srgbClr val="FF7A1A"/>
                 </a:solidFill>
@@ -8089,7 +8089,7 @@
                 <a:ea typeface="微软雅黑"/>
                 <a:cs typeface="微软雅黑"/>
               </a:rPr>
-              <a:t>问题</a:t>
+              <a:t>问题：意图识别存在错误</a:t>
             </a:r>
           </a:p>
         </p:txBody>
@@ -8102,8 +8102,8 @@
         </p:nvSpPr>
         <p:spPr>
           <a:xfrm>
-            <a:off x="1234440" y="2587752"/>
-            <a:ext cx="4663440" cy="731520"/>
+            <a:off x="1188720" y="2523744"/>
+            <a:ext cx="4709160" cy="731520"/>
           </a:xfrm>
           <a:prstGeom prst="rect">
             <a:avLst/>
@@ -8118,17 +8118,57 @@
           <a:p>
             <a:pPr algn="l"/>
             <a:r>
-              <a:rPr sz="1400" b="0">
-                <a:solidFill>
-                  <a:srgbClr val="3D4757"/>
+              <a:rPr sz="900" b="0">
+                <a:solidFill>
+                  <a:srgbClr val="FF7A1A"/>
                 </a:solidFill>
                 <a:latin typeface="微软雅黑"/>
                 <a:ea typeface="微软雅黑"/>
                 <a:cs typeface="微软雅黑"/>
               </a:rPr>
-              <a:t>提示词有漏洞，把不属于这一类的 query 纳了进来</a:t>
+              <a:t>●  </a:t>
+            </a:r>
+            <a:r>
+              <a:rPr sz="1300" b="0">
+                <a:solidFill>
+                  <a:srgbClr val="3D4757"/>
+                </a:solidFill>
+                <a:latin typeface="微软雅黑"/>
+                <a:ea typeface="微软雅黑"/>
+                <a:cs typeface="微软雅黑"/>
+              </a:rPr>
+              <a:t>意图识别是最基础的能力，分错了类就会答非所问</a:t>
             </a:r>
           </a:p>
+          <a:p>
+            <a:pPr algn="l">
+              <a:spcBef>
+                <a:spcPts val="400"/>
+              </a:spcBef>
+            </a:pPr>
+            <a:r>
+              <a:rPr sz="900" b="0">
+                <a:solidFill>
+                  <a:srgbClr val="FF7A1A"/>
+                </a:solidFill>
+                <a:latin typeface="微软雅黑"/>
+                <a:ea typeface="微软雅黑"/>
+                <a:cs typeface="微软雅黑"/>
+              </a:rPr>
+              <a:t>●  </a:t>
+            </a:r>
+            <a:r>
+              <a:rPr sz="1300" b="0">
+                <a:solidFill>
+                  <a:srgbClr val="3D4757"/>
+                </a:solidFill>
+                <a:latin typeface="微软雅黑"/>
+                <a:ea typeface="微软雅黑"/>
+                <a:cs typeface="微软雅黑"/>
+              </a:rPr>
+              <a:t>提示词存在不足，把不属于该类的 query 纳了进来</a:t>
+            </a:r>
+          </a:p>
         </p:txBody>
       </p:sp>
       <p:sp>
@@ -8139,7 +8179,7 @@
         </p:nvSpPr>
         <p:spPr>
           <a:xfrm>
-            <a:off x="548640" y="3429000"/>
+            <a:off x="502920" y="3364991"/>
             <a:ext cx="502920" cy="502920"/>
           </a:xfrm>
           <a:prstGeom prst="ellipse">
@@ -8189,7 +8229,7 @@
         </p:blipFill>
         <p:spPr>
           <a:xfrm>
-            <a:off x="674370" y="3554730"/>
+            <a:off x="628650" y="3490722"/>
             <a:ext cx="251460" cy="251460"/>
           </a:xfrm>
           <a:prstGeom prst="rect">
@@ -8205,8 +8245,8 @@
         </p:nvSpPr>
         <p:spPr>
           <a:xfrm>
-            <a:off x="1234440" y="3383280"/>
-            <a:ext cx="4663440" cy="320040"/>
+            <a:off x="1188720" y="3346703"/>
+            <a:ext cx="4709160" cy="329184"/>
           </a:xfrm>
           <a:prstGeom prst="rect">
             <a:avLst/>
@@ -8221,7 +8261,7 @@
           <a:p>
             <a:pPr algn="l"/>
             <a:r>
-              <a:rPr sz="1400" b="1">
+              <a:rPr sz="1500" b="1">
                 <a:solidFill>
                   <a:srgbClr val="287DFA"/>
                 </a:solidFill>
@@ -8229,7 +8269,7 @@
                 <a:ea typeface="微软雅黑"/>
                 <a:cs typeface="微软雅黑"/>
               </a:rPr>
-              <a:t>方案</a:t>
+              <a:t>方案：以算法业务标签为参照，修订分类框架</a:t>
             </a:r>
           </a:p>
         </p:txBody>
@@ -8242,8 +8282,8 @@
         </p:nvSpPr>
         <p:spPr>
           <a:xfrm>
-            <a:off x="1234440" y="3685032"/>
-            <a:ext cx="4663440" cy="731520"/>
+            <a:off x="1188720" y="3712463"/>
+            <a:ext cx="4709160" cy="731520"/>
           </a:xfrm>
           <a:prstGeom prst="rect">
             <a:avLst/>
@@ -8258,17 +8298,57 @@
           <a:p>
             <a:pPr algn="l"/>
             <a:r>
-              <a:rPr sz="1400" b="0">
-                <a:solidFill>
-                  <a:srgbClr val="3D4757"/>
+              <a:rPr sz="900" b="0">
+                <a:solidFill>
+                  <a:srgbClr val="287DFA"/>
                 </a:solidFill>
                 <a:latin typeface="微软雅黑"/>
                 <a:ea typeface="微软雅黑"/>
                 <a:cs typeface="微软雅黑"/>
               </a:rPr>
-              <a:t>与算法业务标签逐条比对，盯“算法对、Agent 错”的样本，逐类修改关键词和分类标准</a:t>
+              <a:t>●  </a:t>
+            </a:r>
+            <a:r>
+              <a:rPr sz="1300" b="0">
+                <a:solidFill>
+                  <a:srgbClr val="3D4757"/>
+                </a:solidFill>
+                <a:latin typeface="微软雅黑"/>
+                <a:ea typeface="微软雅黑"/>
+                <a:cs typeface="微软雅黑"/>
+              </a:rPr>
+              <a:t>抽样 1,000 条线上 query，与算法业务标签逐条比对</a:t>
             </a:r>
           </a:p>
+          <a:p>
+            <a:pPr algn="l">
+              <a:spcBef>
+                <a:spcPts val="400"/>
+              </a:spcBef>
+            </a:pPr>
+            <a:r>
+              <a:rPr sz="900" b="0">
+                <a:solidFill>
+                  <a:srgbClr val="287DFA"/>
+                </a:solidFill>
+                <a:latin typeface="微软雅黑"/>
+                <a:ea typeface="微软雅黑"/>
+                <a:cs typeface="微软雅黑"/>
+              </a:rPr>
+              <a:t>●  </a:t>
+            </a:r>
+            <a:r>
+              <a:rPr sz="1300" b="0">
+                <a:solidFill>
+                  <a:srgbClr val="3D4757"/>
+                </a:solidFill>
+                <a:latin typeface="微软雅黑"/>
+                <a:ea typeface="微软雅黑"/>
+                <a:cs typeface="微软雅黑"/>
+              </a:rPr>
+              <a:t>针对“算法正确、Agent 错误”的样本，逐类修订分类标准</a:t>
+            </a:r>
+          </a:p>
         </p:txBody>
       </p:sp>
       <p:sp>
@@ -8279,8 +8359,8 @@
         </p:nvSpPr>
         <p:spPr>
           <a:xfrm>
-            <a:off x="457200" y="4526280"/>
-            <a:ext cx="5486400" cy="1554480"/>
+            <a:off x="457200" y="4572000"/>
+            <a:ext cx="5486400" cy="1508760"/>
           </a:xfrm>
           <a:prstGeom prst="roundRect">
             <a:avLst>
@@ -8323,8 +8403,8 @@
         </p:nvSpPr>
         <p:spPr>
           <a:xfrm>
-            <a:off x="731520" y="4617720"/>
-            <a:ext cx="1828800" cy="320040"/>
+            <a:off x="731520" y="4663440"/>
+            <a:ext cx="1828800" cy="274320"/>
           </a:xfrm>
           <a:prstGeom prst="rect">
             <a:avLst/>
@@ -8360,8 +8440,8 @@
         </p:nvSpPr>
         <p:spPr>
           <a:xfrm>
-            <a:off x="731520" y="4919472"/>
-            <a:ext cx="2926079" cy="594360"/>
+            <a:off x="731520" y="4983480"/>
+            <a:ext cx="2194560" cy="457200"/>
           </a:xfrm>
           <a:prstGeom prst="rect">
             <a:avLst/>
@@ -8369,14 +8449,51 @@
           <a:noFill/>
         </p:spPr>
         <p:txBody>
-          <a:bodyPr wrap="square" lIns="0" rIns="0" tIns="0" bIns="0" anchor="t">
+          <a:bodyPr wrap="square" lIns="0" rIns="0" tIns="0" bIns="0" anchor="ctr">
             <a:spAutoFit/>
           </a:bodyPr>
           <a:lstStyle/>
           <a:p>
             <a:pPr algn="l"/>
             <a:r>
-              <a:rPr sz="2800" b="1">
+              <a:rPr sz="1200" b="1">
+                <a:solidFill>
+                  <a:srgbClr val="3D4757"/>
+                </a:solidFill>
+                <a:latin typeface="微软雅黑"/>
+                <a:ea typeface="微软雅黑"/>
+                <a:cs typeface="微软雅黑"/>
+              </a:rPr>
+              <a:t>意图识别准确率</a:t>
+            </a:r>
+          </a:p>
+        </p:txBody>
+      </p:sp>
+      <p:sp>
+        <p:nvSpPr>
+          <p:cNvPr id="17" name="TextBox 16"/>
+          <p:cNvSpPr txBox="1"/>
+          <p:nvPr/>
+        </p:nvSpPr>
+        <p:spPr>
+          <a:xfrm>
+            <a:off x="2926080" y="4983480"/>
+            <a:ext cx="1965960" cy="457200"/>
+          </a:xfrm>
+          <a:prstGeom prst="rect">
+            <a:avLst/>
+          </a:prstGeom>
+          <a:noFill/>
+        </p:spPr>
+        <p:txBody>
+          <a:bodyPr wrap="square" lIns="0" rIns="0" tIns="0" bIns="0" anchor="ctr">
+            <a:spAutoFit/>
+          </a:bodyPr>
+          <a:lstStyle/>
+          <a:p>
+            <a:pPr algn="l"/>
+            <a:r>
+              <a:rPr sz="1800" b="1">
                 <a:solidFill>
                   <a:srgbClr val="287DFA"/>
                 </a:solidFill>
@@ -8391,14 +8508,60 @@
       </p:sp>
       <p:sp>
         <p:nvSpPr>
-          <p:cNvPr id="17" name="TextBox 16"/>
+          <p:cNvPr id="18" name="Rounded Rectangle 17"/>
+          <p:cNvSpPr/>
+          <p:nvPr/>
+        </p:nvSpPr>
+        <p:spPr>
+          <a:xfrm>
+            <a:off x="4864608" y="5056632"/>
+            <a:ext cx="1005840" cy="310896"/>
+          </a:xfrm>
+          <a:prstGeom prst="roundRect">
+            <a:avLst>
+              <a:gd name="adj" fmla="val 50000"/>
+            </a:avLst>
+          </a:prstGeom>
+          <a:solidFill>
+            <a:srgbClr val="FFFFFF"/>
+          </a:solidFill>
+          <a:ln w="12700">
+            <a:solidFill>
+              <a:srgbClr val="287DFA"/>
+            </a:solidFill>
+          </a:ln>
+          <a:effectLst/>
+        </p:spPr>
+        <p:style>
+          <a:lnRef idx="1">
+            <a:schemeClr val="accent1"/>
+          </a:lnRef>
+          <a:fillRef idx="3">
+            <a:schemeClr val="accent1"/>
+          </a:fillRef>
+          <a:effectRef idx="2">
+            <a:schemeClr val="accent1"/>
+          </a:effectRef>
+          <a:fontRef idx="minor">
+            <a:schemeClr val="lt1"/>
+          </a:fontRef>
+        </p:style>
+        <p:txBody>
+          <a:bodyPr rtlCol="0" anchor="ctr"/>
+          <a:lstStyle/>
+          <a:p/>
+        </p:txBody>
+      </p:sp>
+      <p:sp>
+        <p:nvSpPr>
+          <p:cNvPr id="19" name="TextBox 18"/>
           <p:cNvSpPr txBox="1"/>
           <p:nvPr/>
         </p:nvSpPr>
         <p:spPr>
           <a:xfrm>
-            <a:off x="731520" y="5532120"/>
-            <a:ext cx="2926079" cy="365760"/>
+            <a:off x="4864608" y="5056632"/>
+            <a:ext cx="1005840" cy="310896"/>
           </a:xfrm>
           <a:prstGeom prst="rect">
             <a:avLst/>
@@ -8406,36 +8569,36 @@
           <a:noFill/>
         </p:spPr>
         <p:txBody>
-          <a:bodyPr wrap="square" lIns="0" rIns="0" tIns="0" bIns="0" anchor="t">
+          <a:bodyPr wrap="square" lIns="0" rIns="0" tIns="0" bIns="0" anchor="ctr">
             <a:spAutoFit/>
           </a:bodyPr>
           <a:lstStyle/>
           <a:p>
-            <a:pPr algn="l"/>
+            <a:pPr algn="ctr"/>
             <a:r>
-              <a:rPr sz="1300" b="0">
-                <a:solidFill>
-                  <a:srgbClr val="3D4757"/>
+              <a:rPr sz="1000" b="1">
+                <a:solidFill>
+                  <a:srgbClr val="287DFA"/>
                 </a:solidFill>
                 <a:latin typeface="微软雅黑"/>
                 <a:ea typeface="微软雅黑"/>
                 <a:cs typeface="微软雅黑"/>
               </a:rPr>
-              <a:t>意图分类准确率</a:t>
+              <a:t>lift +3.59%</a:t>
             </a:r>
           </a:p>
         </p:txBody>
       </p:sp>
       <p:sp>
         <p:nvSpPr>
-          <p:cNvPr id="18" name="TextBox 17"/>
+          <p:cNvPr id="20" name="TextBox 19"/>
           <p:cNvSpPr txBox="1"/>
           <p:nvPr/>
         </p:nvSpPr>
         <p:spPr>
           <a:xfrm>
-            <a:off x="3749039" y="4919472"/>
-            <a:ext cx="1828800" cy="594360"/>
+            <a:off x="731520" y="5513832"/>
+            <a:ext cx="2194560" cy="457200"/>
           </a:xfrm>
           <a:prstGeom prst="rect">
             <a:avLst/>
@@ -8443,51 +8606,14 @@
           <a:noFill/>
         </p:spPr>
         <p:txBody>
-          <a:bodyPr wrap="square" lIns="0" rIns="0" tIns="0" bIns="0" anchor="t">
+          <a:bodyPr wrap="square" lIns="0" rIns="0" tIns="0" bIns="0" anchor="ctr">
             <a:spAutoFit/>
           </a:bodyPr>
           <a:lstStyle/>
           <a:p>
             <a:pPr algn="l"/>
             <a:r>
-              <a:rPr sz="2800" b="1">
-                <a:solidFill>
-                  <a:srgbClr val="287DFA"/>
-                </a:solidFill>
-                <a:latin typeface="微软雅黑"/>
-                <a:ea typeface="微软雅黑"/>
-                <a:cs typeface="微软雅黑"/>
-              </a:rPr>
-              <a:t>+7.7%</a:t>
-            </a:r>
-          </a:p>
-        </p:txBody>
-      </p:sp>
-      <p:sp>
-        <p:nvSpPr>
-          <p:cNvPr id="19" name="TextBox 18"/>
-          <p:cNvSpPr txBox="1"/>
-          <p:nvPr/>
-        </p:nvSpPr>
-        <p:spPr>
-          <a:xfrm>
-            <a:off x="3749039" y="5532120"/>
-            <a:ext cx="1828800" cy="365760"/>
-          </a:xfrm>
-          <a:prstGeom prst="rect">
-            <a:avLst/>
-          </a:prstGeom>
-          <a:noFill/>
-        </p:spPr>
-        <p:txBody>
-          <a:bodyPr wrap="square" lIns="0" rIns="0" tIns="0" bIns="0" anchor="t">
-            <a:spAutoFit/>
-          </a:bodyPr>
-          <a:lstStyle/>
-          <a:p>
-            <a:pPr algn="l"/>
-            <a:r>
-              <a:rPr sz="1300" b="0">
+              <a:rPr sz="1200" b="1">
                 <a:solidFill>
                   <a:srgbClr val="3D4757"/>
                 </a:solidFill>
@@ -8502,14 +8628,134 @@
       </p:sp>
       <p:sp>
         <p:nvSpPr>
-          <p:cNvPr id="20" name="Rounded Rectangle 19"/>
+          <p:cNvPr id="21" name="TextBox 20"/>
+          <p:cNvSpPr txBox="1"/>
+          <p:nvPr/>
+        </p:nvSpPr>
+        <p:spPr>
+          <a:xfrm>
+            <a:off x="2926080" y="5513832"/>
+            <a:ext cx="1965960" cy="457200"/>
+          </a:xfrm>
+          <a:prstGeom prst="rect">
+            <a:avLst/>
+          </a:prstGeom>
+          <a:noFill/>
+        </p:spPr>
+        <p:txBody>
+          <a:bodyPr wrap="square" lIns="0" rIns="0" tIns="0" bIns="0" anchor="ctr">
+            <a:spAutoFit/>
+          </a:bodyPr>
+          <a:lstStyle/>
+          <a:p>
+            <a:pPr algn="l"/>
+            <a:r>
+              <a:rPr sz="1800" b="1">
+                <a:solidFill>
+                  <a:srgbClr val="287DFA"/>
+                </a:solidFill>
+                <a:latin typeface="微软雅黑"/>
+                <a:ea typeface="微软雅黑"/>
+                <a:cs typeface="微软雅黑"/>
+              </a:rPr>
+              <a:t>57% → 60.7%</a:t>
+            </a:r>
+          </a:p>
+        </p:txBody>
+      </p:sp>
+      <p:sp>
+        <p:nvSpPr>
+          <p:cNvPr id="22" name="Rounded Rectangle 21"/>
           <p:cNvSpPr/>
           <p:nvPr/>
         </p:nvSpPr>
         <p:spPr>
           <a:xfrm>
-            <a:off x="6245352" y="1508760"/>
-            <a:ext cx="5486400" cy="548640"/>
+            <a:off x="4864608" y="5586984"/>
+            <a:ext cx="1005840" cy="310896"/>
+          </a:xfrm>
+          <a:prstGeom prst="roundRect">
+            <a:avLst>
+              <a:gd name="adj" fmla="val 50000"/>
+            </a:avLst>
+          </a:prstGeom>
+          <a:solidFill>
+            <a:srgbClr val="FFFFFF"/>
+          </a:solidFill>
+          <a:ln w="12700">
+            <a:solidFill>
+              <a:srgbClr val="287DFA"/>
+            </a:solidFill>
+          </a:ln>
+          <a:effectLst/>
+        </p:spPr>
+        <p:style>
+          <a:lnRef idx="1">
+            <a:schemeClr val="accent1"/>
+          </a:lnRef>
+          <a:fillRef idx="3">
+            <a:schemeClr val="accent1"/>
+          </a:fillRef>
+          <a:effectRef idx="2">
+            <a:schemeClr val="accent1"/>
+          </a:effectRef>
+          <a:fontRef idx="minor">
+            <a:schemeClr val="lt1"/>
+          </a:fontRef>
+        </p:style>
+        <p:txBody>
+          <a:bodyPr rtlCol="0" anchor="ctr"/>
+          <a:lstStyle/>
+          <a:p/>
+        </p:txBody>
+      </p:sp>
+      <p:sp>
+        <p:nvSpPr>
+          <p:cNvPr id="23" name="TextBox 22"/>
+          <p:cNvSpPr txBox="1"/>
+          <p:nvPr/>
+        </p:nvSpPr>
+        <p:spPr>
+          <a:xfrm>
+            <a:off x="4864608" y="5586984"/>
+            <a:ext cx="1005840" cy="310896"/>
+          </a:xfrm>
+          <a:prstGeom prst="rect">
+            <a:avLst/>
+          </a:prstGeom>
+          <a:noFill/>
+        </p:spPr>
+        <p:txBody>
+          <a:bodyPr wrap="square" lIns="0" rIns="0" tIns="0" bIns="0" anchor="ctr">
+            <a:spAutoFit/>
+          </a:bodyPr>
+          <a:lstStyle/>
+          <a:p>
+            <a:pPr algn="ctr"/>
+            <a:r>
+              <a:rPr sz="1000" b="1">
+                <a:solidFill>
+                  <a:srgbClr val="287DFA"/>
+                </a:solidFill>
+                <a:latin typeface="微软雅黑"/>
+                <a:ea typeface="微软雅黑"/>
+                <a:cs typeface="微软雅黑"/>
+              </a:rPr>
+              <a:t>lift +7.7%</a:t>
+            </a:r>
+          </a:p>
+        </p:txBody>
+      </p:sp>
+      <p:sp>
+        <p:nvSpPr>
+          <p:cNvPr id="24" name="Rounded Rectangle 23"/>
+          <p:cNvSpPr/>
+          <p:nvPr/>
+        </p:nvSpPr>
+        <p:spPr>
+          <a:xfrm>
+            <a:off x="6245352" y="1481328"/>
+            <a:ext cx="5486400" cy="502920"/>
           </a:xfrm>
           <a:prstGeom prst="roundRect">
             <a:avLst>
@@ -8546,14 +8792,14 @@
       </p:sp>
       <p:sp>
         <p:nvSpPr>
-          <p:cNvPr id="21" name="TextBox 20"/>
+          <p:cNvPr id="25" name="TextBox 24"/>
           <p:cNvSpPr txBox="1"/>
           <p:nvPr/>
         </p:nvSpPr>
         <p:spPr>
           <a:xfrm>
-            <a:off x="6245352" y="1508760"/>
-            <a:ext cx="5486400" cy="548640"/>
+            <a:off x="6245352" y="1481328"/>
+            <a:ext cx="5486400" cy="502920"/>
           </a:xfrm>
           <a:prstGeom prst="rect">
             <a:avLst/>
@@ -8576,20 +8822,20 @@
                 <a:ea typeface="微软雅黑"/>
                 <a:cs typeface="微软雅黑"/>
               </a:rPr>
-              <a:t>二期 · 界定什么不属于火车</a:t>
+              <a:t>拒答治理：界定什么不属于火车</a:t>
             </a:r>
           </a:p>
         </p:txBody>
       </p:sp>
       <p:sp>
         <p:nvSpPr>
-          <p:cNvPr id="22" name="icon-circle"/>
+          <p:cNvPr id="26" name="icon-circle"/>
           <p:cNvSpPr/>
           <p:nvPr/>
         </p:nvSpPr>
         <p:spPr>
           <a:xfrm>
-            <a:off x="6336792" y="2331720"/>
+            <a:off x="6291072" y="2176272"/>
             <a:ext cx="502920" cy="502920"/>
           </a:xfrm>
           <a:prstGeom prst="ellipse">
@@ -8625,7 +8871,7 @@
       </p:sp>
       <p:pic>
         <p:nvPicPr>
-          <p:cNvPr id="23" name="Picture 22" descr="FaTriangleExclamation_w.png"/>
+          <p:cNvPr id="27" name="Picture 26" descr="FaTriangleExclamation_w.png"/>
           <p:cNvPicPr>
             <a:picLocks noChangeAspect="1"/>
           </p:cNvPicPr>
@@ -8639,7 +8885,7 @@
         </p:blipFill>
         <p:spPr>
           <a:xfrm>
-            <a:off x="6462522" y="2457450"/>
+            <a:off x="6416802" y="2302002"/>
             <a:ext cx="251460" cy="251460"/>
           </a:xfrm>
           <a:prstGeom prst="rect">
@@ -8649,14 +8895,14 @@
       </p:pic>
       <p:sp>
         <p:nvSpPr>
-          <p:cNvPr id="24" name="TextBox 23"/>
+          <p:cNvPr id="28" name="TextBox 27"/>
           <p:cNvSpPr txBox="1"/>
           <p:nvPr/>
         </p:nvSpPr>
         <p:spPr>
           <a:xfrm>
-            <a:off x="7022592" y="2286000"/>
-            <a:ext cx="4663440" cy="320040"/>
+            <a:off x="6976872" y="2157984"/>
+            <a:ext cx="4709160" cy="329184"/>
           </a:xfrm>
           <a:prstGeom prst="rect">
             <a:avLst/>
@@ -8671,7 +8917,7 @@
           <a:p>
             <a:pPr algn="l"/>
             <a:r>
-              <a:rPr sz="1400" b="1">
+              <a:rPr sz="1500" b="1">
                 <a:solidFill>
                   <a:srgbClr val="FF7A1A"/>
                 </a:solidFill>
@@ -8679,21 +8925,21 @@
                 <a:ea typeface="微软雅黑"/>
                 <a:cs typeface="微软雅黑"/>
               </a:rPr>
-              <a:t>问题</a:t>
+              <a:t>问题：火车 Agent 拒答率偏高</a:t>
             </a:r>
           </a:p>
         </p:txBody>
       </p:sp>
       <p:sp>
         <p:nvSpPr>
-          <p:cNvPr id="25" name="TextBox 24"/>
+          <p:cNvPr id="29" name="TextBox 28"/>
           <p:cNvSpPr txBox="1"/>
           <p:nvPr/>
         </p:nvSpPr>
         <p:spPr>
           <a:xfrm>
-            <a:off x="7022592" y="2587752"/>
-            <a:ext cx="4663440" cy="731520"/>
+            <a:off x="6976872" y="2523744"/>
+            <a:ext cx="4709160" cy="731520"/>
           </a:xfrm>
           <a:prstGeom prst="rect">
             <a:avLst/>
@@ -8708,28 +8954,68 @@
           <a:p>
             <a:pPr algn="l"/>
             <a:r>
-              <a:rPr sz="1400" b="0">
-                <a:solidFill>
-                  <a:srgbClr val="3D4757"/>
+              <a:rPr sz="900" b="0">
+                <a:solidFill>
+                  <a:srgbClr val="FF7A1A"/>
                 </a:solidFill>
                 <a:latin typeface="微软雅黑"/>
                 <a:ea typeface="微软雅黑"/>
                 <a:cs typeface="微软雅黑"/>
               </a:rPr>
-              <a:t>约一半问题被拒答，其中一部分根本不属于火车，是被错误分发过来的</a:t>
+              <a:t>●  </a:t>
+            </a:r>
+            <a:r>
+              <a:rPr sz="1300" b="0">
+                <a:solidFill>
+                  <a:srgbClr val="3D4757"/>
+                </a:solidFill>
+                <a:latin typeface="微软雅黑"/>
+                <a:ea typeface="微软雅黑"/>
+                <a:cs typeface="微软雅黑"/>
+              </a:rPr>
+              <a:t>约一半问题被拒答，其中部分是被错误分发的非火车问题</a:t>
             </a:r>
           </a:p>
-        </p:txBody>
-      </p:sp>
-      <p:sp>
-        <p:nvSpPr>
-          <p:cNvPr id="26" name="icon-circle"/>
+          <a:p>
+            <a:pPr algn="l">
+              <a:spcBef>
+                <a:spcPts val="400"/>
+              </a:spcBef>
+            </a:pPr>
+            <a:r>
+              <a:rPr sz="900" b="0">
+                <a:solidFill>
+                  <a:srgbClr val="FF7A1A"/>
+                </a:solidFill>
+                <a:latin typeface="微软雅黑"/>
+                <a:ea typeface="微软雅黑"/>
+                <a:cs typeface="微软雅黑"/>
+              </a:rPr>
+              <a:t>●  </a:t>
+            </a:r>
+            <a:r>
+              <a:rPr sz="1300" b="0">
+                <a:solidFill>
+                  <a:srgbClr val="3D4757"/>
+                </a:solidFill>
+                <a:latin typeface="微软雅黑"/>
+                <a:ea typeface="微软雅黑"/>
+                <a:cs typeface="微软雅黑"/>
+              </a:rPr>
+              <a:t>这类问题在火车 Agent 内无法回答，只能从上游分发解决</a:t>
+            </a:r>
+          </a:p>
+        </p:txBody>
+      </p:sp>
+      <p:sp>
+        <p:nvSpPr>
+          <p:cNvPr id="30" name="icon-circle"/>
           <p:cNvSpPr/>
           <p:nvPr/>
         </p:nvSpPr>
         <p:spPr>
           <a:xfrm>
-            <a:off x="6336792" y="3429000"/>
+            <a:off x="6291072" y="3364991"/>
             <a:ext cx="502920" cy="502920"/>
           </a:xfrm>
           <a:prstGeom prst="ellipse">
@@ -8765,7 +9051,7 @@
       </p:sp>
       <p:pic>
         <p:nvPicPr>
-          <p:cNvPr id="27" name="Picture 26" descr="FaFilter_w.png"/>
+          <p:cNvPr id="31" name="Picture 30" descr="FaFilter_w.png"/>
           <p:cNvPicPr>
             <a:picLocks noChangeAspect="1"/>
           </p:cNvPicPr>
@@ -8779,7 +9065,7 @@
         </p:blipFill>
         <p:spPr>
           <a:xfrm>
-            <a:off x="6462522" y="3554730"/>
+            <a:off x="6416802" y="3490722"/>
             <a:ext cx="251460" cy="251460"/>
           </a:xfrm>
           <a:prstGeom prst="rect">
@@ -8789,14 +9075,14 @@
       </p:pic>
       <p:sp>
         <p:nvSpPr>
-          <p:cNvPr id="28" name="TextBox 27"/>
+          <p:cNvPr id="32" name="TextBox 31"/>
           <p:cNvSpPr txBox="1"/>
           <p:nvPr/>
         </p:nvSpPr>
         <p:spPr>
           <a:xfrm>
-            <a:off x="7022592" y="3383280"/>
-            <a:ext cx="4663440" cy="320040"/>
+            <a:off x="6976872" y="3346703"/>
+            <a:ext cx="4709160" cy="329184"/>
           </a:xfrm>
           <a:prstGeom prst="rect">
             <a:avLst/>
@@ -8811,7 +9097,7 @@
           <a:p>
             <a:pPr algn="l"/>
             <a:r>
-              <a:rPr sz="1400" b="1">
+              <a:rPr sz="1500" b="1">
                 <a:solidFill>
                   <a:srgbClr val="287DFA"/>
                 </a:solidFill>
@@ -8819,21 +9105,21 @@
                 <a:ea typeface="微软雅黑"/>
                 <a:cs typeface="微软雅黑"/>
               </a:rPr>
-              <a:t>方案</a:t>
+              <a:t>方案：推进能力覆盖的同时，优先治理错误分发</a:t>
             </a:r>
           </a:p>
         </p:txBody>
       </p:sp>
       <p:sp>
         <p:nvSpPr>
-          <p:cNvPr id="29" name="TextBox 28"/>
+          <p:cNvPr id="33" name="TextBox 32"/>
           <p:cNvSpPr txBox="1"/>
           <p:nvPr/>
         </p:nvSpPr>
         <p:spPr>
           <a:xfrm>
-            <a:off x="7022592" y="3685032"/>
-            <a:ext cx="4663440" cy="731520"/>
+            <a:off x="6976872" y="3712463"/>
+            <a:ext cx="4709160" cy="731520"/>
           </a:xfrm>
           <a:prstGeom prst="rect">
             <a:avLst/>
@@ -8848,29 +9134,69 @@
           <a:p>
             <a:pPr algn="l"/>
             <a:r>
-              <a:rPr sz="1400" b="0">
-                <a:solidFill>
-                  <a:srgbClr val="3D4757"/>
+              <a:rPr sz="900" b="0">
+                <a:solidFill>
+                  <a:srgbClr val="287DFA"/>
                 </a:solidFill>
                 <a:latin typeface="微软雅黑"/>
                 <a:ea typeface="微软雅黑"/>
                 <a:cs typeface="微软雅黑"/>
               </a:rPr>
-              <a:t>持续推进能力覆盖的同时，优先治理错误分发：人工核查 1,000 多条拒答 query，整理火车问题边界，交给问道调整分发策略</a:t>
+              <a:t>●  </a:t>
+            </a:r>
+            <a:r>
+              <a:rPr sz="1300" b="0">
+                <a:solidFill>
+                  <a:srgbClr val="3D4757"/>
+                </a:solidFill>
+                <a:latin typeface="微软雅黑"/>
+                <a:ea typeface="微软雅黑"/>
+                <a:cs typeface="微软雅黑"/>
+              </a:rPr>
+              <a:t>人工核查 1,000 多条拒答 query，整理火车问题的边界</a:t>
             </a:r>
           </a:p>
-        </p:txBody>
-      </p:sp>
-      <p:sp>
-        <p:nvSpPr>
-          <p:cNvPr id="30" name="Rounded Rectangle 29"/>
+          <a:p>
+            <a:pPr algn="l">
+              <a:spcBef>
+                <a:spcPts val="400"/>
+              </a:spcBef>
+            </a:pPr>
+            <a:r>
+              <a:rPr sz="900" b="0">
+                <a:solidFill>
+                  <a:srgbClr val="287DFA"/>
+                </a:solidFill>
+                <a:latin typeface="微软雅黑"/>
+                <a:ea typeface="微软雅黑"/>
+                <a:cs typeface="微软雅黑"/>
+              </a:rPr>
+              <a:t>●  </a:t>
+            </a:r>
+            <a:r>
+              <a:rPr sz="1300" b="0">
+                <a:solidFill>
+                  <a:srgbClr val="3D4757"/>
+                </a:solidFill>
+                <a:latin typeface="微软雅黑"/>
+                <a:ea typeface="微软雅黑"/>
+                <a:cs typeface="微软雅黑"/>
+              </a:rPr>
+              <a:t>推动问道调整分发，非火车问题交由其他 Agent 回答</a:t>
+            </a:r>
+          </a:p>
+        </p:txBody>
+      </p:sp>
+      <p:sp>
+        <p:nvSpPr>
+          <p:cNvPr id="34" name="Rounded Rectangle 33"/>
           <p:cNvSpPr/>
           <p:nvPr/>
         </p:nvSpPr>
         <p:spPr>
           <a:xfrm>
-            <a:off x="6245352" y="4526280"/>
-            <a:ext cx="5486400" cy="1554480"/>
+            <a:off x="6245352" y="4572000"/>
+            <a:ext cx="5486400" cy="1508760"/>
           </a:xfrm>
           <a:prstGeom prst="roundRect">
             <a:avLst>
@@ -8907,14 +9233,14 @@
       </p:sp>
       <p:sp>
         <p:nvSpPr>
-          <p:cNvPr id="31" name="TextBox 30"/>
+          <p:cNvPr id="35" name="TextBox 34"/>
           <p:cNvSpPr txBox="1"/>
           <p:nvPr/>
         </p:nvSpPr>
         <p:spPr>
           <a:xfrm>
-            <a:off x="6519672" y="4617720"/>
-            <a:ext cx="1828800" cy="320040"/>
+            <a:off x="6519672" y="4663440"/>
+            <a:ext cx="1828800" cy="274320"/>
           </a:xfrm>
           <a:prstGeom prst="rect">
             <a:avLst/>
@@ -8944,14 +9270,14 @@
       </p:sp>
       <p:sp>
         <p:nvSpPr>
-          <p:cNvPr id="32" name="TextBox 31"/>
+          <p:cNvPr id="36" name="TextBox 35"/>
           <p:cNvSpPr txBox="1"/>
           <p:nvPr/>
         </p:nvSpPr>
         <p:spPr>
           <a:xfrm>
-            <a:off x="6519672" y="4919472"/>
-            <a:ext cx="4846320" cy="594360"/>
+            <a:off x="6519672" y="5212080"/>
+            <a:ext cx="2194560" cy="457200"/>
           </a:xfrm>
           <a:prstGeom prst="rect">
             <a:avLst/>
@@ -8959,14 +9285,51 @@
           <a:noFill/>
         </p:spPr>
         <p:txBody>
-          <a:bodyPr wrap="square" lIns="0" rIns="0" tIns="0" bIns="0" anchor="t">
+          <a:bodyPr wrap="square" lIns="0" rIns="0" tIns="0" bIns="0" anchor="ctr">
             <a:spAutoFit/>
           </a:bodyPr>
           <a:lstStyle/>
           <a:p>
             <a:pPr algn="l"/>
             <a:r>
-              <a:rPr sz="2800" b="1">
+              <a:rPr sz="1200" b="1">
+                <a:solidFill>
+                  <a:srgbClr val="3D4757"/>
+                </a:solidFill>
+                <a:latin typeface="微软雅黑"/>
+                <a:ea typeface="微软雅黑"/>
+                <a:cs typeface="微软雅黑"/>
+              </a:rPr>
+              <a:t>错误分发导致的拒答占比</a:t>
+            </a:r>
+          </a:p>
+        </p:txBody>
+      </p:sp>
+      <p:sp>
+        <p:nvSpPr>
+          <p:cNvPr id="37" name="TextBox 36"/>
+          <p:cNvSpPr txBox="1"/>
+          <p:nvPr/>
+        </p:nvSpPr>
+        <p:spPr>
+          <a:xfrm>
+            <a:off x="8714232" y="5212080"/>
+            <a:ext cx="1965960" cy="457200"/>
+          </a:xfrm>
+          <a:prstGeom prst="rect">
+            <a:avLst/>
+          </a:prstGeom>
+          <a:noFill/>
+        </p:spPr>
+        <p:txBody>
+          <a:bodyPr wrap="square" lIns="0" rIns="0" tIns="0" bIns="0" anchor="ctr">
+            <a:spAutoFit/>
+          </a:bodyPr>
+          <a:lstStyle/>
+          <a:p>
+            <a:pPr algn="l"/>
+            <a:r>
+              <a:rPr sz="1800" b="1">
                 <a:solidFill>
                   <a:srgbClr val="287DFA"/>
                 </a:solidFill>
@@ -8981,14 +9344,60 @@
       </p:sp>
       <p:sp>
         <p:nvSpPr>
-          <p:cNvPr id="33" name="TextBox 32"/>
+          <p:cNvPr id="38" name="Rounded Rectangle 37"/>
+          <p:cNvSpPr/>
+          <p:nvPr/>
+        </p:nvSpPr>
+        <p:spPr>
+          <a:xfrm>
+            <a:off x="10652760" y="5285232"/>
+            <a:ext cx="1005840" cy="310896"/>
+          </a:xfrm>
+          <a:prstGeom prst="roundRect">
+            <a:avLst>
+              <a:gd name="adj" fmla="val 50000"/>
+            </a:avLst>
+          </a:prstGeom>
+          <a:solidFill>
+            <a:srgbClr val="FFFFFF"/>
+          </a:solidFill>
+          <a:ln w="12700">
+            <a:solidFill>
+              <a:srgbClr val="287DFA"/>
+            </a:solidFill>
+          </a:ln>
+          <a:effectLst/>
+        </p:spPr>
+        <p:style>
+          <a:lnRef idx="1">
+            <a:schemeClr val="accent1"/>
+          </a:lnRef>
+          <a:fillRef idx="3">
+            <a:schemeClr val="accent1"/>
+          </a:fillRef>
+          <a:effectRef idx="2">
+            <a:schemeClr val="accent1"/>
+          </a:effectRef>
+          <a:fontRef idx="minor">
+            <a:schemeClr val="lt1"/>
+          </a:fontRef>
+        </p:style>
+        <p:txBody>
+          <a:bodyPr rtlCol="0" anchor="ctr"/>
+          <a:lstStyle/>
+          <a:p/>
+        </p:txBody>
+      </p:sp>
+      <p:sp>
+        <p:nvSpPr>
+          <p:cNvPr id="39" name="TextBox 38"/>
           <p:cNvSpPr txBox="1"/>
           <p:nvPr/>
         </p:nvSpPr>
         <p:spPr>
           <a:xfrm>
-            <a:off x="6519672" y="5532120"/>
-            <a:ext cx="4846320" cy="365760"/>
+            <a:off x="10652760" y="5285232"/>
+            <a:ext cx="1005840" cy="310896"/>
           </a:xfrm>
           <a:prstGeom prst="rect">
             <a:avLst/>
@@ -8996,22 +9405,22 @@
           <a:noFill/>
         </p:spPr>
         <p:txBody>
-          <a:bodyPr wrap="square" lIns="0" rIns="0" tIns="0" bIns="0" anchor="t">
+          <a:bodyPr wrap="square" lIns="0" rIns="0" tIns="0" bIns="0" anchor="ctr">
             <a:spAutoFit/>
           </a:bodyPr>
           <a:lstStyle/>
           <a:p>
-            <a:pPr algn="l"/>
+            <a:pPr algn="ctr"/>
             <a:r>
-              <a:rPr sz="1300" b="0">
-                <a:solidFill>
-                  <a:srgbClr val="3D4757"/>
+              <a:rPr sz="1000" b="1">
+                <a:solidFill>
+                  <a:srgbClr val="287DFA"/>
                 </a:solidFill>
                 <a:latin typeface="微软雅黑"/>
                 <a:ea typeface="微软雅黑"/>
                 <a:cs typeface="微软雅黑"/>
               </a:rPr>
-              <a:t>错误分发导致的拒答占比</a:t>
+              <a:t>lift −54.2%</a:t>
             </a:r>
           </a:p>
         </p:txBody>

</xml_diff>

<commit_message>
Add real screenshot to smart second-leg slide
Co-Authored-By: Claude Opus 5.5 <noreply@anthropic.com>
Claude-Session: https://claude.ai/code/session_011iFrL2Hfizgp6kYckDtNGc
</commit_message>
<xml_diff>
--- a/答辩PPT.pptx
+++ b/答辩PPT.pptx
@@ -9536,7 +9536,7 @@
                 <a:ea typeface="微软雅黑"/>
                 <a:cs typeface="微软雅黑"/>
               </a:rPr>
-              <a:t>兴奋型需求最怕的不是做不到，而是给了预期又兑现不了</a:t>
+              <a:t>智能第二程——兴奋型需求</a:t>
             </a:r>
           </a:p>
         </p:txBody>
@@ -9550,7 +9550,7 @@
         <p:spPr>
           <a:xfrm>
             <a:off x="457200" y="1554480"/>
-            <a:ext cx="2514600" cy="1508760"/>
+            <a:ext cx="1965960" cy="1463040"/>
           </a:xfrm>
           <a:prstGeom prst="roundRect">
             <a:avLst>
@@ -9595,8 +9595,8 @@
         </p:nvSpPr>
         <p:spPr>
           <a:xfrm>
-            <a:off x="1399032" y="1691640"/>
-            <a:ext cx="640080" cy="640080"/>
+            <a:off x="1129284" y="1700784"/>
+            <a:ext cx="621792" cy="621792"/>
           </a:xfrm>
           <a:prstGeom prst="ellipse">
             <a:avLst/>
@@ -9645,8 +9645,8 @@
         </p:blipFill>
         <p:spPr>
           <a:xfrm>
-            <a:off x="1559052" y="1851660"/>
-            <a:ext cx="320040" cy="320040"/>
+            <a:off x="1284731" y="1856232"/>
+            <a:ext cx="310896" cy="310896"/>
           </a:xfrm>
           <a:prstGeom prst="rect">
             <a:avLst/>
@@ -9661,8 +9661,8 @@
         </p:nvSpPr>
         <p:spPr>
           <a:xfrm>
-            <a:off x="594360" y="2395728"/>
-            <a:ext cx="2240280" cy="594360"/>
+            <a:off x="548640" y="2423160"/>
+            <a:ext cx="1783080" cy="548640"/>
           </a:xfrm>
           <a:prstGeom prst="rect">
             <a:avLst/>
@@ -9677,7 +9677,7 @@
           <a:p>
             <a:pPr algn="ctr"/>
             <a:r>
-              <a:rPr sz="1400" b="1">
+              <a:rPr sz="1300" b="1">
                 <a:solidFill>
                   <a:srgbClr val="3D4757"/>
                 </a:solidFill>
@@ -9695,7 +9695,7 @@
               </a:spcBef>
             </a:pPr>
             <a:r>
-              <a:rPr sz="1400" b="1">
+              <a:rPr sz="1300" b="1">
                 <a:solidFill>
                   <a:srgbClr val="3D4757"/>
                 </a:solidFill>
@@ -9716,8 +9716,8 @@
         </p:nvSpPr>
         <p:spPr>
           <a:xfrm>
-            <a:off x="3035808" y="2148840"/>
-            <a:ext cx="292608" cy="292608"/>
+            <a:off x="2459736" y="2130552"/>
+            <a:ext cx="228600" cy="274320"/>
           </a:xfrm>
           <a:prstGeom prst="rightArrow">
             <a:avLst/>
@@ -9758,8 +9758,8 @@
         </p:nvSpPr>
         <p:spPr>
           <a:xfrm>
-            <a:off x="3383280" y="1554480"/>
-            <a:ext cx="2514600" cy="1508760"/>
+            <a:off x="2724912" y="1554480"/>
+            <a:ext cx="1965960" cy="1463040"/>
           </a:xfrm>
           <a:prstGeom prst="roundRect">
             <a:avLst>
@@ -9804,8 +9804,8 @@
         </p:nvSpPr>
         <p:spPr>
           <a:xfrm>
-            <a:off x="4325112" y="1691640"/>
-            <a:ext cx="640080" cy="640080"/>
+            <a:off x="3396996" y="1700784"/>
+            <a:ext cx="621792" cy="621792"/>
           </a:xfrm>
           <a:prstGeom prst="ellipse">
             <a:avLst/>
@@ -9854,8 +9854,8 @@
         </p:blipFill>
         <p:spPr>
           <a:xfrm>
-            <a:off x="4485132" y="1851660"/>
-            <a:ext cx="320040" cy="320040"/>
+            <a:off x="3552444" y="1856232"/>
+            <a:ext cx="310896" cy="310896"/>
           </a:xfrm>
           <a:prstGeom prst="rect">
             <a:avLst/>
@@ -9870,8 +9870,8 @@
         </p:nvSpPr>
         <p:spPr>
           <a:xfrm>
-            <a:off x="3520440" y="2395728"/>
-            <a:ext cx="2240280" cy="594360"/>
+            <a:off x="2816352" y="2423160"/>
+            <a:ext cx="1783080" cy="548640"/>
           </a:xfrm>
           <a:prstGeom prst="rect">
             <a:avLst/>
@@ -9886,7 +9886,7 @@
           <a:p>
             <a:pPr algn="ctr"/>
             <a:r>
-              <a:rPr sz="1400" b="1">
+              <a:rPr sz="1300" b="1">
                 <a:solidFill>
                   <a:srgbClr val="3D4757"/>
                 </a:solidFill>
@@ -9904,7 +9904,7 @@
               </a:spcBef>
             </a:pPr>
             <a:r>
-              <a:rPr sz="1400" b="1">
+              <a:rPr sz="1300" b="1">
                 <a:solidFill>
                   <a:srgbClr val="3D4757"/>
                 </a:solidFill>
@@ -9925,8 +9925,8 @@
         </p:nvSpPr>
         <p:spPr>
           <a:xfrm>
-            <a:off x="5961888" y="2148840"/>
-            <a:ext cx="292608" cy="292608"/>
+            <a:off x="4727448" y="2130552"/>
+            <a:ext cx="228600" cy="274320"/>
           </a:xfrm>
           <a:prstGeom prst="rightArrow">
             <a:avLst/>
@@ -9967,8 +9967,8 @@
         </p:nvSpPr>
         <p:spPr>
           <a:xfrm>
-            <a:off x="6309360" y="1554480"/>
-            <a:ext cx="2514600" cy="1508760"/>
+            <a:off x="4992624" y="1554480"/>
+            <a:ext cx="1965960" cy="1463040"/>
           </a:xfrm>
           <a:prstGeom prst="roundRect">
             <a:avLst>
@@ -9976,7 +9976,7 @@
             </a:avLst>
           </a:prstGeom>
           <a:solidFill>
-            <a:srgbClr val="FFF3EA"/>
+            <a:srgbClr val="F5F9FF"/>
           </a:solidFill>
           <a:ln w="12700">
             <a:solidFill>
@@ -10013,14 +10013,14 @@
         </p:nvSpPr>
         <p:spPr>
           <a:xfrm>
-            <a:off x="7251192" y="1691640"/>
-            <a:ext cx="640080" cy="640080"/>
+            <a:off x="5664708" y="1700784"/>
+            <a:ext cx="621792" cy="621792"/>
           </a:xfrm>
           <a:prstGeom prst="ellipse">
             <a:avLst/>
           </a:prstGeom>
           <a:solidFill>
-            <a:srgbClr val="FF7A1A"/>
+            <a:srgbClr val="287DFA"/>
           </a:solidFill>
           <a:ln>
             <a:noFill/>
@@ -10063,8 +10063,8 @@
         </p:blipFill>
         <p:spPr>
           <a:xfrm>
-            <a:off x="7411212" y="1851660"/>
-            <a:ext cx="320040" cy="320040"/>
+            <a:off x="5820156" y="1856232"/>
+            <a:ext cx="310896" cy="310896"/>
           </a:xfrm>
           <a:prstGeom prst="rect">
             <a:avLst/>
@@ -10079,8 +10079,8 @@
         </p:nvSpPr>
         <p:spPr>
           <a:xfrm>
-            <a:off x="6446520" y="2395728"/>
-            <a:ext cx="2240280" cy="594360"/>
+            <a:off x="5084064" y="2423160"/>
+            <a:ext cx="1783080" cy="548640"/>
           </a:xfrm>
           <a:prstGeom prst="rect">
             <a:avLst/>
@@ -10095,7 +10095,7 @@
           <a:p>
             <a:pPr algn="ctr"/>
             <a:r>
-              <a:rPr sz="1400" b="1">
+              <a:rPr sz="1300" b="1">
                 <a:solidFill>
                   <a:srgbClr val="3D4757"/>
                 </a:solidFill>
@@ -10116,8 +10116,8 @@
         </p:nvSpPr>
         <p:spPr>
           <a:xfrm>
-            <a:off x="8887968" y="2148840"/>
-            <a:ext cx="292608" cy="292608"/>
+            <a:off x="6995159" y="2130552"/>
+            <a:ext cx="228600" cy="274320"/>
           </a:xfrm>
           <a:prstGeom prst="rightArrow">
             <a:avLst/>
@@ -10158,8 +10158,236 @@
         </p:nvSpPr>
         <p:spPr>
           <a:xfrm>
-            <a:off x="9235440" y="1554480"/>
-            <a:ext cx="2514600" cy="1508760"/>
+            <a:off x="7260336" y="1554480"/>
+            <a:ext cx="1965960" cy="1463040"/>
+          </a:xfrm>
+          <a:prstGeom prst="roundRect">
+            <a:avLst>
+              <a:gd name="adj" fmla="val 6000"/>
+            </a:avLst>
+          </a:prstGeom>
+          <a:solidFill>
+            <a:srgbClr val="F5F9FF"/>
+          </a:solidFill>
+          <a:ln w="12700">
+            <a:solidFill>
+              <a:srgbClr val="FF7A1A"/>
+            </a:solidFill>
+          </a:ln>
+          <a:effectLst/>
+        </p:spPr>
+        <p:style>
+          <a:lnRef idx="1">
+            <a:schemeClr val="accent1"/>
+          </a:lnRef>
+          <a:fillRef idx="3">
+            <a:schemeClr val="accent1"/>
+          </a:fillRef>
+          <a:effectRef idx="2">
+            <a:schemeClr val="accent1"/>
+          </a:effectRef>
+          <a:fontRef idx="minor">
+            <a:schemeClr val="lt1"/>
+          </a:fontRef>
+        </p:style>
+        <p:txBody>
+          <a:bodyPr rtlCol="0" anchor="ctr"/>
+          <a:lstStyle/>
+          <a:p/>
+        </p:txBody>
+      </p:sp>
+      <p:sp>
+        <p:nvSpPr>
+          <p:cNvPr id="20" name="icon-circle"/>
+          <p:cNvSpPr/>
+          <p:nvPr/>
+        </p:nvSpPr>
+        <p:spPr>
+          <a:xfrm>
+            <a:off x="7932419" y="1700784"/>
+            <a:ext cx="621792" cy="621792"/>
+          </a:xfrm>
+          <a:prstGeom prst="ellipse">
+            <a:avLst/>
+          </a:prstGeom>
+          <a:solidFill>
+            <a:srgbClr val="287DFA"/>
+          </a:solidFill>
+          <a:ln>
+            <a:noFill/>
+          </a:ln>
+          <a:effectLst/>
+        </p:spPr>
+        <p:style>
+          <a:lnRef idx="1">
+            <a:schemeClr val="accent1"/>
+          </a:lnRef>
+          <a:fillRef idx="3">
+            <a:schemeClr val="accent1"/>
+          </a:fillRef>
+          <a:effectRef idx="2">
+            <a:schemeClr val="accent1"/>
+          </a:effectRef>
+          <a:fontRef idx="minor">
+            <a:schemeClr val="lt1"/>
+          </a:fontRef>
+        </p:style>
+        <p:txBody>
+          <a:bodyPr rtlCol="0" anchor="ctr"/>
+          <a:lstStyle/>
+          <a:p/>
+        </p:txBody>
+      </p:sp>
+      <p:pic>
+        <p:nvPicPr>
+          <p:cNvPr id="21" name="Picture 20" descr="FaTicket_w.png"/>
+          <p:cNvPicPr>
+            <a:picLocks noChangeAspect="1"/>
+          </p:cNvPicPr>
+          <p:nvPr/>
+        </p:nvPicPr>
+        <p:blipFill>
+          <a:blip r:embed="rId6"/>
+          <a:stretch>
+            <a:fillRect/>
+          </a:stretch>
+        </p:blipFill>
+        <p:spPr>
+          <a:xfrm>
+            <a:off x="8087867" y="1856232"/>
+            <a:ext cx="310896" cy="310896"/>
+          </a:xfrm>
+          <a:prstGeom prst="rect">
+            <a:avLst/>
+          </a:prstGeom>
+        </p:spPr>
+      </p:pic>
+      <p:sp>
+        <p:nvSpPr>
+          <p:cNvPr id="22" name="TextBox 21"/>
+          <p:cNvSpPr txBox="1"/>
+          <p:nvPr/>
+        </p:nvSpPr>
+        <p:spPr>
+          <a:xfrm>
+            <a:off x="7351775" y="2423160"/>
+            <a:ext cx="1783080" cy="548640"/>
+          </a:xfrm>
+          <a:prstGeom prst="rect">
+            <a:avLst/>
+          </a:prstGeom>
+          <a:noFill/>
+        </p:spPr>
+        <p:txBody>
+          <a:bodyPr wrap="square" lIns="0" rIns="0" tIns="0" bIns="0" anchor="t">
+            <a:spAutoFit/>
+          </a:bodyPr>
+          <a:lstStyle/>
+          <a:p>
+            <a:pPr algn="ctr"/>
+            <a:r>
+              <a:rPr sz="1300" b="1">
+                <a:solidFill>
+                  <a:srgbClr val="3D4757"/>
+                </a:solidFill>
+                <a:latin typeface="微软雅黑"/>
+                <a:ea typeface="微软雅黑"/>
+                <a:cs typeface="微软雅黑"/>
+              </a:rPr>
+              <a:t>出票</a:t>
+            </a:r>
+          </a:p>
+        </p:txBody>
+      </p:sp>
+      <p:sp>
+        <p:nvSpPr>
+          <p:cNvPr id="23" name="Rectangle 22"/>
+          <p:cNvSpPr/>
+          <p:nvPr/>
+        </p:nvSpPr>
+        <p:spPr>
+          <a:xfrm>
+            <a:off x="4901184" y="1463040"/>
+            <a:ext cx="4416552" cy="1645920"/>
+          </a:xfrm>
+          <a:prstGeom prst="rect">
+            <a:avLst/>
+          </a:prstGeom>
+          <a:noFill/>
+          <a:ln w="12700">
+            <a:solidFill>
+              <a:srgbClr val="FF7A1A"/>
+            </a:solidFill>
+          </a:ln>
+          <a:effectLst/>
+        </p:spPr>
+        <p:style>
+          <a:lnRef idx="1">
+            <a:schemeClr val="accent1"/>
+          </a:lnRef>
+          <a:fillRef idx="3">
+            <a:schemeClr val="accent1"/>
+          </a:fillRef>
+          <a:effectRef idx="2">
+            <a:schemeClr val="accent1"/>
+          </a:effectRef>
+          <a:fontRef idx="minor">
+            <a:schemeClr val="lt1"/>
+          </a:fontRef>
+        </p:style>
+        <p:txBody>
+          <a:bodyPr rtlCol="0" anchor="ctr"/>
+          <a:lstStyle/>
+          <a:p/>
+        </p:txBody>
+      </p:sp>
+      <p:sp>
+        <p:nvSpPr>
+          <p:cNvPr id="24" name="TextBox 23"/>
+          <p:cNvSpPr txBox="1"/>
+          <p:nvPr/>
+        </p:nvSpPr>
+        <p:spPr>
+          <a:xfrm>
+            <a:off x="4901184" y="3154680"/>
+            <a:ext cx="4416552" cy="274320"/>
+          </a:xfrm>
+          <a:prstGeom prst="rect">
+            <a:avLst/>
+          </a:prstGeom>
+          <a:noFill/>
+        </p:spPr>
+        <p:txBody>
+          <a:bodyPr wrap="square" lIns="0" rIns="0" tIns="0" bIns="0" anchor="t">
+            <a:spAutoFit/>
+          </a:bodyPr>
+          <a:lstStyle/>
+          <a:p>
+            <a:pPr algn="ctr"/>
+            <a:r>
+              <a:rPr sz="1200" b="1">
+                <a:solidFill>
+                  <a:srgbClr val="FF7A1A"/>
+                </a:solidFill>
+                <a:latin typeface="微软雅黑"/>
+                <a:ea typeface="微软雅黑"/>
+                <a:cs typeface="微软雅黑"/>
+              </a:rPr>
+              <a:t>受风控限制，付款到出票环节容易失败</a:t>
+            </a:r>
+          </a:p>
+        </p:txBody>
+      </p:sp>
+      <p:sp>
+        <p:nvSpPr>
+          <p:cNvPr id="25" name="Rounded Rectangle 24"/>
+          <p:cNvSpPr/>
+          <p:nvPr/>
+        </p:nvSpPr>
+        <p:spPr>
+          <a:xfrm>
+            <a:off x="457200" y="3657600"/>
+            <a:ext cx="4480560" cy="2423160"/>
           </a:xfrm>
           <a:prstGeom prst="roundRect">
             <a:avLst>
@@ -10196,19 +10424,185 @@
           <a:p/>
         </p:txBody>
       </p:sp>
-      <p:sp>
-        <p:nvSpPr>
-          <p:cNvPr id="20" name="icon-circle"/>
+      <p:pic>
+        <p:nvPicPr>
+          <p:cNvPr id="26" name="Picture 25" descr="FaLightbulb_b.png"/>
+          <p:cNvPicPr>
+            <a:picLocks noChangeAspect="1"/>
+          </p:cNvPicPr>
+          <p:nvPr/>
+        </p:nvPicPr>
+        <p:blipFill>
+          <a:blip r:embed="rId7"/>
+          <a:stretch>
+            <a:fillRect/>
+          </a:stretch>
+        </p:blipFill>
+        <p:spPr>
+          <a:xfrm>
+            <a:off x="685800" y="3858768"/>
+            <a:ext cx="365760" cy="365760"/>
+          </a:xfrm>
+          <a:prstGeom prst="rect">
+            <a:avLst/>
+          </a:prstGeom>
+        </p:spPr>
+      </p:pic>
+      <p:sp>
+        <p:nvSpPr>
+          <p:cNvPr id="27" name="TextBox 26"/>
+          <p:cNvSpPr txBox="1"/>
+          <p:nvPr/>
+        </p:nvSpPr>
+        <p:spPr>
+          <a:xfrm>
+            <a:off x="1170432" y="3858768"/>
+            <a:ext cx="3566160" cy="365760"/>
+          </a:xfrm>
+          <a:prstGeom prst="rect">
+            <a:avLst/>
+          </a:prstGeom>
+          <a:noFill/>
+        </p:spPr>
+        <p:txBody>
+          <a:bodyPr wrap="square" lIns="0" rIns="0" tIns="0" bIns="0" anchor="t">
+            <a:spAutoFit/>
+          </a:bodyPr>
+          <a:lstStyle/>
+          <a:p>
+            <a:pPr algn="l"/>
+            <a:r>
+              <a:rPr sz="1600" b="1">
+                <a:solidFill>
+                  <a:srgbClr val="15315E"/>
+                </a:solidFill>
+                <a:latin typeface="微软雅黑"/>
+                <a:ea typeface="微软雅黑"/>
+                <a:cs typeface="微软雅黑"/>
+              </a:rPr>
+              <a:t>KANO：兴奋型需求</a:t>
+            </a:r>
+          </a:p>
+        </p:txBody>
+      </p:sp>
+      <p:sp>
+        <p:nvSpPr>
+          <p:cNvPr id="28" name="TextBox 27"/>
+          <p:cNvSpPr txBox="1"/>
+          <p:nvPr/>
+        </p:nvSpPr>
+        <p:spPr>
+          <a:xfrm>
+            <a:off x="685800" y="4370832"/>
+            <a:ext cx="4069080" cy="914400"/>
+          </a:xfrm>
+          <a:prstGeom prst="rect">
+            <a:avLst/>
+          </a:prstGeom>
+          <a:noFill/>
+        </p:spPr>
+        <p:txBody>
+          <a:bodyPr wrap="square" lIns="0" rIns="0" tIns="0" bIns="0" anchor="t">
+            <a:spAutoFit/>
+          </a:bodyPr>
+          <a:lstStyle/>
+          <a:p>
+            <a:pPr algn="l"/>
+            <a:r>
+              <a:rPr sz="1300" b="0">
+                <a:solidFill>
+                  <a:srgbClr val="3D4757"/>
+                </a:solidFill>
+                <a:latin typeface="微软雅黑"/>
+                <a:ea typeface="微软雅黑"/>
+                <a:cs typeface="微软雅黑"/>
+              </a:rPr>
+              <a:t>做到了是惊喜，做不到用户也不会抱怨；但一旦通知了用户、用户也付了款，他就默认一定能出票。</a:t>
+            </a:r>
+          </a:p>
+        </p:txBody>
+      </p:sp>
+      <p:sp>
+        <p:nvSpPr>
+          <p:cNvPr id="29" name="TextBox 28"/>
+          <p:cNvSpPr txBox="1"/>
+          <p:nvPr/>
+        </p:nvSpPr>
+        <p:spPr>
+          <a:xfrm>
+            <a:off x="685800" y="5349240"/>
+            <a:ext cx="4069080" cy="640080"/>
+          </a:xfrm>
+          <a:prstGeom prst="rect">
+            <a:avLst/>
+          </a:prstGeom>
+          <a:noFill/>
+        </p:spPr>
+        <p:txBody>
+          <a:bodyPr wrap="square" lIns="0" rIns="0" tIns="0" bIns="0" anchor="t">
+            <a:spAutoFit/>
+          </a:bodyPr>
+          <a:lstStyle/>
+          <a:p>
+            <a:pPr algn="l"/>
+            <a:r>
+              <a:rPr sz="1300" b="1">
+                <a:solidFill>
+                  <a:srgbClr val="287DFA"/>
+                </a:solidFill>
+                <a:latin typeface="微软雅黑"/>
+                <a:ea typeface="微软雅黑"/>
+                <a:cs typeface="微软雅黑"/>
+              </a:rPr>
+              <a:t>解决方案　</a:t>
+            </a:r>
+            <a:r>
+              <a:rPr sz="1300" b="0">
+                <a:solidFill>
+                  <a:srgbClr val="3D4757"/>
+                </a:solidFill>
+                <a:latin typeface="微软雅黑"/>
+                <a:ea typeface="微软雅黑"/>
+                <a:cs typeface="微软雅黑"/>
+              </a:rPr>
+              <a:t>确认出票的付款统一改为直付，付款成功即可出票</a:t>
+            </a:r>
+          </a:p>
+        </p:txBody>
+      </p:sp>
+      <p:graphicFrame>
+        <p:nvGraphicFramePr>
+          <p:cNvPr id="30" name="Chart 29"/>
+          <p:cNvGraphicFramePr>
+            <a:graphicFrameLocks noGrp="1"/>
+          </p:cNvGraphicFramePr>
+          <p:nvPr/>
+        </p:nvGraphicFramePr>
+        <p:xfrm>
+          <a:off x="5120640" y="3657600"/>
+          <a:ext cx="2377440" cy="2423160"/>
+        </p:xfrm>
+        <a:graphic>
+          <a:graphicData uri="http://schemas.openxmlformats.org/drawingml/2006/chart">
+            <c:chart xmlns:c="http://schemas.openxmlformats.org/drawingml/2006/chart" r:id="rId8"/>
+          </a:graphicData>
+        </a:graphic>
+      </p:graphicFrame>
+      <p:sp>
+        <p:nvSpPr>
+          <p:cNvPr id="31" name="Rounded Rectangle 30"/>
           <p:cNvSpPr/>
           <p:nvPr/>
         </p:nvSpPr>
         <p:spPr>
           <a:xfrm>
-            <a:off x="10177272" y="1691640"/>
-            <a:ext cx="640080" cy="640080"/>
-          </a:xfrm>
-          <a:prstGeom prst="ellipse">
-            <a:avLst/>
+            <a:off x="7680960" y="3657600"/>
+            <a:ext cx="1691640" cy="2423160"/>
+          </a:xfrm>
+          <a:prstGeom prst="roundRect">
+            <a:avLst>
+              <a:gd name="adj" fmla="val 6000"/>
+            </a:avLst>
           </a:prstGeom>
           <a:solidFill>
             <a:srgbClr val="287DFA"/>
@@ -10238,40 +10632,16 @@
           <a:p/>
         </p:txBody>
       </p:sp>
-      <p:pic>
-        <p:nvPicPr>
-          <p:cNvPr id="21" name="Picture 20" descr="FaTicket_w.png"/>
-          <p:cNvPicPr>
-            <a:picLocks noChangeAspect="1"/>
-          </p:cNvPicPr>
-          <p:nvPr/>
-        </p:nvPicPr>
-        <p:blipFill>
-          <a:blip r:embed="rId6"/>
-          <a:stretch>
-            <a:fillRect/>
-          </a:stretch>
-        </p:blipFill>
-        <p:spPr>
-          <a:xfrm>
-            <a:off x="10337292" y="1851660"/>
-            <a:ext cx="320040" cy="320040"/>
-          </a:xfrm>
-          <a:prstGeom prst="rect">
-            <a:avLst/>
-          </a:prstGeom>
-        </p:spPr>
-      </p:pic>
-      <p:sp>
-        <p:nvSpPr>
-          <p:cNvPr id="22" name="TextBox 21"/>
+      <p:sp>
+        <p:nvSpPr>
+          <p:cNvPr id="32" name="TextBox 31"/>
           <p:cNvSpPr txBox="1"/>
           <p:nvPr/>
         </p:nvSpPr>
         <p:spPr>
           <a:xfrm>
-            <a:off x="9372600" y="2395728"/>
-            <a:ext cx="2240280" cy="594360"/>
+            <a:off x="7726679" y="4343400"/>
+            <a:ext cx="1600200" cy="1005840"/>
           </a:xfrm>
           <a:prstGeom prst="rect">
             <a:avLst/>
@@ -10286,335 +10656,25 @@
           <a:p>
             <a:pPr algn="ctr"/>
             <a:r>
-              <a:rPr sz="1400" b="1">
-                <a:solidFill>
-                  <a:srgbClr val="3D4757"/>
+              <a:rPr sz="1500" b="1">
+                <a:solidFill>
+                  <a:srgbClr val="FFFFFF"/>
                 </a:solidFill>
                 <a:latin typeface="微软雅黑"/>
                 <a:ea typeface="微软雅黑"/>
                 <a:cs typeface="微软雅黑"/>
               </a:rPr>
-              <a:t>出票</a:t>
+              <a:t>预估年化票量</a:t>
             </a:r>
           </a:p>
-        </p:txBody>
-      </p:sp>
-      <p:sp>
-        <p:nvSpPr>
-          <p:cNvPr id="23" name="TextBox 22"/>
-          <p:cNvSpPr txBox="1"/>
-          <p:nvPr/>
-        </p:nvSpPr>
-        <p:spPr>
-          <a:xfrm>
-            <a:off x="6309360" y="3154680"/>
-            <a:ext cx="2514600" cy="320040"/>
-          </a:xfrm>
-          <a:prstGeom prst="rect">
-            <a:avLst/>
-          </a:prstGeom>
-          <a:noFill/>
-        </p:spPr>
-        <p:txBody>
-          <a:bodyPr wrap="square" lIns="0" rIns="0" tIns="0" bIns="0" anchor="t">
-            <a:spAutoFit/>
-          </a:bodyPr>
-          <a:lstStyle/>
           <a:p>
-            <a:pPr algn="ctr"/>
+            <a:pPr algn="ctr">
+              <a:spcBef>
+                <a:spcPts val="600"/>
+              </a:spcBef>
+            </a:pPr>
             <a:r>
-              <a:rPr sz="1200" b="1">
-                <a:solidFill>
-                  <a:srgbClr val="FF7A1A"/>
-                </a:solidFill>
-                <a:latin typeface="微软雅黑"/>
-                <a:ea typeface="微软雅黑"/>
-                <a:cs typeface="微软雅黑"/>
-              </a:rPr>
-              <a:t>受风控限制，付款环节容易失败</a:t>
-            </a:r>
-          </a:p>
-        </p:txBody>
-      </p:sp>
-      <p:sp>
-        <p:nvSpPr>
-          <p:cNvPr id="24" name="Rounded Rectangle 23"/>
-          <p:cNvSpPr/>
-          <p:nvPr/>
-        </p:nvSpPr>
-        <p:spPr>
-          <a:xfrm>
-            <a:off x="457200" y="3657600"/>
-            <a:ext cx="6035040" cy="2423160"/>
-          </a:xfrm>
-          <a:prstGeom prst="roundRect">
-            <a:avLst>
-              <a:gd name="adj" fmla="val 6000"/>
-            </a:avLst>
-          </a:prstGeom>
-          <a:solidFill>
-            <a:srgbClr val="F5F9FF"/>
-          </a:solidFill>
-          <a:ln w="12700">
-            <a:solidFill>
-              <a:srgbClr val="D3E2FB"/>
-            </a:solidFill>
-          </a:ln>
-          <a:effectLst/>
-        </p:spPr>
-        <p:style>
-          <a:lnRef idx="1">
-            <a:schemeClr val="accent1"/>
-          </a:lnRef>
-          <a:fillRef idx="3">
-            <a:schemeClr val="accent1"/>
-          </a:fillRef>
-          <a:effectRef idx="2">
-            <a:schemeClr val="accent1"/>
-          </a:effectRef>
-          <a:fontRef idx="minor">
-            <a:schemeClr val="lt1"/>
-          </a:fontRef>
-        </p:style>
-        <p:txBody>
-          <a:bodyPr rtlCol="0" anchor="ctr"/>
-          <a:lstStyle/>
-          <a:p/>
-        </p:txBody>
-      </p:sp>
-      <p:pic>
-        <p:nvPicPr>
-          <p:cNvPr id="25" name="Picture 24" descr="FaLightbulb_b.png"/>
-          <p:cNvPicPr>
-            <a:picLocks noChangeAspect="1"/>
-          </p:cNvPicPr>
-          <p:nvPr/>
-        </p:nvPicPr>
-        <p:blipFill>
-          <a:blip r:embed="rId7"/>
-          <a:stretch>
-            <a:fillRect/>
-          </a:stretch>
-        </p:blipFill>
-        <p:spPr>
-          <a:xfrm>
-            <a:off x="731520" y="3886200"/>
-            <a:ext cx="365760" cy="365760"/>
-          </a:xfrm>
-          <a:prstGeom prst="rect">
-            <a:avLst/>
-          </a:prstGeom>
-        </p:spPr>
-      </p:pic>
-      <p:sp>
-        <p:nvSpPr>
-          <p:cNvPr id="26" name="TextBox 25"/>
-          <p:cNvSpPr txBox="1"/>
-          <p:nvPr/>
-        </p:nvSpPr>
-        <p:spPr>
-          <a:xfrm>
-            <a:off x="1234440" y="3886200"/>
-            <a:ext cx="5029200" cy="365760"/>
-          </a:xfrm>
-          <a:prstGeom prst="rect">
-            <a:avLst/>
-          </a:prstGeom>
-          <a:noFill/>
-        </p:spPr>
-        <p:txBody>
-          <a:bodyPr wrap="square" lIns="0" rIns="0" tIns="0" bIns="0" anchor="t">
-            <a:spAutoFit/>
-          </a:bodyPr>
-          <a:lstStyle/>
-          <a:p>
-            <a:pPr algn="l"/>
-            <a:r>
-              <a:rPr sz="1600" b="1">
-                <a:solidFill>
-                  <a:srgbClr val="15315E"/>
-                </a:solidFill>
-                <a:latin typeface="微软雅黑"/>
-                <a:ea typeface="微软雅黑"/>
-                <a:cs typeface="微软雅黑"/>
-              </a:rPr>
-              <a:t>KANO：兴奋型需求</a:t>
-            </a:r>
-          </a:p>
-        </p:txBody>
-      </p:sp>
-      <p:sp>
-        <p:nvSpPr>
-          <p:cNvPr id="27" name="TextBox 26"/>
-          <p:cNvSpPr txBox="1"/>
-          <p:nvPr/>
-        </p:nvSpPr>
-        <p:spPr>
-          <a:xfrm>
-            <a:off x="731520" y="4389120"/>
-            <a:ext cx="5577840" cy="777240"/>
-          </a:xfrm>
-          <a:prstGeom prst="rect">
-            <a:avLst/>
-          </a:prstGeom>
-          <a:noFill/>
-        </p:spPr>
-        <p:txBody>
-          <a:bodyPr wrap="square" lIns="0" rIns="0" tIns="0" bIns="0" anchor="t">
-            <a:spAutoFit/>
-          </a:bodyPr>
-          <a:lstStyle/>
-          <a:p>
-            <a:pPr algn="l"/>
-            <a:r>
-              <a:rPr sz="1400" b="0">
-                <a:solidFill>
-                  <a:srgbClr val="3D4757"/>
-                </a:solidFill>
-                <a:latin typeface="微软雅黑"/>
-                <a:ea typeface="微软雅黑"/>
-                <a:cs typeface="微软雅黑"/>
-              </a:rPr>
-              <a:t>做到了是惊喜，做不到用户也不会抱怨；但一旦通知了用户、用户也付了款，他就默认一定能出票。</a:t>
-            </a:r>
-          </a:p>
-        </p:txBody>
-      </p:sp>
-      <p:sp>
-        <p:nvSpPr>
-          <p:cNvPr id="28" name="TextBox 27"/>
-          <p:cNvSpPr txBox="1"/>
-          <p:nvPr/>
-        </p:nvSpPr>
-        <p:spPr>
-          <a:xfrm>
-            <a:off x="731520" y="5257800"/>
-            <a:ext cx="5577840" cy="685800"/>
-          </a:xfrm>
-          <a:prstGeom prst="rect">
-            <a:avLst/>
-          </a:prstGeom>
-          <a:noFill/>
-        </p:spPr>
-        <p:txBody>
-          <a:bodyPr wrap="square" lIns="0" rIns="0" tIns="0" bIns="0" anchor="t">
-            <a:spAutoFit/>
-          </a:bodyPr>
-          <a:lstStyle/>
-          <a:p>
-            <a:pPr algn="l"/>
-            <a:r>
-              <a:rPr sz="1400" b="1">
-                <a:solidFill>
-                  <a:srgbClr val="287DFA"/>
-                </a:solidFill>
-                <a:latin typeface="微软雅黑"/>
-                <a:ea typeface="微软雅黑"/>
-                <a:cs typeface="微软雅黑"/>
-              </a:rPr>
-              <a:t>解决方案　</a:t>
-            </a:r>
-            <a:r>
-              <a:rPr sz="1400" b="0">
-                <a:solidFill>
-                  <a:srgbClr val="3D4757"/>
-                </a:solidFill>
-                <a:latin typeface="微软雅黑"/>
-                <a:ea typeface="微软雅黑"/>
-                <a:cs typeface="微软雅黑"/>
-              </a:rPr>
-              <a:t>确认出票的付款统一改为直付，付款成功即可出票</a:t>
-            </a:r>
-          </a:p>
-        </p:txBody>
-      </p:sp>
-      <p:graphicFrame>
-        <p:nvGraphicFramePr>
-          <p:cNvPr id="29" name="Chart 28"/>
-          <p:cNvGraphicFramePr>
-            <a:graphicFrameLocks noGrp="1"/>
-          </p:cNvGraphicFramePr>
-          <p:nvPr/>
-        </p:nvGraphicFramePr>
-        <p:xfrm>
-          <a:off x="6812280" y="3657600"/>
-          <a:ext cx="2743200" cy="2423160"/>
-        </p:xfrm>
-        <a:graphic>
-          <a:graphicData uri="http://schemas.openxmlformats.org/drawingml/2006/chart">
-            <c:chart xmlns:c="http://schemas.openxmlformats.org/drawingml/2006/chart" r:id="rId8"/>
-          </a:graphicData>
-        </a:graphic>
-      </p:graphicFrame>
-      <p:sp>
-        <p:nvSpPr>
-          <p:cNvPr id="30" name="Rounded Rectangle 29"/>
-          <p:cNvSpPr/>
-          <p:nvPr/>
-        </p:nvSpPr>
-        <p:spPr>
-          <a:xfrm>
-            <a:off x="9738360" y="3657600"/>
-            <a:ext cx="2011680" cy="2423160"/>
-          </a:xfrm>
-          <a:prstGeom prst="roundRect">
-            <a:avLst>
-              <a:gd name="adj" fmla="val 6000"/>
-            </a:avLst>
-          </a:prstGeom>
-          <a:solidFill>
-            <a:srgbClr val="287DFA"/>
-          </a:solidFill>
-          <a:ln>
-            <a:noFill/>
-          </a:ln>
-          <a:effectLst/>
-        </p:spPr>
-        <p:style>
-          <a:lnRef idx="1">
-            <a:schemeClr val="accent1"/>
-          </a:lnRef>
-          <a:fillRef idx="3">
-            <a:schemeClr val="accent1"/>
-          </a:fillRef>
-          <a:effectRef idx="2">
-            <a:schemeClr val="accent1"/>
-          </a:effectRef>
-          <a:fontRef idx="minor">
-            <a:schemeClr val="lt1"/>
-          </a:fontRef>
-        </p:style>
-        <p:txBody>
-          <a:bodyPr rtlCol="0" anchor="ctr"/>
-          <a:lstStyle/>
-          <a:p/>
-        </p:txBody>
-      </p:sp>
-      <p:sp>
-        <p:nvSpPr>
-          <p:cNvPr id="31" name="TextBox 30"/>
-          <p:cNvSpPr txBox="1"/>
-          <p:nvPr/>
-        </p:nvSpPr>
-        <p:spPr>
-          <a:xfrm>
-            <a:off x="9829800" y="4160520"/>
-            <a:ext cx="1828800" cy="731520"/>
-          </a:xfrm>
-          <a:prstGeom prst="rect">
-            <a:avLst/>
-          </a:prstGeom>
-          <a:noFill/>
-        </p:spPr>
-        <p:txBody>
-          <a:bodyPr wrap="square" lIns="0" rIns="0" tIns="0" bIns="0" anchor="t">
-            <a:spAutoFit/>
-          </a:bodyPr>
-          <a:lstStyle/>
-          <a:p>
-            <a:pPr algn="ctr"/>
-            <a:r>
-              <a:rPr sz="3200" b="1">
+              <a:rPr sz="2600" b="1">
                 <a:solidFill>
                   <a:srgbClr val="FFFFFF"/>
                 </a:solidFill>
@@ -10627,43 +10687,37 @@
           </a:p>
         </p:txBody>
       </p:sp>
-      <p:sp>
-        <p:nvSpPr>
-          <p:cNvPr id="32" name="TextBox 31"/>
-          <p:cNvSpPr txBox="1"/>
-          <p:nvPr/>
-        </p:nvSpPr>
-        <p:spPr>
-          <a:xfrm>
-            <a:off x="9829800" y="4937760"/>
-            <a:ext cx="1828800" cy="365760"/>
-          </a:xfrm>
-          <a:prstGeom prst="rect">
-            <a:avLst/>
-          </a:prstGeom>
-          <a:noFill/>
-        </p:spPr>
-        <p:txBody>
-          <a:bodyPr wrap="square" lIns="0" rIns="0" tIns="0" bIns="0" anchor="t">
-            <a:spAutoFit/>
-          </a:bodyPr>
-          <a:lstStyle/>
-          <a:p>
-            <a:pPr algn="ctr"/>
-            <a:r>
-              <a:rPr sz="1400" b="0">
-                <a:solidFill>
-                  <a:srgbClr val="FFFFFF"/>
-                </a:solidFill>
-                <a:latin typeface="微软雅黑"/>
-                <a:ea typeface="微软雅黑"/>
-                <a:cs typeface="微软雅黑"/>
-              </a:rPr>
-              <a:t>预估年化票量</a:t>
-            </a:r>
-          </a:p>
-        </p:txBody>
-      </p:sp>
+      <p:pic>
+        <p:nvPicPr>
+          <p:cNvPr id="33" name="真实截图-车票待确认" descr="second_leg.jpg"/>
+          <p:cNvPicPr>
+            <a:picLocks noChangeAspect="1"/>
+          </p:cNvPicPr>
+          <p:nvPr/>
+        </p:nvPicPr>
+        <p:blipFill>
+          <a:blip r:embed="rId9"/>
+          <a:stretch>
+            <a:fillRect/>
+          </a:stretch>
+        </p:blipFill>
+        <p:spPr>
+          <a:xfrm>
+            <a:off x="9630689" y="1463040"/>
+            <a:ext cx="2101062" cy="4617720"/>
+          </a:xfrm>
+          <a:prstGeom prst="roundRect">
+            <a:avLst>
+              <a:gd name="adj" fmla="val 6000"/>
+            </a:avLst>
+          </a:prstGeom>
+          <a:ln w="25400">
+            <a:solidFill>
+              <a:srgbClr val="000000"/>
+            </a:solidFill>
+          </a:ln>
+        </p:spPr>
+      </p:pic>
     </p:spTree>
   </p:cSld>
   <p:clrMapOvr>

</xml_diff>

<commit_message>
Rework grab-to-buy slide with real screenshots
Co-Authored-By: Claude Opus 5.5 <noreply@anthropic.com>
Claude-Session: https://claude.ai/code/session_011iFrL2Hfizgp6kYckDtNGc
</commit_message>
<xml_diff>
--- a/答辩PPT.pptx
+++ b/答辩PPT.pptx
@@ -10871,7 +10871,7 @@
                 <a:latin typeface="微软雅黑" panose="020B0503020204020204" pitchFamily="34" charset="-122"/>
                 <a:ea typeface="微软雅黑" panose="020B0503020204020204" pitchFamily="34" charset="-122"/>
               </a:rPr>
-              <a:t>2、主要项目 · 抢票：放开抢转买</a:t>
+              <a:t>2、主要项目 · 抢票：支付宝（非黑名单）放开抢转买</a:t>
             </a:r>
             <a:endParaRPr lang="zh-CN" altLang="en-US" sz="2400" b="1" dirty="0">
               <a:solidFill>
@@ -10915,7 +10915,7 @@
                 <a:ea typeface="微软雅黑"/>
                 <a:cs typeface="微软雅黑"/>
               </a:rPr>
-              <a:t>用户妥协接受了替代方案，就该用更直接的方式出票</a:t>
+              <a:t>用户的让步，换的是“马上能出票”</a:t>
             </a:r>
           </a:p>
         </p:txBody>
@@ -10929,7 +10929,7 @@
         <p:spPr>
           <a:xfrm>
             <a:off x="457200" y="1554480"/>
-            <a:ext cx="5212080" cy="4526280"/>
+            <a:ext cx="3063240" cy="914400"/>
           </a:xfrm>
           <a:prstGeom prst="roundRect">
             <a:avLst>
@@ -10968,14 +10968,530 @@
       </p:sp>
       <p:sp>
         <p:nvSpPr>
-          <p:cNvPr id="5" name="TextBox 4"/>
+          <p:cNvPr id="5" name="icon-circle"/>
+          <p:cNvSpPr/>
+          <p:nvPr/>
+        </p:nvSpPr>
+        <p:spPr>
+          <a:xfrm>
+            <a:off x="685800" y="1737360"/>
+            <a:ext cx="548640" cy="548640"/>
+          </a:xfrm>
+          <a:prstGeom prst="ellipse">
+            <a:avLst/>
+          </a:prstGeom>
+          <a:solidFill>
+            <a:srgbClr val="287DFA"/>
+          </a:solidFill>
+          <a:ln>
+            <a:noFill/>
+          </a:ln>
+          <a:effectLst/>
+        </p:spPr>
+        <p:style>
+          <a:lnRef idx="1">
+            <a:schemeClr val="accent1"/>
+          </a:lnRef>
+          <a:fillRef idx="3">
+            <a:schemeClr val="accent1"/>
+          </a:fillRef>
+          <a:effectRef idx="2">
+            <a:schemeClr val="accent1"/>
+          </a:effectRef>
+          <a:fontRef idx="minor">
+            <a:schemeClr val="lt1"/>
+          </a:fontRef>
+        </p:style>
+        <p:txBody>
+          <a:bodyPr rtlCol="0" anchor="ctr"/>
+          <a:lstStyle/>
+          <a:p/>
+        </p:txBody>
+      </p:sp>
+      <p:pic>
+        <p:nvPicPr>
+          <p:cNvPr id="6" name="Picture 5" descr="FaListCheck_w.png"/>
+          <p:cNvPicPr>
+            <a:picLocks noChangeAspect="1"/>
+          </p:cNvPicPr>
+          <p:nvPr/>
+        </p:nvPicPr>
+        <p:blipFill>
+          <a:blip r:embed="rId3"/>
+          <a:stretch>
+            <a:fillRect/>
+          </a:stretch>
+        </p:blipFill>
+        <p:spPr>
+          <a:xfrm>
+            <a:off x="822960" y="1874519"/>
+            <a:ext cx="274320" cy="274320"/>
+          </a:xfrm>
+          <a:prstGeom prst="rect">
+            <a:avLst/>
+          </a:prstGeom>
+        </p:spPr>
+      </p:pic>
+      <p:sp>
+        <p:nvSpPr>
+          <p:cNvPr id="7" name="TextBox 6"/>
           <p:cNvSpPr txBox="1"/>
           <p:nvPr/>
         </p:nvSpPr>
         <p:spPr>
           <a:xfrm>
-            <a:off x="777240" y="1737360"/>
-            <a:ext cx="4572000" cy="411480"/>
+            <a:off x="1371600" y="1554480"/>
+            <a:ext cx="2057400" cy="914400"/>
+          </a:xfrm>
+          <a:prstGeom prst="rect">
+            <a:avLst/>
+          </a:prstGeom>
+          <a:noFill/>
+        </p:spPr>
+        <p:txBody>
+          <a:bodyPr wrap="square" lIns="0" rIns="0" tIns="0" bIns="0" anchor="ctr">
+            <a:spAutoFit/>
+          </a:bodyPr>
+          <a:lstStyle/>
+          <a:p>
+            <a:pPr algn="l"/>
+            <a:r>
+              <a:rPr sz="1400" b="1">
+                <a:solidFill>
+                  <a:srgbClr val="15315E"/>
+                </a:solidFill>
+                <a:latin typeface="微软雅黑"/>
+                <a:ea typeface="微软雅黑"/>
+                <a:cs typeface="微软雅黑"/>
+              </a:rPr>
+              <a:t>推荐可立即出票的</a:t>
+            </a:r>
+          </a:p>
+          <a:p>
+            <a:pPr algn="l">
+              <a:spcBef>
+                <a:spcPts val="0"/>
+              </a:spcBef>
+            </a:pPr>
+            <a:r>
+              <a:rPr sz="1400" b="1">
+                <a:solidFill>
+                  <a:srgbClr val="15315E"/>
+                </a:solidFill>
+                <a:latin typeface="微软雅黑"/>
+                <a:ea typeface="微软雅黑"/>
+                <a:cs typeface="微软雅黑"/>
+              </a:rPr>
+              <a:t>替代方案</a:t>
+            </a:r>
+          </a:p>
+        </p:txBody>
+      </p:sp>
+      <p:sp>
+        <p:nvSpPr>
+          <p:cNvPr id="8" name="Rounded Rectangle 7"/>
+          <p:cNvSpPr/>
+          <p:nvPr/>
+        </p:nvSpPr>
+        <p:spPr>
+          <a:xfrm>
+            <a:off x="3886200" y="1554480"/>
+            <a:ext cx="3063240" cy="914400"/>
+          </a:xfrm>
+          <a:prstGeom prst="roundRect">
+            <a:avLst>
+              <a:gd name="adj" fmla="val 6000"/>
+            </a:avLst>
+          </a:prstGeom>
+          <a:solidFill>
+            <a:srgbClr val="F5F9FF"/>
+          </a:solidFill>
+          <a:ln w="12700">
+            <a:solidFill>
+              <a:srgbClr val="D3E2FB"/>
+            </a:solidFill>
+          </a:ln>
+          <a:effectLst/>
+        </p:spPr>
+        <p:style>
+          <a:lnRef idx="1">
+            <a:schemeClr val="accent1"/>
+          </a:lnRef>
+          <a:fillRef idx="3">
+            <a:schemeClr val="accent1"/>
+          </a:fillRef>
+          <a:effectRef idx="2">
+            <a:schemeClr val="accent1"/>
+          </a:effectRef>
+          <a:fontRef idx="minor">
+            <a:schemeClr val="lt1"/>
+          </a:fontRef>
+        </p:style>
+        <p:txBody>
+          <a:bodyPr rtlCol="0" anchor="ctr"/>
+          <a:lstStyle/>
+          <a:p/>
+        </p:txBody>
+      </p:sp>
+      <p:sp>
+        <p:nvSpPr>
+          <p:cNvPr id="9" name="icon-circle"/>
+          <p:cNvSpPr/>
+          <p:nvPr/>
+        </p:nvSpPr>
+        <p:spPr>
+          <a:xfrm>
+            <a:off x="4114800" y="1737360"/>
+            <a:ext cx="548640" cy="548640"/>
+          </a:xfrm>
+          <a:prstGeom prst="ellipse">
+            <a:avLst/>
+          </a:prstGeom>
+          <a:solidFill>
+            <a:srgbClr val="287DFA"/>
+          </a:solidFill>
+          <a:ln>
+            <a:noFill/>
+          </a:ln>
+          <a:effectLst/>
+        </p:spPr>
+        <p:style>
+          <a:lnRef idx="1">
+            <a:schemeClr val="accent1"/>
+          </a:lnRef>
+          <a:fillRef idx="3">
+            <a:schemeClr val="accent1"/>
+          </a:fillRef>
+          <a:effectRef idx="2">
+            <a:schemeClr val="accent1"/>
+          </a:effectRef>
+          <a:fontRef idx="minor">
+            <a:schemeClr val="lt1"/>
+          </a:fontRef>
+        </p:style>
+        <p:txBody>
+          <a:bodyPr rtlCol="0" anchor="ctr"/>
+          <a:lstStyle/>
+          <a:p/>
+        </p:txBody>
+      </p:sp>
+      <p:pic>
+        <p:nvPicPr>
+          <p:cNvPr id="10" name="Picture 9" descr="FaUserCheck_w.png"/>
+          <p:cNvPicPr>
+            <a:picLocks noChangeAspect="1"/>
+          </p:cNvPicPr>
+          <p:nvPr/>
+        </p:nvPicPr>
+        <p:blipFill>
+          <a:blip r:embed="rId4"/>
+          <a:stretch>
+            <a:fillRect/>
+          </a:stretch>
+        </p:blipFill>
+        <p:spPr>
+          <a:xfrm>
+            <a:off x="4251960" y="1874519"/>
+            <a:ext cx="274320" cy="274320"/>
+          </a:xfrm>
+          <a:prstGeom prst="rect">
+            <a:avLst/>
+          </a:prstGeom>
+        </p:spPr>
+      </p:pic>
+      <p:sp>
+        <p:nvSpPr>
+          <p:cNvPr id="11" name="TextBox 10"/>
+          <p:cNvSpPr txBox="1"/>
+          <p:nvPr/>
+        </p:nvSpPr>
+        <p:spPr>
+          <a:xfrm>
+            <a:off x="4800600" y="1554480"/>
+            <a:ext cx="2057400" cy="914400"/>
+          </a:xfrm>
+          <a:prstGeom prst="rect">
+            <a:avLst/>
+          </a:prstGeom>
+          <a:noFill/>
+        </p:spPr>
+        <p:txBody>
+          <a:bodyPr wrap="square" lIns="0" rIns="0" tIns="0" bIns="0" anchor="ctr">
+            <a:spAutoFit/>
+          </a:bodyPr>
+          <a:lstStyle/>
+          <a:p>
+            <a:pPr algn="l"/>
+            <a:r>
+              <a:rPr sz="1400" b="1">
+                <a:solidFill>
+                  <a:srgbClr val="15315E"/>
+                </a:solidFill>
+                <a:latin typeface="微软雅黑"/>
+                <a:ea typeface="微软雅黑"/>
+                <a:cs typeface="微软雅黑"/>
+              </a:rPr>
+              <a:t>用户让步，</a:t>
+            </a:r>
+          </a:p>
+          <a:p>
+            <a:pPr algn="l">
+              <a:spcBef>
+                <a:spcPts val="0"/>
+              </a:spcBef>
+            </a:pPr>
+            <a:r>
+              <a:rPr sz="1400" b="1">
+                <a:solidFill>
+                  <a:srgbClr val="15315E"/>
+                </a:solidFill>
+                <a:latin typeface="微软雅黑"/>
+                <a:ea typeface="微软雅黑"/>
+                <a:cs typeface="微软雅黑"/>
+              </a:rPr>
+              <a:t>接受替代方案</a:t>
+            </a:r>
+          </a:p>
+        </p:txBody>
+      </p:sp>
+      <p:sp>
+        <p:nvSpPr>
+          <p:cNvPr id="12" name="arrow"/>
+          <p:cNvSpPr/>
+          <p:nvPr/>
+        </p:nvSpPr>
+        <p:spPr>
+          <a:xfrm>
+            <a:off x="3584448" y="1874519"/>
+            <a:ext cx="256032" cy="274320"/>
+          </a:xfrm>
+          <a:prstGeom prst="rightArrow">
+            <a:avLst/>
+          </a:prstGeom>
+          <a:solidFill>
+            <a:srgbClr val="D3E2FB"/>
+          </a:solidFill>
+          <a:ln>
+            <a:noFill/>
+          </a:ln>
+          <a:effectLst/>
+        </p:spPr>
+        <p:style>
+          <a:lnRef idx="1">
+            <a:schemeClr val="accent1"/>
+          </a:lnRef>
+          <a:fillRef idx="3">
+            <a:schemeClr val="accent1"/>
+          </a:fillRef>
+          <a:effectRef idx="2">
+            <a:schemeClr val="accent1"/>
+          </a:effectRef>
+          <a:fontRef idx="minor">
+            <a:schemeClr val="lt1"/>
+          </a:fontRef>
+        </p:style>
+        <p:txBody>
+          <a:bodyPr rtlCol="0" anchor="ctr"/>
+          <a:lstStyle/>
+          <a:p/>
+        </p:txBody>
+      </p:sp>
+      <p:cxnSp>
+        <p:nvCxnSpPr>
+          <p:cNvPr id="13" name="Connector 12"/>
+          <p:cNvCxnSpPr/>
+          <p:nvPr/>
+        </p:nvCxnSpPr>
+        <p:spPr>
+          <a:xfrm>
+            <a:off x="5413248" y="2468880"/>
+            <a:ext cx="0" cy="274320"/>
+          </a:xfrm>
+          <a:prstGeom prst="line">
+            <a:avLst/>
+          </a:prstGeom>
+          <a:ln w="19050">
+            <a:solidFill>
+              <a:srgbClr val="287DFA"/>
+            </a:solidFill>
+          </a:ln>
+        </p:spPr>
+        <p:style>
+          <a:lnRef idx="2">
+            <a:schemeClr val="accent1"/>
+          </a:lnRef>
+          <a:fillRef idx="0">
+            <a:schemeClr val="accent1"/>
+          </a:fillRef>
+          <a:effectRef idx="1">
+            <a:schemeClr val="accent1"/>
+          </a:effectRef>
+          <a:fontRef idx="minor">
+            <a:schemeClr val="tx1"/>
+          </a:fontRef>
+        </p:style>
+      </p:cxnSp>
+      <p:cxnSp>
+        <p:nvCxnSpPr>
+          <p:cNvPr id="14" name="Connector 13"/>
+          <p:cNvCxnSpPr/>
+          <p:nvPr/>
+        </p:nvCxnSpPr>
+        <p:spPr>
+          <a:xfrm>
+            <a:off x="1984248" y="2743200"/>
+            <a:ext cx="3429000" cy="0"/>
+          </a:xfrm>
+          <a:prstGeom prst="line">
+            <a:avLst/>
+          </a:prstGeom>
+          <a:ln w="19050">
+            <a:solidFill>
+              <a:srgbClr val="287DFA"/>
+            </a:solidFill>
+          </a:ln>
+        </p:spPr>
+        <p:style>
+          <a:lnRef idx="2">
+            <a:schemeClr val="accent1"/>
+          </a:lnRef>
+          <a:fillRef idx="0">
+            <a:schemeClr val="accent1"/>
+          </a:fillRef>
+          <a:effectRef idx="1">
+            <a:schemeClr val="accent1"/>
+          </a:effectRef>
+          <a:fontRef idx="minor">
+            <a:schemeClr val="tx1"/>
+          </a:fontRef>
+        </p:style>
+      </p:cxnSp>
+      <p:cxnSp>
+        <p:nvCxnSpPr>
+          <p:cNvPr id="15" name="Connector 14"/>
+          <p:cNvCxnSpPr/>
+          <p:nvPr/>
+        </p:nvCxnSpPr>
+        <p:spPr>
+          <a:xfrm>
+            <a:off x="1984248" y="2743200"/>
+            <a:ext cx="0" cy="228600"/>
+          </a:xfrm>
+          <a:prstGeom prst="line">
+            <a:avLst/>
+          </a:prstGeom>
+          <a:ln w="19050">
+            <a:solidFill>
+              <a:srgbClr val="7A8599"/>
+            </a:solidFill>
+          </a:ln>
+        </p:spPr>
+        <p:style>
+          <a:lnRef idx="2">
+            <a:schemeClr val="accent1"/>
+          </a:lnRef>
+          <a:fillRef idx="0">
+            <a:schemeClr val="accent1"/>
+          </a:fillRef>
+          <a:effectRef idx="1">
+            <a:schemeClr val="accent1"/>
+          </a:effectRef>
+          <a:fontRef idx="minor">
+            <a:schemeClr val="tx1"/>
+          </a:fontRef>
+        </p:style>
+      </p:cxnSp>
+      <p:cxnSp>
+        <p:nvCxnSpPr>
+          <p:cNvPr id="16" name="Connector 15"/>
+          <p:cNvCxnSpPr/>
+          <p:nvPr/>
+        </p:nvCxnSpPr>
+        <p:spPr>
+          <a:xfrm>
+            <a:off x="5413248" y="2743200"/>
+            <a:ext cx="0" cy="228600"/>
+          </a:xfrm>
+          <a:prstGeom prst="line">
+            <a:avLst/>
+          </a:prstGeom>
+          <a:ln w="19050">
+            <a:solidFill>
+              <a:srgbClr val="287DFA"/>
+            </a:solidFill>
+          </a:ln>
+        </p:spPr>
+        <p:style>
+          <a:lnRef idx="2">
+            <a:schemeClr val="accent1"/>
+          </a:lnRef>
+          <a:fillRef idx="0">
+            <a:schemeClr val="accent1"/>
+          </a:fillRef>
+          <a:effectRef idx="1">
+            <a:schemeClr val="accent1"/>
+          </a:effectRef>
+          <a:fontRef idx="minor">
+            <a:schemeClr val="tx1"/>
+          </a:fontRef>
+        </p:style>
+      </p:cxnSp>
+      <p:sp>
+        <p:nvSpPr>
+          <p:cNvPr id="17" name="Rounded Rectangle 16"/>
+          <p:cNvSpPr/>
+          <p:nvPr/>
+        </p:nvSpPr>
+        <p:spPr>
+          <a:xfrm>
+            <a:off x="457200" y="2971800"/>
+            <a:ext cx="3063240" cy="3108960"/>
+          </a:xfrm>
+          <a:prstGeom prst="roundRect">
+            <a:avLst>
+              <a:gd name="adj" fmla="val 6000"/>
+            </a:avLst>
+          </a:prstGeom>
+          <a:solidFill>
+            <a:srgbClr val="F5F9FF"/>
+          </a:solidFill>
+          <a:ln w="12700">
+            <a:solidFill>
+              <a:srgbClr val="D3E2FB"/>
+            </a:solidFill>
+          </a:ln>
+          <a:effectLst/>
+        </p:spPr>
+        <p:style>
+          <a:lnRef idx="1">
+            <a:schemeClr val="accent1"/>
+          </a:lnRef>
+          <a:fillRef idx="3">
+            <a:schemeClr val="accent1"/>
+          </a:fillRef>
+          <a:effectRef idx="2">
+            <a:schemeClr val="accent1"/>
+          </a:effectRef>
+          <a:fontRef idx="minor">
+            <a:schemeClr val="lt1"/>
+          </a:fontRef>
+        </p:style>
+        <p:txBody>
+          <a:bodyPr rtlCol="0" anchor="ctr"/>
+          <a:lstStyle/>
+          <a:p/>
+        </p:txBody>
+      </p:sp>
+      <p:sp>
+        <p:nvSpPr>
+          <p:cNvPr id="18" name="TextBox 17"/>
+          <p:cNvSpPr txBox="1"/>
+          <p:nvPr/>
+        </p:nvSpPr>
+        <p:spPr>
+          <a:xfrm>
+            <a:off x="731520" y="3127248"/>
+            <a:ext cx="2560320" cy="365760"/>
           </a:xfrm>
           <a:prstGeom prst="rect">
             <a:avLst/>
@@ -10990,7 +11506,7 @@
           <a:p>
             <a:pPr algn="l"/>
             <a:r>
-              <a:rPr sz="2000" b="1">
+              <a:rPr sz="1800" b="1">
                 <a:solidFill>
                   <a:srgbClr val="7A8599"/>
                 </a:solidFill>
@@ -11005,14 +11521,14 @@
       </p:sp>
       <p:sp>
         <p:nvSpPr>
-          <p:cNvPr id="6" name="icon-circle"/>
+          <p:cNvPr id="19" name="icon-circle"/>
           <p:cNvSpPr/>
           <p:nvPr/>
         </p:nvSpPr>
         <p:spPr>
           <a:xfrm>
-            <a:off x="777240" y="2377440"/>
-            <a:ext cx="548640" cy="548640"/>
+            <a:off x="731520" y="3703320"/>
+            <a:ext cx="640080" cy="640080"/>
           </a:xfrm>
           <a:prstGeom prst="ellipse">
             <a:avLst/>
@@ -11047,283 +11563,7 @@
       </p:sp>
       <p:pic>
         <p:nvPicPr>
-          <p:cNvPr id="7" name="Picture 6" descr="FaListCheck_w.png"/>
-          <p:cNvPicPr>
-            <a:picLocks noChangeAspect="1"/>
-          </p:cNvPicPr>
-          <p:nvPr/>
-        </p:nvPicPr>
-        <p:blipFill>
-          <a:blip r:embed="rId3"/>
-          <a:stretch>
-            <a:fillRect/>
-          </a:stretch>
-        </p:blipFill>
-        <p:spPr>
-          <a:xfrm>
-            <a:off x="914400" y="2514600"/>
-            <a:ext cx="274320" cy="274320"/>
-          </a:xfrm>
-          <a:prstGeom prst="rect">
-            <a:avLst/>
-          </a:prstGeom>
-        </p:spPr>
-      </p:pic>
-      <p:sp>
-        <p:nvSpPr>
-          <p:cNvPr id="8" name="TextBox 7"/>
-          <p:cNvSpPr txBox="1"/>
-          <p:nvPr/>
-        </p:nvSpPr>
-        <p:spPr>
-          <a:xfrm>
-            <a:off x="1508760" y="2359152"/>
-            <a:ext cx="3931920" cy="594360"/>
-          </a:xfrm>
-          <a:prstGeom prst="rect">
-            <a:avLst/>
-          </a:prstGeom>
-          <a:noFill/>
-        </p:spPr>
-        <p:txBody>
-          <a:bodyPr wrap="square" lIns="0" rIns="0" tIns="0" bIns="0" anchor="ctr">
-            <a:spAutoFit/>
-          </a:bodyPr>
-          <a:lstStyle/>
-          <a:p>
-            <a:pPr algn="l"/>
-            <a:r>
-              <a:rPr sz="1400" b="0">
-                <a:solidFill>
-                  <a:srgbClr val="3D4757"/>
-                </a:solidFill>
-                <a:latin typeface="微软雅黑"/>
-                <a:ea typeface="微软雅黑"/>
-                <a:cs typeface="微软雅黑"/>
-              </a:rPr>
-              <a:t>抢必走 / YOYO 有票方案页，推荐可立即出票的替代方案</a:t>
-            </a:r>
-          </a:p>
-        </p:txBody>
-      </p:sp>
-      <p:cxnSp>
-        <p:nvCxnSpPr>
-          <p:cNvPr id="9" name="Connector 8"/>
-          <p:cNvCxnSpPr/>
-          <p:nvPr/>
-        </p:nvCxnSpPr>
-        <p:spPr>
-          <a:xfrm>
-            <a:off x="1051560" y="2944368"/>
-            <a:ext cx="0" cy="329184"/>
-          </a:xfrm>
-          <a:prstGeom prst="line">
-            <a:avLst/>
-          </a:prstGeom>
-          <a:ln w="19050">
-            <a:solidFill>
-              <a:srgbClr val="7A8599"/>
-            </a:solidFill>
-          </a:ln>
-        </p:spPr>
-        <p:style>
-          <a:lnRef idx="2">
-            <a:schemeClr val="accent1"/>
-          </a:lnRef>
-          <a:fillRef idx="0">
-            <a:schemeClr val="accent1"/>
-          </a:fillRef>
-          <a:effectRef idx="1">
-            <a:schemeClr val="accent1"/>
-          </a:effectRef>
-          <a:fontRef idx="minor">
-            <a:schemeClr val="tx1"/>
-          </a:fontRef>
-        </p:style>
-      </p:cxnSp>
-      <p:sp>
-        <p:nvSpPr>
-          <p:cNvPr id="10" name="icon-circle"/>
-          <p:cNvSpPr/>
-          <p:nvPr/>
-        </p:nvSpPr>
-        <p:spPr>
-          <a:xfrm>
-            <a:off x="777240" y="3291840"/>
-            <a:ext cx="548640" cy="548640"/>
-          </a:xfrm>
-          <a:prstGeom prst="ellipse">
-            <a:avLst/>
-          </a:prstGeom>
-          <a:solidFill>
-            <a:srgbClr val="7A8599"/>
-          </a:solidFill>
-          <a:ln>
-            <a:noFill/>
-          </a:ln>
-          <a:effectLst/>
-        </p:spPr>
-        <p:style>
-          <a:lnRef idx="1">
-            <a:schemeClr val="accent1"/>
-          </a:lnRef>
-          <a:fillRef idx="3">
-            <a:schemeClr val="accent1"/>
-          </a:fillRef>
-          <a:effectRef idx="2">
-            <a:schemeClr val="accent1"/>
-          </a:effectRef>
-          <a:fontRef idx="minor">
-            <a:schemeClr val="lt1"/>
-          </a:fontRef>
-        </p:style>
-        <p:txBody>
-          <a:bodyPr rtlCol="0" anchor="ctr"/>
-          <a:lstStyle/>
-          <a:p/>
-        </p:txBody>
-      </p:sp>
-      <p:pic>
-        <p:nvPicPr>
-          <p:cNvPr id="11" name="Picture 10" descr="FaUserCheck_w.png"/>
-          <p:cNvPicPr>
-            <a:picLocks noChangeAspect="1"/>
-          </p:cNvPicPr>
-          <p:nvPr/>
-        </p:nvPicPr>
-        <p:blipFill>
-          <a:blip r:embed="rId4"/>
-          <a:stretch>
-            <a:fillRect/>
-          </a:stretch>
-        </p:blipFill>
-        <p:spPr>
-          <a:xfrm>
-            <a:off x="914400" y="3429000"/>
-            <a:ext cx="274320" cy="274320"/>
-          </a:xfrm>
-          <a:prstGeom prst="rect">
-            <a:avLst/>
-          </a:prstGeom>
-        </p:spPr>
-      </p:pic>
-      <p:sp>
-        <p:nvSpPr>
-          <p:cNvPr id="12" name="TextBox 11"/>
-          <p:cNvSpPr txBox="1"/>
-          <p:nvPr/>
-        </p:nvSpPr>
-        <p:spPr>
-          <a:xfrm>
-            <a:off x="1508760" y="3273552"/>
-            <a:ext cx="3931920" cy="594360"/>
-          </a:xfrm>
-          <a:prstGeom prst="rect">
-            <a:avLst/>
-          </a:prstGeom>
-          <a:noFill/>
-        </p:spPr>
-        <p:txBody>
-          <a:bodyPr wrap="square" lIns="0" rIns="0" tIns="0" bIns="0" anchor="ctr">
-            <a:spAutoFit/>
-          </a:bodyPr>
-          <a:lstStyle/>
-          <a:p>
-            <a:pPr algn="l"/>
-            <a:r>
-              <a:rPr sz="1400" b="0">
-                <a:solidFill>
-                  <a:srgbClr val="3D4757"/>
-                </a:solidFill>
-                <a:latin typeface="微软雅黑"/>
-                <a:ea typeface="微软雅黑"/>
-                <a:cs typeface="微软雅黑"/>
-              </a:rPr>
-              <a:t>用户妥协，接受替代方案</a:t>
-            </a:r>
-          </a:p>
-        </p:txBody>
-      </p:sp>
-      <p:cxnSp>
-        <p:nvCxnSpPr>
-          <p:cNvPr id="13" name="Connector 12"/>
-          <p:cNvCxnSpPr/>
-          <p:nvPr/>
-        </p:nvCxnSpPr>
-        <p:spPr>
-          <a:xfrm>
-            <a:off x="1051560" y="3858768"/>
-            <a:ext cx="0" cy="329184"/>
-          </a:xfrm>
-          <a:prstGeom prst="line">
-            <a:avLst/>
-          </a:prstGeom>
-          <a:ln w="19050">
-            <a:solidFill>
-              <a:srgbClr val="7A8599"/>
-            </a:solidFill>
-          </a:ln>
-        </p:spPr>
-        <p:style>
-          <a:lnRef idx="2">
-            <a:schemeClr val="accent1"/>
-          </a:lnRef>
-          <a:fillRef idx="0">
-            <a:schemeClr val="accent1"/>
-          </a:fillRef>
-          <a:effectRef idx="1">
-            <a:schemeClr val="accent1"/>
-          </a:effectRef>
-          <a:fontRef idx="minor">
-            <a:schemeClr val="tx1"/>
-          </a:fontRef>
-        </p:style>
-      </p:cxnSp>
-      <p:sp>
-        <p:nvSpPr>
-          <p:cNvPr id="14" name="icon-circle"/>
-          <p:cNvSpPr/>
-          <p:nvPr/>
-        </p:nvSpPr>
-        <p:spPr>
-          <a:xfrm>
-            <a:off x="777240" y="4206240"/>
-            <a:ext cx="548640" cy="548640"/>
-          </a:xfrm>
-          <a:prstGeom prst="ellipse">
-            <a:avLst/>
-          </a:prstGeom>
-          <a:solidFill>
-            <a:srgbClr val="7A8599"/>
-          </a:solidFill>
-          <a:ln>
-            <a:noFill/>
-          </a:ln>
-          <a:effectLst/>
-        </p:spPr>
-        <p:style>
-          <a:lnRef idx="1">
-            <a:schemeClr val="accent1"/>
-          </a:lnRef>
-          <a:fillRef idx="3">
-            <a:schemeClr val="accent1"/>
-          </a:fillRef>
-          <a:effectRef idx="2">
-            <a:schemeClr val="accent1"/>
-          </a:effectRef>
-          <a:fontRef idx="minor">
-            <a:schemeClr val="lt1"/>
-          </a:fontRef>
-        </p:style>
-        <p:txBody>
-          <a:bodyPr rtlCol="0" anchor="ctr"/>
-          <a:lstStyle/>
-          <a:p/>
-        </p:txBody>
-      </p:sp>
-      <p:pic>
-        <p:nvPicPr>
-          <p:cNvPr id="15" name="Picture 14" descr="FaRotate_w.png"/>
+          <p:cNvPr id="20" name="Picture 19" descr="FaRotate_w.png"/>
           <p:cNvPicPr>
             <a:picLocks noChangeAspect="1"/>
           </p:cNvPicPr>
@@ -11337,8 +11577,8 @@
         </p:blipFill>
         <p:spPr>
           <a:xfrm>
-            <a:off x="914400" y="4343400"/>
-            <a:ext cx="274320" cy="274320"/>
+            <a:off x="891540" y="3863339"/>
+            <a:ext cx="320040" cy="320040"/>
           </a:xfrm>
           <a:prstGeom prst="rect">
             <a:avLst/>
@@ -11347,14 +11587,14 @@
       </p:pic>
       <p:sp>
         <p:nvSpPr>
-          <p:cNvPr id="16" name="TextBox 15"/>
+          <p:cNvPr id="21" name="TextBox 20"/>
           <p:cNvSpPr txBox="1"/>
           <p:nvPr/>
         </p:nvSpPr>
         <p:spPr>
           <a:xfrm>
-            <a:off x="1508760" y="4187952"/>
-            <a:ext cx="3931920" cy="594360"/>
+            <a:off x="1508760" y="3657600"/>
+            <a:ext cx="1874519" cy="731520"/>
           </a:xfrm>
           <a:prstGeom prst="rect">
             <a:avLst/>
@@ -11369,7 +11609,7 @@
           <a:p>
             <a:pPr algn="l"/>
             <a:r>
-              <a:rPr sz="1400" b="0">
+              <a:rPr sz="1500" b="1">
                 <a:solidFill>
                   <a:srgbClr val="3D4757"/>
                 </a:solidFill>
@@ -11384,18 +11624,18 @@
       </p:sp>
       <p:sp>
         <p:nvSpPr>
-          <p:cNvPr id="17" name="Rounded Rectangle 16"/>
+          <p:cNvPr id="22" name="Rounded Rectangle 21"/>
           <p:cNvSpPr/>
           <p:nvPr/>
         </p:nvSpPr>
         <p:spPr>
           <a:xfrm>
-            <a:off x="777240" y="5166360"/>
-            <a:ext cx="4572000" cy="685800"/>
+            <a:off x="731520" y="4983480"/>
+            <a:ext cx="2514600" cy="640080"/>
           </a:xfrm>
           <a:prstGeom prst="roundRect">
             <a:avLst>
-              <a:gd name="adj" fmla="val 6000"/>
+              <a:gd name="adj" fmla="val 30000"/>
             </a:avLst>
           </a:prstGeom>
           <a:solidFill>
@@ -11430,14 +11670,14 @@
       </p:sp>
       <p:sp>
         <p:nvSpPr>
-          <p:cNvPr id="18" name="TextBox 17"/>
+          <p:cNvPr id="23" name="TextBox 22"/>
           <p:cNvSpPr txBox="1"/>
           <p:nvPr/>
         </p:nvSpPr>
         <p:spPr>
           <a:xfrm>
-            <a:off x="914400" y="5166360"/>
-            <a:ext cx="4297680" cy="685800"/>
+            <a:off x="731520" y="4983480"/>
+            <a:ext cx="2514600" cy="640080"/>
           </a:xfrm>
           <a:prstGeom prst="rect">
             <a:avLst/>
@@ -11450,7 +11690,7 @@
           </a:bodyPr>
           <a:lstStyle/>
           <a:p>
-            <a:pPr algn="l"/>
+            <a:pPr algn="ctr"/>
             <a:r>
               <a:rPr sz="1400" b="1">
                 <a:solidFill>
@@ -11460,21 +11700,21 @@
                 <a:ea typeface="微软雅黑"/>
                 <a:cs typeface="微软雅黑"/>
               </a:rPr>
-              <a:t>出票概率【待补充】，用户预期落空，体验较差</a:t>
+              <a:t>出票概率【待补充】</a:t>
             </a:r>
           </a:p>
         </p:txBody>
       </p:sp>
       <p:sp>
         <p:nvSpPr>
-          <p:cNvPr id="19" name="Rounded Rectangle 18"/>
+          <p:cNvPr id="24" name="Rounded Rectangle 23"/>
           <p:cNvSpPr/>
           <p:nvPr/>
         </p:nvSpPr>
         <p:spPr>
           <a:xfrm>
-            <a:off x="6519672" y="1554480"/>
-            <a:ext cx="5212080" cy="4526280"/>
+            <a:off x="3886200" y="2971800"/>
+            <a:ext cx="3063240" cy="3108960"/>
           </a:xfrm>
           <a:prstGeom prst="roundRect">
             <a:avLst>
@@ -11513,14 +11753,14 @@
       </p:sp>
       <p:sp>
         <p:nvSpPr>
-          <p:cNvPr id="20" name="TextBox 19"/>
+          <p:cNvPr id="25" name="TextBox 24"/>
           <p:cNvSpPr txBox="1"/>
           <p:nvPr/>
         </p:nvSpPr>
         <p:spPr>
           <a:xfrm>
-            <a:off x="6839712" y="1737360"/>
-            <a:ext cx="4572000" cy="411480"/>
+            <a:off x="4160520" y="3127248"/>
+            <a:ext cx="2560320" cy="365760"/>
           </a:xfrm>
           <a:prstGeom prst="rect">
             <a:avLst/>
@@ -11535,7 +11775,7 @@
           <a:p>
             <a:pPr algn="l"/>
             <a:r>
-              <a:rPr sz="2000" b="1">
+              <a:rPr sz="1800" b="1">
                 <a:solidFill>
                   <a:srgbClr val="287DFA"/>
                 </a:solidFill>
@@ -11550,14 +11790,14 @@
       </p:sp>
       <p:sp>
         <p:nvSpPr>
-          <p:cNvPr id="21" name="icon-circle"/>
+          <p:cNvPr id="26" name="icon-circle"/>
           <p:cNvSpPr/>
           <p:nvPr/>
         </p:nvSpPr>
         <p:spPr>
           <a:xfrm>
-            <a:off x="6839712" y="2377440"/>
-            <a:ext cx="548640" cy="548640"/>
+            <a:off x="4160520" y="3703320"/>
+            <a:ext cx="640080" cy="640080"/>
           </a:xfrm>
           <a:prstGeom prst="ellipse">
             <a:avLst/>
@@ -11592,283 +11832,7 @@
       </p:sp>
       <p:pic>
         <p:nvPicPr>
-          <p:cNvPr id="22" name="Picture 21" descr="FaListCheck_w.png"/>
-          <p:cNvPicPr>
-            <a:picLocks noChangeAspect="1"/>
-          </p:cNvPicPr>
-          <p:nvPr/>
-        </p:nvPicPr>
-        <p:blipFill>
-          <a:blip r:embed="rId3"/>
-          <a:stretch>
-            <a:fillRect/>
-          </a:stretch>
-        </p:blipFill>
-        <p:spPr>
-          <a:xfrm>
-            <a:off x="6976872" y="2514600"/>
-            <a:ext cx="274320" cy="274320"/>
-          </a:xfrm>
-          <a:prstGeom prst="rect">
-            <a:avLst/>
-          </a:prstGeom>
-        </p:spPr>
-      </p:pic>
-      <p:sp>
-        <p:nvSpPr>
-          <p:cNvPr id="23" name="TextBox 22"/>
-          <p:cNvSpPr txBox="1"/>
-          <p:nvPr/>
-        </p:nvSpPr>
-        <p:spPr>
-          <a:xfrm>
-            <a:off x="7571231" y="2359152"/>
-            <a:ext cx="3931920" cy="594360"/>
-          </a:xfrm>
-          <a:prstGeom prst="rect">
-            <a:avLst/>
-          </a:prstGeom>
-          <a:noFill/>
-        </p:spPr>
-        <p:txBody>
-          <a:bodyPr wrap="square" lIns="0" rIns="0" tIns="0" bIns="0" anchor="ctr">
-            <a:spAutoFit/>
-          </a:bodyPr>
-          <a:lstStyle/>
-          <a:p>
-            <a:pPr algn="l"/>
-            <a:r>
-              <a:rPr sz="1400" b="0">
-                <a:solidFill>
-                  <a:srgbClr val="3D4757"/>
-                </a:solidFill>
-                <a:latin typeface="微软雅黑"/>
-                <a:ea typeface="微软雅黑"/>
-                <a:cs typeface="微软雅黑"/>
-              </a:rPr>
-              <a:t>同样推荐可立即出票的替代方案</a:t>
-            </a:r>
-          </a:p>
-        </p:txBody>
-      </p:sp>
-      <p:cxnSp>
-        <p:nvCxnSpPr>
-          <p:cNvPr id="24" name="Connector 23"/>
-          <p:cNvCxnSpPr/>
-          <p:nvPr/>
-        </p:nvCxnSpPr>
-        <p:spPr>
-          <a:xfrm>
-            <a:off x="7114032" y="2944368"/>
-            <a:ext cx="0" cy="329184"/>
-          </a:xfrm>
-          <a:prstGeom prst="line">
-            <a:avLst/>
-          </a:prstGeom>
-          <a:ln w="19050">
-            <a:solidFill>
-              <a:srgbClr val="287DFA"/>
-            </a:solidFill>
-          </a:ln>
-        </p:spPr>
-        <p:style>
-          <a:lnRef idx="2">
-            <a:schemeClr val="accent1"/>
-          </a:lnRef>
-          <a:fillRef idx="0">
-            <a:schemeClr val="accent1"/>
-          </a:fillRef>
-          <a:effectRef idx="1">
-            <a:schemeClr val="accent1"/>
-          </a:effectRef>
-          <a:fontRef idx="minor">
-            <a:schemeClr val="tx1"/>
-          </a:fontRef>
-        </p:style>
-      </p:cxnSp>
-      <p:sp>
-        <p:nvSpPr>
-          <p:cNvPr id="25" name="icon-circle"/>
-          <p:cNvSpPr/>
-          <p:nvPr/>
-        </p:nvSpPr>
-        <p:spPr>
-          <a:xfrm>
-            <a:off x="6839712" y="3291840"/>
-            <a:ext cx="548640" cy="548640"/>
-          </a:xfrm>
-          <a:prstGeom prst="ellipse">
-            <a:avLst/>
-          </a:prstGeom>
-          <a:solidFill>
-            <a:srgbClr val="287DFA"/>
-          </a:solidFill>
-          <a:ln>
-            <a:noFill/>
-          </a:ln>
-          <a:effectLst/>
-        </p:spPr>
-        <p:style>
-          <a:lnRef idx="1">
-            <a:schemeClr val="accent1"/>
-          </a:lnRef>
-          <a:fillRef idx="3">
-            <a:schemeClr val="accent1"/>
-          </a:fillRef>
-          <a:effectRef idx="2">
-            <a:schemeClr val="accent1"/>
-          </a:effectRef>
-          <a:fontRef idx="minor">
-            <a:schemeClr val="lt1"/>
-          </a:fontRef>
-        </p:style>
-        <p:txBody>
-          <a:bodyPr rtlCol="0" anchor="ctr"/>
-          <a:lstStyle/>
-          <a:p/>
-        </p:txBody>
-      </p:sp>
-      <p:pic>
-        <p:nvPicPr>
-          <p:cNvPr id="26" name="Picture 25" descr="FaUserCheck_w.png"/>
-          <p:cNvPicPr>
-            <a:picLocks noChangeAspect="1"/>
-          </p:cNvPicPr>
-          <p:nvPr/>
-        </p:nvPicPr>
-        <p:blipFill>
-          <a:blip r:embed="rId4"/>
-          <a:stretch>
-            <a:fillRect/>
-          </a:stretch>
-        </p:blipFill>
-        <p:spPr>
-          <a:xfrm>
-            <a:off x="6976872" y="3429000"/>
-            <a:ext cx="274320" cy="274320"/>
-          </a:xfrm>
-          <a:prstGeom prst="rect">
-            <a:avLst/>
-          </a:prstGeom>
-        </p:spPr>
-      </p:pic>
-      <p:sp>
-        <p:nvSpPr>
-          <p:cNvPr id="27" name="TextBox 26"/>
-          <p:cNvSpPr txBox="1"/>
-          <p:nvPr/>
-        </p:nvSpPr>
-        <p:spPr>
-          <a:xfrm>
-            <a:off x="7571231" y="3273552"/>
-            <a:ext cx="3931920" cy="594360"/>
-          </a:xfrm>
-          <a:prstGeom prst="rect">
-            <a:avLst/>
-          </a:prstGeom>
-          <a:noFill/>
-        </p:spPr>
-        <p:txBody>
-          <a:bodyPr wrap="square" lIns="0" rIns="0" tIns="0" bIns="0" anchor="ctr">
-            <a:spAutoFit/>
-          </a:bodyPr>
-          <a:lstStyle/>
-          <a:p>
-            <a:pPr algn="l"/>
-            <a:r>
-              <a:rPr sz="1400" b="0">
-                <a:solidFill>
-                  <a:srgbClr val="3D4757"/>
-                </a:solidFill>
-                <a:latin typeface="微软雅黑"/>
-                <a:ea typeface="微软雅黑"/>
-                <a:cs typeface="微软雅黑"/>
-              </a:rPr>
-              <a:t>支付宝（非黑名单）订单，用户接受方案</a:t>
-            </a:r>
-          </a:p>
-        </p:txBody>
-      </p:sp>
-      <p:cxnSp>
-        <p:nvCxnSpPr>
-          <p:cNvPr id="28" name="Connector 27"/>
-          <p:cNvCxnSpPr/>
-          <p:nvPr/>
-        </p:nvCxnSpPr>
-        <p:spPr>
-          <a:xfrm>
-            <a:off x="7114032" y="3858768"/>
-            <a:ext cx="0" cy="329184"/>
-          </a:xfrm>
-          <a:prstGeom prst="line">
-            <a:avLst/>
-          </a:prstGeom>
-          <a:ln w="19050">
-            <a:solidFill>
-              <a:srgbClr val="287DFA"/>
-            </a:solidFill>
-          </a:ln>
-        </p:spPr>
-        <p:style>
-          <a:lnRef idx="2">
-            <a:schemeClr val="accent1"/>
-          </a:lnRef>
-          <a:fillRef idx="0">
-            <a:schemeClr val="accent1"/>
-          </a:fillRef>
-          <a:effectRef idx="1">
-            <a:schemeClr val="accent1"/>
-          </a:effectRef>
-          <a:fontRef idx="minor">
-            <a:schemeClr val="tx1"/>
-          </a:fontRef>
-        </p:style>
-      </p:cxnSp>
-      <p:sp>
-        <p:nvSpPr>
-          <p:cNvPr id="29" name="icon-circle"/>
-          <p:cNvSpPr/>
-          <p:nvPr/>
-        </p:nvSpPr>
-        <p:spPr>
-          <a:xfrm>
-            <a:off x="6839712" y="4206240"/>
-            <a:ext cx="548640" cy="548640"/>
-          </a:xfrm>
-          <a:prstGeom prst="ellipse">
-            <a:avLst/>
-          </a:prstGeom>
-          <a:solidFill>
-            <a:srgbClr val="287DFA"/>
-          </a:solidFill>
-          <a:ln>
-            <a:noFill/>
-          </a:ln>
-          <a:effectLst/>
-        </p:spPr>
-        <p:style>
-          <a:lnRef idx="1">
-            <a:schemeClr val="accent1"/>
-          </a:lnRef>
-          <a:fillRef idx="3">
-            <a:schemeClr val="accent1"/>
-          </a:fillRef>
-          <a:effectRef idx="2">
-            <a:schemeClr val="accent1"/>
-          </a:effectRef>
-          <a:fontRef idx="minor">
-            <a:schemeClr val="lt1"/>
-          </a:fontRef>
-        </p:style>
-        <p:txBody>
-          <a:bodyPr rtlCol="0" anchor="ctr"/>
-          <a:lstStyle/>
-          <a:p/>
-        </p:txBody>
-      </p:sp>
-      <p:pic>
-        <p:nvPicPr>
-          <p:cNvPr id="30" name="Picture 29" descr="FaTicket_w.png"/>
+          <p:cNvPr id="27" name="Picture 26" descr="FaTicket_w.png"/>
           <p:cNvPicPr>
             <a:picLocks noChangeAspect="1"/>
           </p:cNvPicPr>
@@ -11882,8 +11846,8 @@
         </p:blipFill>
         <p:spPr>
           <a:xfrm>
-            <a:off x="6976872" y="4343400"/>
-            <a:ext cx="274320" cy="274320"/>
+            <a:off x="4320540" y="3863339"/>
+            <a:ext cx="320040" cy="320040"/>
           </a:xfrm>
           <a:prstGeom prst="rect">
             <a:avLst/>
@@ -11892,14 +11856,14 @@
       </p:pic>
       <p:sp>
         <p:nvSpPr>
-          <p:cNvPr id="31" name="TextBox 30"/>
+          <p:cNvPr id="28" name="TextBox 27"/>
           <p:cNvSpPr txBox="1"/>
           <p:nvPr/>
         </p:nvSpPr>
         <p:spPr>
           <a:xfrm>
-            <a:off x="7571231" y="4187952"/>
-            <a:ext cx="3931920" cy="594360"/>
+            <a:off x="4937760" y="3657600"/>
+            <a:ext cx="1874519" cy="731520"/>
           </a:xfrm>
           <a:prstGeom prst="rect">
             <a:avLst/>
@@ -11914,7 +11878,7 @@
           <a:p>
             <a:pPr algn="l"/>
             <a:r>
-              <a:rPr sz="1400" b="0">
+              <a:rPr sz="1500" b="1">
                 <a:solidFill>
                   <a:srgbClr val="3D4757"/>
                 </a:solidFill>
@@ -11929,18 +11893,18 @@
       </p:sp>
       <p:sp>
         <p:nvSpPr>
-          <p:cNvPr id="32" name="Rounded Rectangle 31"/>
+          <p:cNvPr id="29" name="Rounded Rectangle 28"/>
           <p:cNvSpPr/>
           <p:nvPr/>
         </p:nvSpPr>
         <p:spPr>
           <a:xfrm>
-            <a:off x="6839712" y="5166360"/>
-            <a:ext cx="4572000" cy="685800"/>
+            <a:off x="4160520" y="4983480"/>
+            <a:ext cx="2514600" cy="640080"/>
           </a:xfrm>
           <a:prstGeom prst="roundRect">
             <a:avLst>
-              <a:gd name="adj" fmla="val 6000"/>
+              <a:gd name="adj" fmla="val 30000"/>
             </a:avLst>
           </a:prstGeom>
           <a:solidFill>
@@ -11975,14 +11939,14 @@
       </p:sp>
       <p:sp>
         <p:nvSpPr>
-          <p:cNvPr id="33" name="TextBox 32"/>
+          <p:cNvPr id="30" name="TextBox 29"/>
           <p:cNvSpPr txBox="1"/>
           <p:nvPr/>
         </p:nvSpPr>
         <p:spPr>
           <a:xfrm>
-            <a:off x="6976872" y="5166360"/>
-            <a:ext cx="4297680" cy="685800"/>
+            <a:off x="4160520" y="4983480"/>
+            <a:ext cx="2514600" cy="640080"/>
           </a:xfrm>
           <a:prstGeom prst="rect">
             <a:avLst/>
@@ -11995,7 +11959,7 @@
           </a:bodyPr>
           <a:lstStyle/>
           <a:p>
-            <a:pPr algn="l"/>
+            <a:pPr algn="ctr"/>
             <a:r>
               <a:rPr sz="1400" b="1">
                 <a:solidFill>
@@ -12005,51 +11969,145 @@
                 <a:ea typeface="微软雅黑"/>
                 <a:cs typeface="微软雅黑"/>
               </a:rPr>
-              <a:t>上线后的增量【待补】</a:t>
+              <a:t>上线后增量【待补】</a:t>
             </a:r>
           </a:p>
         </p:txBody>
       </p:sp>
-      <p:sp>
-        <p:nvSpPr>
-          <p:cNvPr id="34" name="arrow"/>
-          <p:cNvSpPr/>
-          <p:nvPr/>
-        </p:nvSpPr>
-        <p:spPr>
-          <a:xfrm>
-            <a:off x="5806440" y="3520440"/>
-            <a:ext cx="594360" cy="457200"/>
-          </a:xfrm>
-          <a:prstGeom prst="rightArrow">
-            <a:avLst/>
-          </a:prstGeom>
-          <a:solidFill>
-            <a:srgbClr val="287DFA"/>
-          </a:solidFill>
-          <a:ln>
-            <a:noFill/>
+      <p:pic>
+        <p:nvPicPr>
+          <p:cNvPr id="31" name="真实截图-抢必走" descr="qbz.png"/>
+          <p:cNvPicPr>
+            <a:picLocks noChangeAspect="1"/>
+          </p:cNvPicPr>
+          <p:nvPr/>
+        </p:nvPicPr>
+        <p:blipFill>
+          <a:blip r:embed="rId7"/>
+          <a:stretch>
+            <a:fillRect/>
+          </a:stretch>
+        </p:blipFill>
+        <p:spPr>
+          <a:xfrm>
+            <a:off x="7721193" y="1481328"/>
+            <a:ext cx="1913839" cy="4206240"/>
+          </a:xfrm>
+          <a:prstGeom prst="roundRect">
+            <a:avLst>
+              <a:gd name="adj" fmla="val 6000"/>
+            </a:avLst>
+          </a:prstGeom>
+          <a:ln w="25400">
+            <a:solidFill>
+              <a:srgbClr val="000000"/>
+            </a:solidFill>
           </a:ln>
-          <a:effectLst/>
-        </p:spPr>
-        <p:style>
-          <a:lnRef idx="1">
-            <a:schemeClr val="accent1"/>
-          </a:lnRef>
-          <a:fillRef idx="3">
-            <a:schemeClr val="accent1"/>
-          </a:fillRef>
-          <a:effectRef idx="2">
-            <a:schemeClr val="accent1"/>
-          </a:effectRef>
-          <a:fontRef idx="minor">
-            <a:schemeClr val="lt1"/>
-          </a:fontRef>
-        </p:style>
-        <p:txBody>
-          <a:bodyPr rtlCol="0" anchor="ctr"/>
-          <a:lstStyle/>
-          <a:p/>
+        </p:spPr>
+      </p:pic>
+      <p:sp>
+        <p:nvSpPr>
+          <p:cNvPr id="32" name="TextBox 31"/>
+          <p:cNvSpPr txBox="1"/>
+          <p:nvPr/>
+        </p:nvSpPr>
+        <p:spPr>
+          <a:xfrm>
+            <a:off x="7721193" y="5760720"/>
+            <a:ext cx="1913839" cy="274320"/>
+          </a:xfrm>
+          <a:prstGeom prst="rect">
+            <a:avLst/>
+          </a:prstGeom>
+          <a:noFill/>
+        </p:spPr>
+        <p:txBody>
+          <a:bodyPr wrap="square" lIns="0" rIns="0" tIns="0" bIns="0" anchor="t">
+            <a:spAutoFit/>
+          </a:bodyPr>
+          <a:lstStyle/>
+          <a:p>
+            <a:pPr algn="ctr"/>
+            <a:r>
+              <a:rPr sz="1200" b="1">
+                <a:solidFill>
+                  <a:srgbClr val="3D4757"/>
+                </a:solidFill>
+                <a:latin typeface="微软雅黑"/>
+                <a:ea typeface="微软雅黑"/>
+                <a:cs typeface="微软雅黑"/>
+              </a:rPr>
+              <a:t>抢必走</a:t>
+            </a:r>
+          </a:p>
+        </p:txBody>
+      </p:sp>
+      <p:pic>
+        <p:nvPicPr>
+          <p:cNvPr id="33" name="真实截图-有票方案" descr="yoyo.png"/>
+          <p:cNvPicPr>
+            <a:picLocks noChangeAspect="1"/>
+          </p:cNvPicPr>
+          <p:nvPr/>
+        </p:nvPicPr>
+        <p:blipFill>
+          <a:blip r:embed="rId8"/>
+          <a:stretch>
+            <a:fillRect/>
+          </a:stretch>
+        </p:blipFill>
+        <p:spPr>
+          <a:xfrm>
+            <a:off x="9817912" y="1481328"/>
+            <a:ext cx="1913839" cy="4206240"/>
+          </a:xfrm>
+          <a:prstGeom prst="roundRect">
+            <a:avLst>
+              <a:gd name="adj" fmla="val 6000"/>
+            </a:avLst>
+          </a:prstGeom>
+          <a:ln w="25400">
+            <a:solidFill>
+              <a:srgbClr val="000000"/>
+            </a:solidFill>
+          </a:ln>
+        </p:spPr>
+      </p:pic>
+      <p:sp>
+        <p:nvSpPr>
+          <p:cNvPr id="34" name="TextBox 33"/>
+          <p:cNvSpPr txBox="1"/>
+          <p:nvPr/>
+        </p:nvSpPr>
+        <p:spPr>
+          <a:xfrm>
+            <a:off x="9817912" y="5760720"/>
+            <a:ext cx="1913839" cy="274320"/>
+          </a:xfrm>
+          <a:prstGeom prst="rect">
+            <a:avLst/>
+          </a:prstGeom>
+          <a:noFill/>
+        </p:spPr>
+        <p:txBody>
+          <a:bodyPr wrap="square" lIns="0" rIns="0" tIns="0" bIns="0" anchor="t">
+            <a:spAutoFit/>
+          </a:bodyPr>
+          <a:lstStyle/>
+          <a:p>
+            <a:pPr algn="ctr"/>
+            <a:r>
+              <a:rPr sz="1200" b="1">
+                <a:solidFill>
+                  <a:srgbClr val="3D4757"/>
+                </a:solidFill>
+                <a:latin typeface="微软雅黑"/>
+                <a:ea typeface="微软雅黑"/>
+                <a:cs typeface="微软雅黑"/>
+              </a:rPr>
+              <a:t>有票方案页</a:t>
+            </a:r>
+          </a:p>
         </p:txBody>
       </p:sp>
     </p:spTree>

</xml_diff>

<commit_message>
Rework planning slide as balance diagram and plan table
Co-Authored-By: Claude Opus 5.5 <noreply@anthropic.com>
Claude-Session: https://claude.ai/code/session_011iFrL2Hfizgp6kYckDtNGc
</commit_message>
<xml_diff>
--- a/答辩PPT.pptx
+++ b/答辩PPT.pptx
@@ -1321,28 +1321,59 @@
           <a:lstStyle/>
           <a:p>
             <a:r>
-              <a:t>说到接下来的规划，我对抢票业务的理解是：它要同时平衡三件事，票量、收益和体验。前面讲到的几个需求，其实都是在这三者之间找平衡点：既要让更多订单出票，也要让用户在过程中有好的感受，同时守住平台的收益。接下来我也想围绕这三点继续推进。</a:t>
+              <a:t>说到接下来的规划，我对抢票业务的理解是：它要同时平衡三件事，票量、收益和体验。</a:t>
             </a:r>
           </a:p>
-          <a:p/>
           <a:p>
             <a:r>
-              <a:t>票量上，我想重点补齐小程序的出票。小程序受风控影响比较大，没法走代付出票，需要跳到客服对话付款的订单，只能通过支付召回来完成，付款这一步的流失比较多。接下来想从两个方向推进：一是在小程序内部优化付款方式，比如接入微信合单支付，在稳住体验的前提下提升小程序的票量；二是做场景转换，把订单引导到成功率更高的路径上，比如召回用户回到 App 下单，或者引导用户在小程序里完成信用付授权。</a:t>
+              <a:t>前面讲到的几个需求，其实都是在这三者之间找平衡点：既要让更多订单出票，也要让用户在过程中有好的感受，同时守住平台的收益。</a:t>
             </a:r>
           </a:p>
-          <a:p/>
           <a:p>
             <a:r>
-              <a:t>收益上，我希望在合规的前提下，重新梳理各个场景里用户比较需要的服务，在目前线上的流程和环节中，补上一些收益场景的空白。同时，提高收益的前提是稳住用户体验，我目前正在探索的一个方向，就是外呼场景下的策略优化。</a:t>
+              <a:t>接下来我也想围绕这三点继续推进。</a:t>
             </a:r>
           </a:p>
-          <a:p/>
           <a:p>
             <a:r>
-              <a:t>AI 上，我希望从 AI native 的产品走进业务，把 AI 能力真正落到抢票业务的链路里。我一直在思考和探索的，是如何找出那些用传统方法不太好解决的痛点，引入 AI，并用我们平台用户最容易接受的方式呈现，提供他们当下最需要的能力，让 AI 真正服务于票量、收益和体验三者之间的平衡。</a:t>
+              <a:t>票量上，我想重点补齐小程序的支付策略。</a:t>
             </a:r>
           </a:p>
-          <a:p/>
+          <a:p>
+            <a:r>
+              <a:t>小程序受风控影响比较大，没法走代付出票，需要跳到客服对话付款的订单，只能通过支付召回来完成，付款这一步的流失比较多。</a:t>
+            </a:r>
+          </a:p>
+          <a:p>
+            <a:r>
+              <a:t>接下来想从两个方向推进：一是在小程序内部优化付款方式，比如接入微信合单支付，在稳住体验的前提下提升小程序的票量；二是做场景转换，把订单引导到成功率更高的路径上，比如召回用户回到 App 下单，或者引导用户在小程序里完成信用付授权。</a:t>
+            </a:r>
+          </a:p>
+          <a:p>
+            <a:r>
+              <a:t>收益上，我希望在合规的前提下，重新梳理各个场景里用户比较需要的服务，在目前线上的流程和环节中，补上一些收益场景的空白。</a:t>
+            </a:r>
+          </a:p>
+          <a:p>
+            <a:r>
+              <a:t>同时，提高收益的前提是稳住用户体验，我目前正在探索的一个方向，就是外呼场景下的策略优化。</a:t>
+            </a:r>
+          </a:p>
+          <a:p>
+            <a:r>
+              <a:t>AI 上，我希望从 AI native 的产品走进业务，把 AI 能力真正落到抢票业务的链路里。</a:t>
+            </a:r>
+          </a:p>
+          <a:p>
+            <a:r>
+              <a:t>我已经在自己的工作中把Ai运用固定为一套较为固定的流程，比如用飞书命令行工具，直接读取文档、群聊记录，行程我个人的工作日报和提醒，进行材料的整理和数据核对，并且用claudecode写了一个skill，能够辅助进行需求验收。</a:t>
+            </a:r>
+          </a:p>
+          <a:p>
+            <a:r>
+              <a:t>我一直在思考和探索的，还有如何找出那些用传统方法不太好解决的痛点，引入 AI，并用我们平台用户最容易接受的方式呈现，提供他们当下最需要的能力，让 AI 真正服务于票量、收益和体验三者之间的平衡。</a:t>
+            </a:r>
+          </a:p>
           <a:p>
             <a:r>
               <a:t>以上就是我的分享，谢谢各位老师。</a:t>
@@ -16073,34 +16104,30 @@
                 <a:ea typeface="微软雅黑"/>
                 <a:cs typeface="微软雅黑"/>
               </a:rPr>
-              <a:t>抢票业务要同时平衡三件事，AI 服务于这三者的平衡</a:t>
+              <a:t>抢票业务要同时平衡票量、收益与体验，AI 服务于三者的平衡</a:t>
             </a:r>
           </a:p>
         </p:txBody>
       </p:sp>
       <p:sp>
         <p:nvSpPr>
-          <p:cNvPr id="4" name="Rounded Rectangle 3"/>
+          <p:cNvPr id="4" name="Isosceles Triangle 3"/>
           <p:cNvSpPr/>
           <p:nvPr/>
         </p:nvSpPr>
         <p:spPr>
           <a:xfrm>
-            <a:off x="457200" y="1508760"/>
-            <a:ext cx="3630168" cy="2697480"/>
-          </a:xfrm>
-          <a:prstGeom prst="roundRect">
-            <a:avLst>
-              <a:gd name="adj" fmla="val 6000"/>
-            </a:avLst>
+            <a:off x="868680" y="1965960"/>
+            <a:ext cx="3017520" cy="2743200"/>
+          </a:xfrm>
+          <a:prstGeom prst="triangle">
+            <a:avLst/>
           </a:prstGeom>
           <a:solidFill>
-            <a:srgbClr val="F5F9FF"/>
+            <a:srgbClr val="EAF2FF"/>
           </a:solidFill>
-          <a:ln w="12700">
-            <a:solidFill>
-              <a:srgbClr val="D3E2FB"/>
-            </a:solidFill>
+          <a:ln>
+            <a:noFill/>
           </a:ln>
           <a:effectLst/>
         </p:spPr>
@@ -16132,8 +16159,8 @@
         </p:nvSpPr>
         <p:spPr>
           <a:xfrm>
-            <a:off x="731520" y="1737360"/>
-            <a:ext cx="731520" cy="731520"/>
+            <a:off x="1993392" y="1399032"/>
+            <a:ext cx="768096" cy="768096"/>
           </a:xfrm>
           <a:prstGeom prst="ellipse">
             <a:avLst/>
@@ -16168,7 +16195,7 @@
       </p:sp>
       <p:pic>
         <p:nvPicPr>
-          <p:cNvPr id="6" name="Picture 5" descr="FaMobileScreenButton_w.png"/>
+          <p:cNvPr id="6" name="Picture 5" descr="FaTicket_w.png"/>
           <p:cNvPicPr>
             <a:picLocks noChangeAspect="1"/>
           </p:cNvPicPr>
@@ -16182,8 +16209,8 @@
         </p:blipFill>
         <p:spPr>
           <a:xfrm>
-            <a:off x="914400" y="1920240"/>
-            <a:ext cx="365760" cy="365760"/>
+            <a:off x="2185416" y="1591056"/>
+            <a:ext cx="384048" cy="384048"/>
           </a:xfrm>
           <a:prstGeom prst="rect">
             <a:avLst/>
@@ -16198,8 +16225,8 @@
         </p:nvSpPr>
         <p:spPr>
           <a:xfrm>
-            <a:off x="1645920" y="1737360"/>
-            <a:ext cx="2286000" cy="411480"/>
+            <a:off x="1828800" y="2194560"/>
+            <a:ext cx="1097280" cy="320040"/>
           </a:xfrm>
           <a:prstGeom prst="rect">
             <a:avLst/>
@@ -16212,11 +16239,11 @@
           </a:bodyPr>
           <a:lstStyle/>
           <a:p>
-            <a:pPr algn="l"/>
+            <a:pPr algn="ctr"/>
             <a:r>
-              <a:rPr sz="2000" b="1">
+              <a:rPr sz="1500" b="1">
                 <a:solidFill>
-                  <a:srgbClr val="287DFA"/>
+                  <a:srgbClr val="15315E"/>
                 </a:solidFill>
                 <a:latin typeface="微软雅黑"/>
                 <a:ea typeface="微软雅黑"/>
@@ -16229,14 +16256,80 @@
       </p:sp>
       <p:sp>
         <p:nvSpPr>
-          <p:cNvPr id="8" name="TextBox 7"/>
+          <p:cNvPr id="8" name="icon-circle"/>
+          <p:cNvSpPr/>
+          <p:nvPr/>
+        </p:nvSpPr>
+        <p:spPr>
+          <a:xfrm>
+            <a:off x="484632" y="4325112"/>
+            <a:ext cx="768096" cy="768096"/>
+          </a:xfrm>
+          <a:prstGeom prst="ellipse">
+            <a:avLst/>
+          </a:prstGeom>
+          <a:solidFill>
+            <a:srgbClr val="287DFA"/>
+          </a:solidFill>
+          <a:ln>
+            <a:noFill/>
+          </a:ln>
+          <a:effectLst/>
+        </p:spPr>
+        <p:style>
+          <a:lnRef idx="1">
+            <a:schemeClr val="accent1"/>
+          </a:lnRef>
+          <a:fillRef idx="3">
+            <a:schemeClr val="accent1"/>
+          </a:fillRef>
+          <a:effectRef idx="2">
+            <a:schemeClr val="accent1"/>
+          </a:effectRef>
+          <a:fontRef idx="minor">
+            <a:schemeClr val="lt1"/>
+          </a:fontRef>
+        </p:style>
+        <p:txBody>
+          <a:bodyPr rtlCol="0" anchor="ctr"/>
+          <a:lstStyle/>
+          <a:p/>
+        </p:txBody>
+      </p:sp>
+      <p:pic>
+        <p:nvPicPr>
+          <p:cNvPr id="9" name="Picture 8" descr="FaCoins_w.png"/>
+          <p:cNvPicPr>
+            <a:picLocks noChangeAspect="1"/>
+          </p:cNvPicPr>
+          <p:nvPr/>
+        </p:nvPicPr>
+        <p:blipFill>
+          <a:blip r:embed="rId4"/>
+          <a:stretch>
+            <a:fillRect/>
+          </a:stretch>
+        </p:blipFill>
+        <p:spPr>
+          <a:xfrm>
+            <a:off x="676656" y="4517136"/>
+            <a:ext cx="384048" cy="384048"/>
+          </a:xfrm>
+          <a:prstGeom prst="rect">
+            <a:avLst/>
+          </a:prstGeom>
+        </p:spPr>
+      </p:pic>
+      <p:sp>
+        <p:nvSpPr>
+          <p:cNvPr id="10" name="TextBox 9"/>
           <p:cNvSpPr txBox="1"/>
           <p:nvPr/>
         </p:nvSpPr>
         <p:spPr>
           <a:xfrm>
-            <a:off x="1645920" y="2148840"/>
-            <a:ext cx="2331720" cy="365760"/>
+            <a:off x="320040" y="5120640"/>
+            <a:ext cx="1097280" cy="320040"/>
           </a:xfrm>
           <a:prstGeom prst="rect">
             <a:avLst/>
@@ -16249,7 +16342,213 @@
           </a:bodyPr>
           <a:lstStyle/>
           <a:p>
-            <a:pPr algn="l"/>
+            <a:pPr algn="ctr"/>
+            <a:r>
+              <a:rPr sz="1500" b="1">
+                <a:solidFill>
+                  <a:srgbClr val="15315E"/>
+                </a:solidFill>
+                <a:latin typeface="微软雅黑"/>
+                <a:ea typeface="微软雅黑"/>
+                <a:cs typeface="微软雅黑"/>
+              </a:rPr>
+              <a:t>收益</a:t>
+            </a:r>
+          </a:p>
+        </p:txBody>
+      </p:sp>
+      <p:sp>
+        <p:nvSpPr>
+          <p:cNvPr id="11" name="icon-circle"/>
+          <p:cNvSpPr/>
+          <p:nvPr/>
+        </p:nvSpPr>
+        <p:spPr>
+          <a:xfrm>
+            <a:off x="3502152" y="4325112"/>
+            <a:ext cx="768096" cy="768096"/>
+          </a:xfrm>
+          <a:prstGeom prst="ellipse">
+            <a:avLst/>
+          </a:prstGeom>
+          <a:solidFill>
+            <a:srgbClr val="287DFA"/>
+          </a:solidFill>
+          <a:ln>
+            <a:noFill/>
+          </a:ln>
+          <a:effectLst/>
+        </p:spPr>
+        <p:style>
+          <a:lnRef idx="1">
+            <a:schemeClr val="accent1"/>
+          </a:lnRef>
+          <a:fillRef idx="3">
+            <a:schemeClr val="accent1"/>
+          </a:fillRef>
+          <a:effectRef idx="2">
+            <a:schemeClr val="accent1"/>
+          </a:effectRef>
+          <a:fontRef idx="minor">
+            <a:schemeClr val="lt1"/>
+          </a:fontRef>
+        </p:style>
+        <p:txBody>
+          <a:bodyPr rtlCol="0" anchor="ctr"/>
+          <a:lstStyle/>
+          <a:p/>
+        </p:txBody>
+      </p:sp>
+      <p:pic>
+        <p:nvPicPr>
+          <p:cNvPr id="12" name="Picture 11" descr="FaFaceSmile_w.png"/>
+          <p:cNvPicPr>
+            <a:picLocks noChangeAspect="1"/>
+          </p:cNvPicPr>
+          <p:nvPr/>
+        </p:nvPicPr>
+        <p:blipFill>
+          <a:blip r:embed="rId5"/>
+          <a:stretch>
+            <a:fillRect/>
+          </a:stretch>
+        </p:blipFill>
+        <p:spPr>
+          <a:xfrm>
+            <a:off x="3694176" y="4517136"/>
+            <a:ext cx="384048" cy="384048"/>
+          </a:xfrm>
+          <a:prstGeom prst="rect">
+            <a:avLst/>
+          </a:prstGeom>
+        </p:spPr>
+      </p:pic>
+      <p:sp>
+        <p:nvSpPr>
+          <p:cNvPr id="13" name="TextBox 12"/>
+          <p:cNvSpPr txBox="1"/>
+          <p:nvPr/>
+        </p:nvSpPr>
+        <p:spPr>
+          <a:xfrm>
+            <a:off x="3337560" y="5120640"/>
+            <a:ext cx="1097280" cy="320040"/>
+          </a:xfrm>
+          <a:prstGeom prst="rect">
+            <a:avLst/>
+          </a:prstGeom>
+          <a:noFill/>
+        </p:spPr>
+        <p:txBody>
+          <a:bodyPr wrap="square" lIns="0" rIns="0" tIns="0" bIns="0" anchor="t">
+            <a:spAutoFit/>
+          </a:bodyPr>
+          <a:lstStyle/>
+          <a:p>
+            <a:pPr algn="ctr"/>
+            <a:r>
+              <a:rPr sz="1500" b="1">
+                <a:solidFill>
+                  <a:srgbClr val="15315E"/>
+                </a:solidFill>
+                <a:latin typeface="微软雅黑"/>
+                <a:ea typeface="微软雅黑"/>
+                <a:cs typeface="微软雅黑"/>
+              </a:rPr>
+              <a:t>体验</a:t>
+            </a:r>
+          </a:p>
+        </p:txBody>
+      </p:sp>
+      <p:sp>
+        <p:nvSpPr>
+          <p:cNvPr id="14" name="icon-circle"/>
+          <p:cNvSpPr/>
+          <p:nvPr/>
+        </p:nvSpPr>
+        <p:spPr>
+          <a:xfrm>
+            <a:off x="1920240" y="3154680"/>
+            <a:ext cx="914400" cy="914400"/>
+          </a:xfrm>
+          <a:prstGeom prst="ellipse">
+            <a:avLst/>
+          </a:prstGeom>
+          <a:solidFill>
+            <a:srgbClr val="15315E"/>
+          </a:solidFill>
+          <a:ln>
+            <a:noFill/>
+          </a:ln>
+          <a:effectLst/>
+        </p:spPr>
+        <p:style>
+          <a:lnRef idx="1">
+            <a:schemeClr val="accent1"/>
+          </a:lnRef>
+          <a:fillRef idx="3">
+            <a:schemeClr val="accent1"/>
+          </a:fillRef>
+          <a:effectRef idx="2">
+            <a:schemeClr val="accent1"/>
+          </a:effectRef>
+          <a:fontRef idx="minor">
+            <a:schemeClr val="lt1"/>
+          </a:fontRef>
+        </p:style>
+        <p:txBody>
+          <a:bodyPr rtlCol="0" anchor="ctr"/>
+          <a:lstStyle/>
+          <a:p/>
+        </p:txBody>
+      </p:sp>
+      <p:pic>
+        <p:nvPicPr>
+          <p:cNvPr id="15" name="Picture 14" descr="FaBrain_w.png"/>
+          <p:cNvPicPr>
+            <a:picLocks noChangeAspect="1"/>
+          </p:cNvPicPr>
+          <p:nvPr/>
+        </p:nvPicPr>
+        <p:blipFill>
+          <a:blip r:embed="rId6"/>
+          <a:stretch>
+            <a:fillRect/>
+          </a:stretch>
+        </p:blipFill>
+        <p:spPr>
+          <a:xfrm>
+            <a:off x="2148840" y="3383280"/>
+            <a:ext cx="457200" cy="457200"/>
+          </a:xfrm>
+          <a:prstGeom prst="rect">
+            <a:avLst/>
+          </a:prstGeom>
+        </p:spPr>
+      </p:pic>
+      <p:sp>
+        <p:nvSpPr>
+          <p:cNvPr id="16" name="TextBox 15"/>
+          <p:cNvSpPr txBox="1"/>
+          <p:nvPr/>
+        </p:nvSpPr>
+        <p:spPr>
+          <a:xfrm>
+            <a:off x="1828800" y="4096512"/>
+            <a:ext cx="1097280" cy="320040"/>
+          </a:xfrm>
+          <a:prstGeom prst="rect">
+            <a:avLst/>
+          </a:prstGeom>
+          <a:noFill/>
+        </p:spPr>
+        <p:txBody>
+          <a:bodyPr wrap="square" lIns="0" rIns="0" tIns="0" bIns="0" anchor="t">
+            <a:spAutoFit/>
+          </a:bodyPr>
+          <a:lstStyle/>
+          <a:p>
+            <a:pPr algn="ctr"/>
             <a:r>
               <a:rPr sz="1400" b="1">
                 <a:solidFill>
@@ -16259,144 +16558,436 @@
                 <a:ea typeface="微软雅黑"/>
                 <a:cs typeface="微软雅黑"/>
               </a:rPr>
-              <a:t>补齐小程序的出票</a:t>
+              <a:t>AI</a:t>
             </a:r>
           </a:p>
         </p:txBody>
       </p:sp>
-      <p:sp>
-        <p:nvSpPr>
-          <p:cNvPr id="9" name="TextBox 8"/>
-          <p:cNvSpPr txBox="1"/>
-          <p:nvPr/>
-        </p:nvSpPr>
-        <p:spPr>
-          <a:xfrm>
-            <a:off x="731520" y="2743200"/>
-            <a:ext cx="3108960" cy="1828800"/>
-          </a:xfrm>
-          <a:prstGeom prst="rect">
-            <a:avLst/>
-          </a:prstGeom>
-          <a:noFill/>
-        </p:spPr>
-        <p:txBody>
-          <a:bodyPr wrap="square" lIns="0" rIns="0" tIns="0" bIns="0" anchor="t">
-            <a:spAutoFit/>
-          </a:bodyPr>
-          <a:lstStyle/>
-          <a:p>
-            <a:pPr algn="l"/>
-            <a:r>
-              <a:rPr sz="1000" b="0">
-                <a:solidFill>
-                  <a:srgbClr val="287DFA"/>
-                </a:solidFill>
-                <a:latin typeface="微软雅黑"/>
-                <a:ea typeface="微软雅黑"/>
-                <a:cs typeface="微软雅黑"/>
-              </a:rPr>
-              <a:t>●  </a:t>
-            </a:r>
-            <a:r>
-              <a:rPr sz="1400" b="0">
-                <a:solidFill>
-                  <a:srgbClr val="3D4757"/>
-                </a:solidFill>
-                <a:latin typeface="微软雅黑"/>
-                <a:ea typeface="微软雅黑"/>
-                <a:cs typeface="微软雅黑"/>
-              </a:rPr>
-              <a:t>小程序内优化付款：如接入微信合单支付</a:t>
-            </a:r>
-          </a:p>
-          <a:p>
-            <a:pPr algn="l">
-              <a:spcBef>
-                <a:spcPts val="800"/>
-              </a:spcBef>
-            </a:pPr>
-            <a:r>
-              <a:rPr sz="1000" b="0">
-                <a:solidFill>
-                  <a:srgbClr val="287DFA"/>
-                </a:solidFill>
-                <a:latin typeface="微软雅黑"/>
-                <a:ea typeface="微软雅黑"/>
-                <a:cs typeface="微软雅黑"/>
-              </a:rPr>
-              <a:t>●  </a:t>
-            </a:r>
-            <a:r>
-              <a:rPr sz="1400" b="0">
-                <a:solidFill>
-                  <a:srgbClr val="3D4757"/>
-                </a:solidFill>
-                <a:latin typeface="微软雅黑"/>
-                <a:ea typeface="微软雅黑"/>
-                <a:cs typeface="微软雅黑"/>
-              </a:rPr>
-              <a:t>场景转换：召回用户回到 App、引导小程序内信用付授权</a:t>
-            </a:r>
-          </a:p>
-        </p:txBody>
-      </p:sp>
-      <p:sp>
-        <p:nvSpPr>
-          <p:cNvPr id="10" name="Rounded Rectangle 9"/>
+      <p:graphicFrame>
+        <p:nvGraphicFramePr>
+          <p:cNvPr id="17" name="Table 16"/>
+          <p:cNvGraphicFramePr>
+            <a:graphicFrameLocks noGrp="1"/>
+          </p:cNvGraphicFramePr>
+          <p:nvPr/>
+        </p:nvGraphicFramePr>
+        <p:xfrm>
+          <a:off x="4526280" y="1554480"/>
+          <a:ext cx="7205472" cy="4526280"/>
+        </p:xfrm>
+        <a:graphic>
+          <a:graphicData uri="http://schemas.openxmlformats.org/drawingml/2006/table">
+            <a:tbl>
+              <a:tblPr firstRow="1" bandRow="1">
+                <a:tableStyleId>{5C22544A-7EE6-4342-B048-85BDC9FD1C3A}</a:tableStyleId>
+              </a:tblPr>
+              <a:tblGrid>
+                <a:gridCol w="1234440"/>
+                <a:gridCol w="2697480"/>
+                <a:gridCol w="3273552"/>
+              </a:tblGrid>
+              <a:tr h="457200">
+                <a:tc>
+                  <a:txBody>
+                    <a:bodyPr wrap="square"/>
+                    <a:lstStyle/>
+                    <a:p>
+                      <a:r>
+                        <a:rPr sz="1500" b="1">
+                          <a:solidFill>
+                            <a:srgbClr val="FFFFFF"/>
+                          </a:solidFill>
+                          <a:latin typeface="微软雅黑"/>
+                          <a:ea typeface="微软雅黑"/>
+                          <a:cs typeface="微软雅黑"/>
+                        </a:rPr>
+                        <a:t>方向</a:t>
+                      </a:r>
+                    </a:p>
+                  </a:txBody>
+                  <a:tcPr anchor="ctr" marL="137160" marR="91440">
+                    <a:solidFill>
+                      <a:srgbClr val="287DFA"/>
+                    </a:solidFill>
+                  </a:tcPr>
+                </a:tc>
+                <a:tc>
+                  <a:txBody>
+                    <a:bodyPr wrap="square"/>
+                    <a:lstStyle/>
+                    <a:p>
+                      <a:r>
+                        <a:rPr sz="1500" b="1">
+                          <a:solidFill>
+                            <a:srgbClr val="FFFFFF"/>
+                          </a:solidFill>
+                          <a:latin typeface="微软雅黑"/>
+                          <a:ea typeface="微软雅黑"/>
+                          <a:cs typeface="微软雅黑"/>
+                        </a:rPr>
+                        <a:t>现状</a:t>
+                      </a:r>
+                    </a:p>
+                  </a:txBody>
+                  <a:tcPr anchor="ctr" marL="137160" marR="91440">
+                    <a:solidFill>
+                      <a:srgbClr val="287DFA"/>
+                    </a:solidFill>
+                  </a:tcPr>
+                </a:tc>
+                <a:tc>
+                  <a:txBody>
+                    <a:bodyPr wrap="square"/>
+                    <a:lstStyle/>
+                    <a:p>
+                      <a:r>
+                        <a:rPr sz="1500" b="1">
+                          <a:solidFill>
+                            <a:srgbClr val="FFFFFF"/>
+                          </a:solidFill>
+                          <a:latin typeface="微软雅黑"/>
+                          <a:ea typeface="微软雅黑"/>
+                          <a:cs typeface="微软雅黑"/>
+                        </a:rPr>
+                        <a:t>接下来做什么</a:t>
+                      </a:r>
+                    </a:p>
+                  </a:txBody>
+                  <a:tcPr anchor="ctr" marL="137160" marR="91440">
+                    <a:solidFill>
+                      <a:srgbClr val="287DFA"/>
+                    </a:solidFill>
+                  </a:tcPr>
+                </a:tc>
+              </a:tr>
+              <a:tr h="1097280">
+                <a:tc>
+                  <a:txBody>
+                    <a:bodyPr wrap="square"/>
+                    <a:lstStyle/>
+                    <a:p>
+                      <a:r>
+                        <a:rPr sz="1500" b="1">
+                          <a:solidFill>
+                            <a:srgbClr val="15315E"/>
+                          </a:solidFill>
+                          <a:latin typeface="微软雅黑"/>
+                          <a:ea typeface="微软雅黑"/>
+                          <a:cs typeface="微软雅黑"/>
+                        </a:rPr>
+                        <a:t>票量</a:t>
+                      </a:r>
+                    </a:p>
+                  </a:txBody>
+                  <a:tcPr anchor="ctr" marL="566928" marR="91440">
+                    <a:solidFill>
+                      <a:srgbClr val="EAF2FF"/>
+                    </a:solidFill>
+                  </a:tcPr>
+                </a:tc>
+                <a:tc>
+                  <a:txBody>
+                    <a:bodyPr wrap="square"/>
+                    <a:lstStyle/>
+                    <a:p>
+                      <a:r>
+                        <a:rPr sz="1300" b="0">
+                          <a:solidFill>
+                            <a:srgbClr val="3D4757"/>
+                          </a:solidFill>
+                          <a:latin typeface="微软雅黑"/>
+                          <a:ea typeface="微软雅黑"/>
+                          <a:cs typeface="微软雅黑"/>
+                        </a:rPr>
+                        <a:t>小程序受风控影响无法代付，跳客服付款，流失多</a:t>
+                      </a:r>
+                    </a:p>
+                  </a:txBody>
+                  <a:tcPr anchor="ctr" marL="137160" marR="91440">
+                    <a:solidFill>
+                      <a:srgbClr val="FFFFFF"/>
+                    </a:solidFill>
+                  </a:tcPr>
+                </a:tc>
+                <a:tc>
+                  <a:txBody>
+                    <a:bodyPr wrap="square"/>
+                    <a:lstStyle/>
+                    <a:p>
+                      <a:r>
+                        <a:rPr sz="1300" b="1">
+                          <a:solidFill>
+                            <a:srgbClr val="287DFA"/>
+                          </a:solidFill>
+                          <a:latin typeface="微软雅黑"/>
+                          <a:ea typeface="微软雅黑"/>
+                          <a:cs typeface="微软雅黑"/>
+                        </a:rPr>
+                        <a:t>小程序内：接入微信合单支付</a:t>
+                      </a:r>
+                    </a:p>
+                    <a:p>
+                      <a:pPr>
+                        <a:spcBef>
+                          <a:spcPts val="400"/>
+                        </a:spcBef>
+                      </a:pPr>
+                      <a:r>
+                        <a:rPr sz="1300" b="1">
+                          <a:solidFill>
+                            <a:srgbClr val="287DFA"/>
+                          </a:solidFill>
+                          <a:latin typeface="微软雅黑"/>
+                          <a:ea typeface="微软雅黑"/>
+                          <a:cs typeface="微软雅黑"/>
+                        </a:rPr>
+                        <a:t>场景转换：召回 App、引导信用付授权</a:t>
+                      </a:r>
+                    </a:p>
+                  </a:txBody>
+                  <a:tcPr anchor="ctr" marL="137160" marR="91440">
+                    <a:solidFill>
+                      <a:srgbClr val="F5F9FF"/>
+                    </a:solidFill>
+                  </a:tcPr>
+                </a:tc>
+              </a:tr>
+              <a:tr h="960120">
+                <a:tc>
+                  <a:txBody>
+                    <a:bodyPr wrap="square"/>
+                    <a:lstStyle/>
+                    <a:p>
+                      <a:r>
+                        <a:rPr sz="1500" b="1">
+                          <a:solidFill>
+                            <a:srgbClr val="15315E"/>
+                          </a:solidFill>
+                          <a:latin typeface="微软雅黑"/>
+                          <a:ea typeface="微软雅黑"/>
+                          <a:cs typeface="微软雅黑"/>
+                        </a:rPr>
+                        <a:t>收益</a:t>
+                      </a:r>
+                    </a:p>
+                  </a:txBody>
+                  <a:tcPr anchor="ctr" marL="566928" marR="91440">
+                    <a:solidFill>
+                      <a:srgbClr val="EAF2FF"/>
+                    </a:solidFill>
+                  </a:tcPr>
+                </a:tc>
+                <a:tc>
+                  <a:txBody>
+                    <a:bodyPr wrap="square"/>
+                    <a:lstStyle/>
+                    <a:p>
+                      <a:r>
+                        <a:rPr sz="1300" b="0">
+                          <a:solidFill>
+                            <a:srgbClr val="3D4757"/>
+                          </a:solidFill>
+                          <a:latin typeface="微软雅黑"/>
+                          <a:ea typeface="微软雅黑"/>
+                          <a:cs typeface="微软雅黑"/>
+                        </a:rPr>
+                        <a:t>合规要求下，部分环节存在收益场景空白</a:t>
+                      </a:r>
+                    </a:p>
+                  </a:txBody>
+                  <a:tcPr anchor="ctr" marL="137160" marR="91440">
+                    <a:solidFill>
+                      <a:srgbClr val="FFFFFF"/>
+                    </a:solidFill>
+                  </a:tcPr>
+                </a:tc>
+                <a:tc>
+                  <a:txBody>
+                    <a:bodyPr wrap="square"/>
+                    <a:lstStyle/>
+                    <a:p>
+                      <a:r>
+                        <a:rPr sz="1300" b="1">
+                          <a:solidFill>
+                            <a:srgbClr val="287DFA"/>
+                          </a:solidFill>
+                          <a:latin typeface="微软雅黑"/>
+                          <a:ea typeface="微软雅黑"/>
+                          <a:cs typeface="微软雅黑"/>
+                        </a:rPr>
+                        <a:t>梳理用户需要的服务，补齐收益场景</a:t>
+                      </a:r>
+                    </a:p>
+                  </a:txBody>
+                  <a:tcPr anchor="ctr" marL="137160" marR="91440">
+                    <a:solidFill>
+                      <a:srgbClr val="F5F9FF"/>
+                    </a:solidFill>
+                  </a:tcPr>
+                </a:tc>
+              </a:tr>
+              <a:tr h="868680">
+                <a:tc>
+                  <a:txBody>
+                    <a:bodyPr wrap="square"/>
+                    <a:lstStyle/>
+                    <a:p>
+                      <a:r>
+                        <a:rPr sz="1500" b="1">
+                          <a:solidFill>
+                            <a:srgbClr val="15315E"/>
+                          </a:solidFill>
+                          <a:latin typeface="微软雅黑"/>
+                          <a:ea typeface="微软雅黑"/>
+                          <a:cs typeface="微软雅黑"/>
+                        </a:rPr>
+                        <a:t>体验</a:t>
+                      </a:r>
+                    </a:p>
+                  </a:txBody>
+                  <a:tcPr anchor="ctr" marL="566928" marR="91440">
+                    <a:solidFill>
+                      <a:srgbClr val="EAF2FF"/>
+                    </a:solidFill>
+                  </a:tcPr>
+                </a:tc>
+                <a:tc>
+                  <a:txBody>
+                    <a:bodyPr wrap="square"/>
+                    <a:lstStyle/>
+                    <a:p>
+                      <a:r>
+                        <a:rPr sz="1300" b="0">
+                          <a:solidFill>
+                            <a:srgbClr val="3D4757"/>
+                          </a:solidFill>
+                          <a:latin typeface="微软雅黑"/>
+                          <a:ea typeface="微软雅黑"/>
+                          <a:cs typeface="微软雅黑"/>
+                        </a:rPr>
+                        <a:t>提高收益的前提，是稳住用户体验</a:t>
+                      </a:r>
+                    </a:p>
+                  </a:txBody>
+                  <a:tcPr anchor="ctr" marL="137160" marR="91440">
+                    <a:solidFill>
+                      <a:srgbClr val="FFFFFF"/>
+                    </a:solidFill>
+                  </a:tcPr>
+                </a:tc>
+                <a:tc>
+                  <a:txBody>
+                    <a:bodyPr wrap="square"/>
+                    <a:lstStyle/>
+                    <a:p>
+                      <a:r>
+                        <a:rPr sz="1300" b="1">
+                          <a:solidFill>
+                            <a:srgbClr val="287DFA"/>
+                          </a:solidFill>
+                          <a:latin typeface="微软雅黑"/>
+                          <a:ea typeface="微软雅黑"/>
+                          <a:cs typeface="微软雅黑"/>
+                        </a:rPr>
+                        <a:t>外呼场景的策略优化</a:t>
+                      </a:r>
+                    </a:p>
+                  </a:txBody>
+                  <a:tcPr anchor="ctr" marL="137160" marR="91440">
+                    <a:solidFill>
+                      <a:srgbClr val="F5F9FF"/>
+                    </a:solidFill>
+                  </a:tcPr>
+                </a:tc>
+              </a:tr>
+              <a:tr h="1143000">
+                <a:tc>
+                  <a:txBody>
+                    <a:bodyPr wrap="square"/>
+                    <a:lstStyle/>
+                    <a:p>
+                      <a:r>
+                        <a:rPr sz="1500" b="1">
+                          <a:solidFill>
+                            <a:srgbClr val="15315E"/>
+                          </a:solidFill>
+                          <a:latin typeface="微软雅黑"/>
+                          <a:ea typeface="微软雅黑"/>
+                          <a:cs typeface="微软雅黑"/>
+                        </a:rPr>
+                        <a:t>AI</a:t>
+                      </a:r>
+                    </a:p>
+                  </a:txBody>
+                  <a:tcPr anchor="ctr" marL="566928" marR="91440">
+                    <a:solidFill>
+                      <a:srgbClr val="EAF2FF"/>
+                    </a:solidFill>
+                  </a:tcPr>
+                </a:tc>
+                <a:tc>
+                  <a:txBody>
+                    <a:bodyPr wrap="square"/>
+                    <a:lstStyle/>
+                    <a:p>
+                      <a:r>
+                        <a:rPr sz="1300" b="0">
+                          <a:solidFill>
+                            <a:srgbClr val="3D4757"/>
+                          </a:solidFill>
+                          <a:latin typeface="微软雅黑"/>
+                          <a:ea typeface="微软雅黑"/>
+                          <a:cs typeface="微软雅黑"/>
+                        </a:rPr>
+                        <a:t>已固化进个人工作流：飞书 CLI、Claude Code Skill</a:t>
+                      </a:r>
+                    </a:p>
+                  </a:txBody>
+                  <a:tcPr anchor="ctr" marL="137160" marR="91440">
+                    <a:solidFill>
+                      <a:srgbClr val="FFFFFF"/>
+                    </a:solidFill>
+                  </a:tcPr>
+                </a:tc>
+                <a:tc>
+                  <a:txBody>
+                    <a:bodyPr wrap="square"/>
+                    <a:lstStyle/>
+                    <a:p>
+                      <a:r>
+                        <a:rPr sz="1300" b="1">
+                          <a:solidFill>
+                            <a:srgbClr val="287DFA"/>
+                          </a:solidFill>
+                          <a:latin typeface="微软雅黑"/>
+                          <a:ea typeface="微软雅黑"/>
+                          <a:cs typeface="微软雅黑"/>
+                        </a:rPr>
+                        <a:t>找到传统方法难解决的痛点，用平台用户最易接受的方式落地</a:t>
+                      </a:r>
+                    </a:p>
+                  </a:txBody>
+                  <a:tcPr anchor="ctr" marL="137160" marR="91440">
+                    <a:solidFill>
+                      <a:srgbClr val="F5F9FF"/>
+                    </a:solidFill>
+                  </a:tcPr>
+                </a:tc>
+              </a:tr>
+            </a:tbl>
+          </a:graphicData>
+        </a:graphic>
+      </p:graphicFrame>
+      <p:sp>
+        <p:nvSpPr>
+          <p:cNvPr id="18" name="icon-circle"/>
           <p:cNvSpPr/>
           <p:nvPr/>
         </p:nvSpPr>
         <p:spPr>
           <a:xfrm>
-            <a:off x="4279392" y="1508760"/>
-            <a:ext cx="3630168" cy="2697480"/>
-          </a:xfrm>
-          <a:prstGeom prst="roundRect">
-            <a:avLst>
-              <a:gd name="adj" fmla="val 6000"/>
-            </a:avLst>
-          </a:prstGeom>
-          <a:solidFill>
-            <a:srgbClr val="F5F9FF"/>
-          </a:solidFill>
-          <a:ln w="12700">
-            <a:solidFill>
-              <a:srgbClr val="D3E2FB"/>
-            </a:solidFill>
-          </a:ln>
-          <a:effectLst/>
-        </p:spPr>
-        <p:style>
-          <a:lnRef idx="1">
-            <a:schemeClr val="accent1"/>
-          </a:lnRef>
-          <a:fillRef idx="3">
-            <a:schemeClr val="accent1"/>
-          </a:fillRef>
-          <a:effectRef idx="2">
-            <a:schemeClr val="accent1"/>
-          </a:effectRef>
-          <a:fontRef idx="minor">
-            <a:schemeClr val="lt1"/>
-          </a:fontRef>
-        </p:style>
-        <p:txBody>
-          <a:bodyPr rtlCol="0" anchor="ctr"/>
-          <a:lstStyle/>
-          <a:p/>
-        </p:txBody>
-      </p:sp>
-      <p:sp>
-        <p:nvSpPr>
-          <p:cNvPr id="11" name="icon-circle"/>
-          <p:cNvSpPr/>
-          <p:nvPr/>
-        </p:nvSpPr>
-        <p:spPr>
-          <a:xfrm>
-            <a:off x="4553712" y="1737360"/>
-            <a:ext cx="731520" cy="731520"/>
+            <a:off x="4636008" y="2368296"/>
+            <a:ext cx="384048" cy="384048"/>
           </a:xfrm>
           <a:prstGeom prst="ellipse">
             <a:avLst/>
@@ -16431,7 +17022,73 @@
       </p:sp>
       <p:pic>
         <p:nvPicPr>
-          <p:cNvPr id="12" name="Picture 11" descr="FaCoins_w.png"/>
+          <p:cNvPr id="19" name="Picture 18" descr="FaTicket_w.png"/>
+          <p:cNvPicPr>
+            <a:picLocks noChangeAspect="1"/>
+          </p:cNvPicPr>
+          <p:nvPr/>
+        </p:nvPicPr>
+        <p:blipFill>
+          <a:blip r:embed="rId3"/>
+          <a:stretch>
+            <a:fillRect/>
+          </a:stretch>
+        </p:blipFill>
+        <p:spPr>
+          <a:xfrm>
+            <a:off x="4732020" y="2464308"/>
+            <a:ext cx="192024" cy="192024"/>
+          </a:xfrm>
+          <a:prstGeom prst="rect">
+            <a:avLst/>
+          </a:prstGeom>
+        </p:spPr>
+      </p:pic>
+      <p:sp>
+        <p:nvSpPr>
+          <p:cNvPr id="20" name="icon-circle"/>
+          <p:cNvSpPr/>
+          <p:nvPr/>
+        </p:nvSpPr>
+        <p:spPr>
+          <a:xfrm>
+            <a:off x="4636008" y="3396996"/>
+            <a:ext cx="384048" cy="384048"/>
+          </a:xfrm>
+          <a:prstGeom prst="ellipse">
+            <a:avLst/>
+          </a:prstGeom>
+          <a:solidFill>
+            <a:srgbClr val="287DFA"/>
+          </a:solidFill>
+          <a:ln>
+            <a:noFill/>
+          </a:ln>
+          <a:effectLst/>
+        </p:spPr>
+        <p:style>
+          <a:lnRef idx="1">
+            <a:schemeClr val="accent1"/>
+          </a:lnRef>
+          <a:fillRef idx="3">
+            <a:schemeClr val="accent1"/>
+          </a:fillRef>
+          <a:effectRef idx="2">
+            <a:schemeClr val="accent1"/>
+          </a:effectRef>
+          <a:fontRef idx="minor">
+            <a:schemeClr val="lt1"/>
+          </a:fontRef>
+        </p:style>
+        <p:txBody>
+          <a:bodyPr rtlCol="0" anchor="ctr"/>
+          <a:lstStyle/>
+          <a:p/>
+        </p:txBody>
+      </p:sp>
+      <p:pic>
+        <p:nvPicPr>
+          <p:cNvPr id="21" name="Picture 20" descr="FaCoins_w.png"/>
           <p:cNvPicPr>
             <a:picLocks noChangeAspect="1"/>
           </p:cNvPicPr>
@@ -16445,8 +17102,8 @@
         </p:blipFill>
         <p:spPr>
           <a:xfrm>
-            <a:off x="4736592" y="1920240"/>
-            <a:ext cx="365760" cy="365760"/>
+            <a:off x="4732020" y="3493008"/>
+            <a:ext cx="192024" cy="192024"/>
           </a:xfrm>
           <a:prstGeom prst="rect">
             <a:avLst/>
@@ -16455,182 +17112,14 @@
       </p:pic>
       <p:sp>
         <p:nvSpPr>
-          <p:cNvPr id="13" name="TextBox 12"/>
-          <p:cNvSpPr txBox="1"/>
-          <p:nvPr/>
-        </p:nvSpPr>
-        <p:spPr>
-          <a:xfrm>
-            <a:off x="5468112" y="1737360"/>
-            <a:ext cx="2286000" cy="411480"/>
-          </a:xfrm>
-          <a:prstGeom prst="rect">
-            <a:avLst/>
-          </a:prstGeom>
-          <a:noFill/>
-        </p:spPr>
-        <p:txBody>
-          <a:bodyPr wrap="square" lIns="0" rIns="0" tIns="0" bIns="0" anchor="t">
-            <a:spAutoFit/>
-          </a:bodyPr>
-          <a:lstStyle/>
-          <a:p>
-            <a:pPr algn="l"/>
-            <a:r>
-              <a:rPr sz="2000" b="1">
-                <a:solidFill>
-                  <a:srgbClr val="287DFA"/>
-                </a:solidFill>
-                <a:latin typeface="微软雅黑"/>
-                <a:ea typeface="微软雅黑"/>
-                <a:cs typeface="微软雅黑"/>
-              </a:rPr>
-              <a:t>收益</a:t>
-            </a:r>
-          </a:p>
-        </p:txBody>
-      </p:sp>
-      <p:sp>
-        <p:nvSpPr>
-          <p:cNvPr id="14" name="TextBox 13"/>
-          <p:cNvSpPr txBox="1"/>
-          <p:nvPr/>
-        </p:nvSpPr>
-        <p:spPr>
-          <a:xfrm>
-            <a:off x="5468112" y="2148840"/>
-            <a:ext cx="2331720" cy="365760"/>
-          </a:xfrm>
-          <a:prstGeom prst="rect">
-            <a:avLst/>
-          </a:prstGeom>
-          <a:noFill/>
-        </p:spPr>
-        <p:txBody>
-          <a:bodyPr wrap="square" lIns="0" rIns="0" tIns="0" bIns="0" anchor="t">
-            <a:spAutoFit/>
-          </a:bodyPr>
-          <a:lstStyle/>
-          <a:p>
-            <a:pPr algn="l"/>
-            <a:r>
-              <a:rPr sz="1400" b="1">
-                <a:solidFill>
-                  <a:srgbClr val="15315E"/>
-                </a:solidFill>
-                <a:latin typeface="微软雅黑"/>
-                <a:ea typeface="微软雅黑"/>
-                <a:cs typeface="微软雅黑"/>
-              </a:rPr>
-              <a:t>补上收益场景的空白</a:t>
-            </a:r>
-          </a:p>
-        </p:txBody>
-      </p:sp>
-      <p:sp>
-        <p:nvSpPr>
-          <p:cNvPr id="15" name="TextBox 14"/>
-          <p:cNvSpPr txBox="1"/>
-          <p:nvPr/>
-        </p:nvSpPr>
-        <p:spPr>
-          <a:xfrm>
-            <a:off x="4553712" y="2743200"/>
-            <a:ext cx="3108960" cy="1828800"/>
-          </a:xfrm>
-          <a:prstGeom prst="rect">
-            <a:avLst/>
-          </a:prstGeom>
-          <a:noFill/>
-        </p:spPr>
-        <p:txBody>
-          <a:bodyPr wrap="square" lIns="0" rIns="0" tIns="0" bIns="0" anchor="t">
-            <a:spAutoFit/>
-          </a:bodyPr>
-          <a:lstStyle/>
-          <a:p>
-            <a:pPr algn="l"/>
-            <a:r>
-              <a:rPr sz="1000" b="0">
-                <a:solidFill>
-                  <a:srgbClr val="287DFA"/>
-                </a:solidFill>
-                <a:latin typeface="微软雅黑"/>
-                <a:ea typeface="微软雅黑"/>
-                <a:cs typeface="微软雅黑"/>
-              </a:rPr>
-              <a:t>●  </a:t>
-            </a:r>
-            <a:r>
-              <a:rPr sz="1400" b="0">
-                <a:solidFill>
-                  <a:srgbClr val="3D4757"/>
-                </a:solidFill>
-                <a:latin typeface="微软雅黑"/>
-                <a:ea typeface="微软雅黑"/>
-                <a:cs typeface="微软雅黑"/>
-              </a:rPr>
-              <a:t>在合规前提下，重新梳理各场景里用户比较需要的服务</a:t>
-            </a:r>
-          </a:p>
-        </p:txBody>
-      </p:sp>
-      <p:sp>
-        <p:nvSpPr>
-          <p:cNvPr id="16" name="Rounded Rectangle 15"/>
+          <p:cNvPr id="22" name="icon-circle"/>
           <p:cNvSpPr/>
           <p:nvPr/>
         </p:nvSpPr>
         <p:spPr>
           <a:xfrm>
-            <a:off x="8101583" y="1508760"/>
-            <a:ext cx="3630168" cy="2697480"/>
-          </a:xfrm>
-          <a:prstGeom prst="roundRect">
-            <a:avLst>
-              <a:gd name="adj" fmla="val 6000"/>
-            </a:avLst>
-          </a:prstGeom>
-          <a:solidFill>
-            <a:srgbClr val="F5F9FF"/>
-          </a:solidFill>
-          <a:ln w="12700">
-            <a:solidFill>
-              <a:srgbClr val="D3E2FB"/>
-            </a:solidFill>
-          </a:ln>
-          <a:effectLst/>
-        </p:spPr>
-        <p:style>
-          <a:lnRef idx="1">
-            <a:schemeClr val="accent1"/>
-          </a:lnRef>
-          <a:fillRef idx="3">
-            <a:schemeClr val="accent1"/>
-          </a:fillRef>
-          <a:effectRef idx="2">
-            <a:schemeClr val="accent1"/>
-          </a:effectRef>
-          <a:fontRef idx="minor">
-            <a:schemeClr val="lt1"/>
-          </a:fontRef>
-        </p:style>
-        <p:txBody>
-          <a:bodyPr rtlCol="0" anchor="ctr"/>
-          <a:lstStyle/>
-          <a:p/>
-        </p:txBody>
-      </p:sp>
-      <p:sp>
-        <p:nvSpPr>
-          <p:cNvPr id="17" name="icon-circle"/>
-          <p:cNvSpPr/>
-          <p:nvPr/>
-        </p:nvSpPr>
-        <p:spPr>
-          <a:xfrm>
-            <a:off x="8375904" y="1737360"/>
-            <a:ext cx="731520" cy="731520"/>
+            <a:off x="4636008" y="4311396"/>
+            <a:ext cx="384048" cy="384048"/>
           </a:xfrm>
           <a:prstGeom prst="ellipse">
             <a:avLst/>
@@ -16665,7 +17154,7 @@
       </p:sp>
       <p:pic>
         <p:nvPicPr>
-          <p:cNvPr id="18" name="Picture 17" descr="FaFaceSmile_w.png"/>
+          <p:cNvPr id="23" name="Picture 22" descr="FaFaceSmile_w.png"/>
           <p:cNvPicPr>
             <a:picLocks noChangeAspect="1"/>
           </p:cNvPicPr>
@@ -16679,8 +17168,8 @@
         </p:blipFill>
         <p:spPr>
           <a:xfrm>
-            <a:off x="8558784" y="1920240"/>
-            <a:ext cx="365760" cy="365760"/>
+            <a:off x="4732020" y="4407408"/>
+            <a:ext cx="192024" cy="192024"/>
           </a:xfrm>
           <a:prstGeom prst="rect">
             <a:avLst/>
@@ -16689,144 +17178,20 @@
       </p:pic>
       <p:sp>
         <p:nvSpPr>
-          <p:cNvPr id="19" name="TextBox 18"/>
-          <p:cNvSpPr txBox="1"/>
-          <p:nvPr/>
-        </p:nvSpPr>
-        <p:spPr>
-          <a:xfrm>
-            <a:off x="9290304" y="1737360"/>
-            <a:ext cx="2286000" cy="411480"/>
-          </a:xfrm>
-          <a:prstGeom prst="rect">
-            <a:avLst/>
-          </a:prstGeom>
-          <a:noFill/>
-        </p:spPr>
-        <p:txBody>
-          <a:bodyPr wrap="square" lIns="0" rIns="0" tIns="0" bIns="0" anchor="t">
-            <a:spAutoFit/>
-          </a:bodyPr>
-          <a:lstStyle/>
-          <a:p>
-            <a:pPr algn="l"/>
-            <a:r>
-              <a:rPr sz="2000" b="1">
-                <a:solidFill>
-                  <a:srgbClr val="287DFA"/>
-                </a:solidFill>
-                <a:latin typeface="微软雅黑"/>
-                <a:ea typeface="微软雅黑"/>
-                <a:cs typeface="微软雅黑"/>
-              </a:rPr>
-              <a:t>体验</a:t>
-            </a:r>
-          </a:p>
-        </p:txBody>
-      </p:sp>
-      <p:sp>
-        <p:nvSpPr>
-          <p:cNvPr id="20" name="TextBox 19"/>
-          <p:cNvSpPr txBox="1"/>
-          <p:nvPr/>
-        </p:nvSpPr>
-        <p:spPr>
-          <a:xfrm>
-            <a:off x="9290304" y="2148840"/>
-            <a:ext cx="2331720" cy="365760"/>
-          </a:xfrm>
-          <a:prstGeom prst="rect">
-            <a:avLst/>
-          </a:prstGeom>
-          <a:noFill/>
-        </p:spPr>
-        <p:txBody>
-          <a:bodyPr wrap="square" lIns="0" rIns="0" tIns="0" bIns="0" anchor="t">
-            <a:spAutoFit/>
-          </a:bodyPr>
-          <a:lstStyle/>
-          <a:p>
-            <a:pPr algn="l"/>
-            <a:r>
-              <a:rPr sz="1400" b="1">
-                <a:solidFill>
-                  <a:srgbClr val="15315E"/>
-                </a:solidFill>
-                <a:latin typeface="微软雅黑"/>
-                <a:ea typeface="微软雅黑"/>
-                <a:cs typeface="微软雅黑"/>
-              </a:rPr>
-              <a:t>提高收益的前提是稳住体验</a:t>
-            </a:r>
-          </a:p>
-        </p:txBody>
-      </p:sp>
-      <p:sp>
-        <p:nvSpPr>
-          <p:cNvPr id="21" name="TextBox 20"/>
-          <p:cNvSpPr txBox="1"/>
-          <p:nvPr/>
-        </p:nvSpPr>
-        <p:spPr>
-          <a:xfrm>
-            <a:off x="8375904" y="2743200"/>
-            <a:ext cx="3108960" cy="1828800"/>
-          </a:xfrm>
-          <a:prstGeom prst="rect">
-            <a:avLst/>
-          </a:prstGeom>
-          <a:noFill/>
-        </p:spPr>
-        <p:txBody>
-          <a:bodyPr wrap="square" lIns="0" rIns="0" tIns="0" bIns="0" anchor="t">
-            <a:spAutoFit/>
-          </a:bodyPr>
-          <a:lstStyle/>
-          <a:p>
-            <a:pPr algn="l"/>
-            <a:r>
-              <a:rPr sz="1000" b="0">
-                <a:solidFill>
-                  <a:srgbClr val="287DFA"/>
-                </a:solidFill>
-                <a:latin typeface="微软雅黑"/>
-                <a:ea typeface="微软雅黑"/>
-                <a:cs typeface="微软雅黑"/>
-              </a:rPr>
-              <a:t>●  </a:t>
-            </a:r>
-            <a:r>
-              <a:rPr sz="1400" b="0">
-                <a:solidFill>
-                  <a:srgbClr val="3D4757"/>
-                </a:solidFill>
-                <a:latin typeface="微软雅黑"/>
-                <a:ea typeface="微软雅黑"/>
-                <a:cs typeface="微软雅黑"/>
-              </a:rPr>
-              <a:t>正在探索：外呼场景下的策略优化</a:t>
-            </a:r>
-          </a:p>
-        </p:txBody>
-      </p:sp>
-      <p:sp>
-        <p:nvSpPr>
-          <p:cNvPr id="22" name="Rounded Rectangle 21"/>
+          <p:cNvPr id="24" name="icon-circle"/>
           <p:cNvSpPr/>
           <p:nvPr/>
         </p:nvSpPr>
         <p:spPr>
           <a:xfrm>
-            <a:off x="457200" y="4434840"/>
-            <a:ext cx="11274552" cy="1645920"/>
-          </a:xfrm>
-          <a:prstGeom prst="roundRect">
-            <a:avLst>
-              <a:gd name="adj" fmla="val 6000"/>
-            </a:avLst>
+            <a:off x="4636008" y="5317236"/>
+            <a:ext cx="384048" cy="384048"/>
+          </a:xfrm>
+          <a:prstGeom prst="ellipse">
+            <a:avLst/>
           </a:prstGeom>
           <a:solidFill>
-            <a:srgbClr val="287DFA"/>
+            <a:srgbClr val="15315E"/>
           </a:solidFill>
           <a:ln>
             <a:noFill/>
@@ -16853,51 +17218,9 @@
           <a:p/>
         </p:txBody>
       </p:sp>
-      <p:sp>
-        <p:nvSpPr>
-          <p:cNvPr id="23" name="icon-circle"/>
-          <p:cNvSpPr/>
-          <p:nvPr/>
-        </p:nvSpPr>
-        <p:spPr>
-          <a:xfrm>
-            <a:off x="777240" y="4846320"/>
-            <a:ext cx="822960" cy="822960"/>
-          </a:xfrm>
-          <a:prstGeom prst="ellipse">
-            <a:avLst/>
-          </a:prstGeom>
-          <a:solidFill>
-            <a:srgbClr val="1F6AE0"/>
-          </a:solidFill>
-          <a:ln>
-            <a:noFill/>
-          </a:ln>
-          <a:effectLst/>
-        </p:spPr>
-        <p:style>
-          <a:lnRef idx="1">
-            <a:schemeClr val="accent1"/>
-          </a:lnRef>
-          <a:fillRef idx="3">
-            <a:schemeClr val="accent1"/>
-          </a:fillRef>
-          <a:effectRef idx="2">
-            <a:schemeClr val="accent1"/>
-          </a:effectRef>
-          <a:fontRef idx="minor">
-            <a:schemeClr val="lt1"/>
-          </a:fontRef>
-        </p:style>
-        <p:txBody>
-          <a:bodyPr rtlCol="0" anchor="ctr"/>
-          <a:lstStyle/>
-          <a:p/>
-        </p:txBody>
-      </p:sp>
       <p:pic>
         <p:nvPicPr>
-          <p:cNvPr id="24" name="Picture 23" descr="FaBrain_w.png"/>
+          <p:cNvPr id="25" name="Picture 24" descr="FaBrain_w.png"/>
           <p:cNvPicPr>
             <a:picLocks noChangeAspect="1"/>
           </p:cNvPicPr>
@@ -16911,80 +17234,14 @@
         </p:blipFill>
         <p:spPr>
           <a:xfrm>
-            <a:off x="982980" y="5052059"/>
-            <a:ext cx="411480" cy="411480"/>
+            <a:off x="4732020" y="5413248"/>
+            <a:ext cx="192024" cy="192024"/>
           </a:xfrm>
           <a:prstGeom prst="rect">
             <a:avLst/>
           </a:prstGeom>
         </p:spPr>
       </p:pic>
-      <p:sp>
-        <p:nvSpPr>
-          <p:cNvPr id="25" name="TextBox 24"/>
-          <p:cNvSpPr txBox="1"/>
-          <p:nvPr/>
-        </p:nvSpPr>
-        <p:spPr>
-          <a:xfrm>
-            <a:off x="1874519" y="4434840"/>
-            <a:ext cx="9601200" cy="1645920"/>
-          </a:xfrm>
-          <a:prstGeom prst="rect">
-            <a:avLst/>
-          </a:prstGeom>
-          <a:noFill/>
-        </p:spPr>
-        <p:txBody>
-          <a:bodyPr wrap="square" lIns="0" rIns="0" tIns="0" bIns="0" anchor="ctr">
-            <a:spAutoFit/>
-          </a:bodyPr>
-          <a:lstStyle/>
-          <a:p>
-            <a:pPr algn="l"/>
-            <a:r>
-              <a:rPr sz="1800" b="1">
-                <a:solidFill>
-                  <a:srgbClr val="FFFFFF"/>
-                </a:solidFill>
-                <a:latin typeface="微软雅黑"/>
-                <a:ea typeface="微软雅黑"/>
-                <a:cs typeface="微软雅黑"/>
-              </a:rPr>
-              <a:t>AI</a:t>
-            </a:r>
-            <a:r>
-              <a:rPr sz="1600" b="1">
-                <a:solidFill>
-                  <a:srgbClr val="D6E6FF"/>
-                </a:solidFill>
-                <a:latin typeface="微软雅黑"/>
-                <a:ea typeface="微软雅黑"/>
-                <a:cs typeface="微软雅黑"/>
-              </a:rPr>
-              <a:t>　从 AI native 走进业务</a:t>
-            </a:r>
-          </a:p>
-          <a:p>
-            <a:pPr algn="l">
-              <a:spcBef>
-                <a:spcPts val="800"/>
-              </a:spcBef>
-            </a:pPr>
-            <a:r>
-              <a:rPr sz="1600" b="0">
-                <a:solidFill>
-                  <a:srgbClr val="FFFFFF"/>
-                </a:solidFill>
-                <a:latin typeface="微软雅黑"/>
-                <a:ea typeface="微软雅黑"/>
-                <a:cs typeface="微软雅黑"/>
-              </a:rPr>
-              <a:t>沿抢票链路找到传统方法不好解决的痛点，用我们平台用户最容易接受的方式呈现，提供他们当下最需要的能力，让 AI 服务于票量、收益和体验的平衡</a:t>
-            </a:r>
-          </a:p>
-        </p:txBody>
-      </p:sp>
     </p:spTree>
   </p:cSld>
   <p:clrMapOvr>

</xml_diff>

<commit_message>
Rework reflection slide around AI-in-business principles
Co-Authored-By: Claude Opus 5.5 <noreply@anthropic.com>
Claude-Session: https://claude.ai/code/session_011iFrL2Hfizgp6kYckDtNGc
</commit_message>
<xml_diff>
--- a/答辩PPT.pptx
+++ b/答辩PPT.pptx
@@ -1245,13 +1245,32 @@
           <a:lstStyle/>
           <a:p>
             <a:r>
-              <a:t>回看这几个月，两条主线给我的收获不太一样。在火车票 Agent 上，我做的更多是模型侧的质量工作，离业务结果比较远；到了抢票业务，我开始直接对票量负责，也逐渐学会从业务指标倒推要做什么。</a:t>
+              <a:t>回看这几个月，两条主线给我的收获不太一样。</a:t>
             </a:r>
           </a:p>
-          <a:p/>
           <a:p>
             <a:r>
-              <a:t>这也让我对 AI 产品有了更具体的理解。在小红书时，模型本身就是产品，我的工作是拓展它的能力边界、限制它的行为边界，衡量的是模型表现得好不好。到了携程，AI 是服务业务的手段：边界由业务来定，比如什么问题属于火车、什么不属于；形态要贴合用户的习惯，二期把对话改成直接操作列表页后，票量明显提升；最终衡量的是票量这样的业务结果。</a:t>
+              <a:t>在火车票 Agent 上，我做的更多是模型侧的质量工作，离业务结果比较远；到了抢票业务，我开始直接对票量负责，也逐渐学会从业务指标倒推要做什么。</a:t>
+            </a:r>
+          </a:p>
+          <a:p>
+            <a:r>
+              <a:t>这也让我对 AI 产品有了更具体的理解。</a:t>
+            </a:r>
+          </a:p>
+          <a:p>
+            <a:r>
+              <a:t>在小红书时，模型本身就是产品，衡量的是模型表现得好不好。</a:t>
+            </a:r>
+          </a:p>
+          <a:p>
+            <a:r>
+              <a:t>到了携程，AI 是服务业务的手段：边界由业务来定，形态要贴合用户的习惯，例如火车agent二期把对话改成直接操作列表页后，这种更符合用户原有行为链路的做法使得票量明显提升；最终衡量的是票量这样的业务结果。</a:t>
+            </a:r>
+          </a:p>
+          <a:p>
+            <a:r>
+              <a:t>所以相比于AInative的产品，在探索AI+业务的时候，我始终应该先四骄傲业务需要它解决什么、用户习惯怎么用。</a:t>
             </a:r>
           </a:p>
         </p:txBody>
@@ -15129,7 +15148,7 @@
                 <a:latin typeface="微软雅黑" panose="020B0503020204020204" pitchFamily="34" charset="-122"/>
                 <a:ea typeface="微软雅黑" panose="020B0503020204020204" pitchFamily="34" charset="-122"/>
               </a:rPr>
-              <a:t>3、未来规划 · 从 AI native 到 AI × 业务</a:t>
+              <a:t>3、思考与未来规划 · 从 AI native 到 AI × 业务</a:t>
             </a:r>
             <a:endParaRPr lang="zh-CN" altLang="en-US" sz="2400" b="1" dirty="0">
               <a:solidFill>
@@ -15187,7 +15206,7 @@
         <p:spPr>
           <a:xfrm>
             <a:off x="457200" y="1508760"/>
-            <a:ext cx="5239512" cy="960120"/>
+            <a:ext cx="5239512" cy="914400"/>
           </a:xfrm>
           <a:prstGeom prst="roundRect">
             <a:avLst>
@@ -15232,7 +15251,7 @@
         </p:nvSpPr>
         <p:spPr>
           <a:xfrm>
-            <a:off x="685800" y="1664208"/>
+            <a:off x="685800" y="1645920"/>
             <a:ext cx="640080" cy="640080"/>
           </a:xfrm>
           <a:prstGeom prst="ellipse">
@@ -15282,7 +15301,7 @@
         </p:blipFill>
         <p:spPr>
           <a:xfrm>
-            <a:off x="845820" y="1824228"/>
+            <a:off x="845820" y="1805940"/>
             <a:ext cx="320040" cy="320040"/>
           </a:xfrm>
           <a:prstGeom prst="rect">
@@ -15299,7 +15318,7 @@
         <p:spPr>
           <a:xfrm>
             <a:off x="1508760" y="1508760"/>
-            <a:ext cx="4069080" cy="960120"/>
+            <a:ext cx="4069080" cy="914400"/>
           </a:xfrm>
           <a:prstGeom prst="rect">
             <a:avLst/>
@@ -15354,7 +15373,7 @@
         <p:spPr>
           <a:xfrm>
             <a:off x="6492240" y="1508760"/>
-            <a:ext cx="5239512" cy="960120"/>
+            <a:ext cx="5239512" cy="914400"/>
           </a:xfrm>
           <a:prstGeom prst="roundRect">
             <a:avLst>
@@ -15399,7 +15418,7 @@
         </p:nvSpPr>
         <p:spPr>
           <a:xfrm>
-            <a:off x="6720840" y="1664208"/>
+            <a:off x="6720840" y="1645920"/>
             <a:ext cx="640080" cy="640080"/>
           </a:xfrm>
           <a:prstGeom prst="ellipse">
@@ -15449,7 +15468,7 @@
         </p:blipFill>
         <p:spPr>
           <a:xfrm>
-            <a:off x="6880859" y="1824228"/>
+            <a:off x="6880859" y="1805940"/>
             <a:ext cx="320040" cy="320040"/>
           </a:xfrm>
           <a:prstGeom prst="rect">
@@ -15466,7 +15485,7 @@
         <p:spPr>
           <a:xfrm>
             <a:off x="7543800" y="1508760"/>
-            <a:ext cx="4069080" cy="960120"/>
+            <a:ext cx="4069080" cy="914400"/>
           </a:xfrm>
           <a:prstGeom prst="rect">
             <a:avLst/>
@@ -15520,7 +15539,7 @@
         </p:nvSpPr>
         <p:spPr>
           <a:xfrm>
-            <a:off x="5806440" y="1828800"/>
+            <a:off x="5806440" y="1801368"/>
             <a:ext cx="457200" cy="329184"/>
           </a:xfrm>
           <a:prstGeom prst="rightArrow">
@@ -15554,329 +15573,76 @@
           <a:p/>
         </p:txBody>
       </p:sp>
-      <p:graphicFrame>
-        <p:nvGraphicFramePr>
-          <p:cNvPr id="13" name="Table 12"/>
-          <p:cNvGraphicFramePr>
-            <a:graphicFrameLocks noGrp="1"/>
-          </p:cNvGraphicFramePr>
-          <p:nvPr/>
-        </p:nvGraphicFramePr>
-        <p:xfrm>
-          <a:off x="457200" y="2697480"/>
-          <a:ext cx="11274552" cy="2560320"/>
-        </p:xfrm>
-        <a:graphic>
-          <a:graphicData uri="http://schemas.openxmlformats.org/drawingml/2006/table">
-            <a:tbl>
-              <a:tblPr firstRow="1" bandRow="1">
-                <a:tableStyleId>{5C22544A-7EE6-4342-B048-85BDC9FD1C3A}</a:tableStyleId>
-              </a:tblPr>
-              <a:tblGrid>
-                <a:gridCol w="2011680"/>
-                <a:gridCol w="4206240"/>
-                <a:gridCol w="5056632"/>
-              </a:tblGrid>
-              <a:tr h="640080">
-                <a:tc>
-                  <a:txBody>
-                    <a:bodyPr/>
-                    <a:lstStyle/>
-                    <a:p>
-                      <a:r>
-                        <a:rPr sz="1600" b="1">
-                          <a:solidFill>
-                            <a:srgbClr val="FFFFFF"/>
-                          </a:solidFill>
-                          <a:latin typeface="微软雅黑"/>
-                          <a:ea typeface="微软雅黑"/>
-                          <a:cs typeface="微软雅黑"/>
-                        </a:rPr>
-                        <a:t/>
-                      </a:r>
-                    </a:p>
-                  </a:txBody>
-                  <a:tcPr anchor="ctr" marL="182880">
-                    <a:solidFill>
-                      <a:srgbClr val="287DFA"/>
-                    </a:solidFill>
-                  </a:tcPr>
-                </a:tc>
-                <a:tc>
-                  <a:txBody>
-                    <a:bodyPr/>
-                    <a:lstStyle/>
-                    <a:p>
-                      <a:r>
-                        <a:rPr sz="1600" b="1">
-                          <a:solidFill>
-                            <a:srgbClr val="FFFFFF"/>
-                          </a:solidFill>
-                          <a:latin typeface="微软雅黑"/>
-                          <a:ea typeface="微软雅黑"/>
-                          <a:cs typeface="微软雅黑"/>
-                        </a:rPr>
-                        <a:t>小红书 · AI native</a:t>
-                      </a:r>
-                    </a:p>
-                  </a:txBody>
-                  <a:tcPr anchor="ctr" marL="182880">
-                    <a:solidFill>
-                      <a:srgbClr val="287DFA"/>
-                    </a:solidFill>
-                  </a:tcPr>
-                </a:tc>
-                <a:tc>
-                  <a:txBody>
-                    <a:bodyPr/>
-                    <a:lstStyle/>
-                    <a:p>
-                      <a:r>
-                        <a:rPr sz="1600" b="1">
-                          <a:solidFill>
-                            <a:srgbClr val="FFFFFF"/>
-                          </a:solidFill>
-                          <a:latin typeface="微软雅黑"/>
-                          <a:ea typeface="微软雅黑"/>
-                          <a:cs typeface="微软雅黑"/>
-                        </a:rPr>
-                        <a:t>携程 · AI × 业务</a:t>
-                      </a:r>
-                    </a:p>
-                  </a:txBody>
-                  <a:tcPr anchor="ctr" marL="182880">
-                    <a:solidFill>
-                      <a:srgbClr val="287DFA"/>
-                    </a:solidFill>
-                  </a:tcPr>
-                </a:tc>
-              </a:tr>
-              <a:tr h="640080">
-                <a:tc>
-                  <a:txBody>
-                    <a:bodyPr/>
-                    <a:lstStyle/>
-                    <a:p>
-                      <a:r>
-                        <a:rPr sz="1500" b="1">
-                          <a:solidFill>
-                            <a:srgbClr val="15315E"/>
-                          </a:solidFill>
-                          <a:latin typeface="微软雅黑"/>
-                          <a:ea typeface="微软雅黑"/>
-                          <a:cs typeface="微软雅黑"/>
-                        </a:rPr>
-                        <a:t>产品是什么</a:t>
-                      </a:r>
-                    </a:p>
-                  </a:txBody>
-                  <a:tcPr anchor="ctr" marL="182880">
-                    <a:solidFill>
-                      <a:srgbClr val="EAF2FF"/>
-                    </a:solidFill>
-                  </a:tcPr>
-                </a:tc>
-                <a:tc>
-                  <a:txBody>
-                    <a:bodyPr/>
-                    <a:lstStyle/>
-                    <a:p>
-                      <a:r>
-                        <a:rPr sz="1500" b="0">
-                          <a:solidFill>
-                            <a:srgbClr val="3D4757"/>
-                          </a:solidFill>
-                          <a:latin typeface="微软雅黑"/>
-                          <a:ea typeface="微软雅黑"/>
-                          <a:cs typeface="微软雅黑"/>
-                        </a:rPr>
-                        <a:t>模型本身就是产品</a:t>
-                      </a:r>
-                    </a:p>
-                  </a:txBody>
-                  <a:tcPr anchor="ctr" marL="182880">
-                    <a:solidFill>
-                      <a:srgbClr val="FFFFFF"/>
-                    </a:solidFill>
-                  </a:tcPr>
-                </a:tc>
-                <a:tc>
-                  <a:txBody>
-                    <a:bodyPr/>
-                    <a:lstStyle/>
-                    <a:p>
-                      <a:r>
-                        <a:rPr sz="1500" b="1">
-                          <a:solidFill>
-                            <a:srgbClr val="287DFA"/>
-                          </a:solidFill>
-                          <a:latin typeface="微软雅黑"/>
-                          <a:ea typeface="微软雅黑"/>
-                          <a:cs typeface="微软雅黑"/>
-                        </a:rPr>
-                        <a:t>AI 是服务业务的手段</a:t>
-                      </a:r>
-                    </a:p>
-                  </a:txBody>
-                  <a:tcPr anchor="ctr" marL="182880">
-                    <a:solidFill>
-                      <a:srgbClr val="F5F9FF"/>
-                    </a:solidFill>
-                  </a:tcPr>
-                </a:tc>
-              </a:tr>
-              <a:tr h="640080">
-                <a:tc>
-                  <a:txBody>
-                    <a:bodyPr/>
-                    <a:lstStyle/>
-                    <a:p>
-                      <a:r>
-                        <a:rPr sz="1500" b="1">
-                          <a:solidFill>
-                            <a:srgbClr val="15315E"/>
-                          </a:solidFill>
-                          <a:latin typeface="微软雅黑"/>
-                          <a:ea typeface="微软雅黑"/>
-                          <a:cs typeface="微软雅黑"/>
-                        </a:rPr>
-                        <a:t>边界由谁定</a:t>
-                      </a:r>
-                    </a:p>
-                  </a:txBody>
-                  <a:tcPr anchor="ctr" marL="182880">
-                    <a:solidFill>
-                      <a:srgbClr val="EAF2FF"/>
-                    </a:solidFill>
-                  </a:tcPr>
-                </a:tc>
-                <a:tc>
-                  <a:txBody>
-                    <a:bodyPr/>
-                    <a:lstStyle/>
-                    <a:p>
-                      <a:r>
-                        <a:rPr sz="1500" b="0">
-                          <a:solidFill>
-                            <a:srgbClr val="3D4757"/>
-                          </a:solidFill>
-                          <a:latin typeface="微软雅黑"/>
-                          <a:ea typeface="微软雅黑"/>
-                          <a:cs typeface="微软雅黑"/>
-                        </a:rPr>
-                        <a:t>拓展能力边界、限制行为边界</a:t>
-                      </a:r>
-                    </a:p>
-                  </a:txBody>
-                  <a:tcPr anchor="ctr" marL="182880">
-                    <a:solidFill>
-                      <a:srgbClr val="FFFFFF"/>
-                    </a:solidFill>
-                  </a:tcPr>
-                </a:tc>
-                <a:tc>
-                  <a:txBody>
-                    <a:bodyPr/>
-                    <a:lstStyle/>
-                    <a:p>
-                      <a:r>
-                        <a:rPr sz="1500" b="1">
-                          <a:solidFill>
-                            <a:srgbClr val="287DFA"/>
-                          </a:solidFill>
-                          <a:latin typeface="微软雅黑"/>
-                          <a:ea typeface="微软雅黑"/>
-                          <a:cs typeface="微软雅黑"/>
-                        </a:rPr>
-                        <a:t>业务来定：什么属于火车、什么不属于</a:t>
-                      </a:r>
-                    </a:p>
-                  </a:txBody>
-                  <a:tcPr anchor="ctr" marL="182880">
-                    <a:solidFill>
-                      <a:srgbClr val="F5F9FF"/>
-                    </a:solidFill>
-                  </a:tcPr>
-                </a:tc>
-              </a:tr>
-              <a:tr h="640080">
-                <a:tc>
-                  <a:txBody>
-                    <a:bodyPr/>
-                    <a:lstStyle/>
-                    <a:p>
-                      <a:r>
-                        <a:rPr sz="1500" b="1">
-                          <a:solidFill>
-                            <a:srgbClr val="15315E"/>
-                          </a:solidFill>
-                          <a:latin typeface="微软雅黑"/>
-                          <a:ea typeface="微软雅黑"/>
-                          <a:cs typeface="微软雅黑"/>
-                        </a:rPr>
-                        <a:t>衡量标准</a:t>
-                      </a:r>
-                    </a:p>
-                  </a:txBody>
-                  <a:tcPr anchor="ctr" marL="182880">
-                    <a:solidFill>
-                      <a:srgbClr val="EAF2FF"/>
-                    </a:solidFill>
-                  </a:tcPr>
-                </a:tc>
-                <a:tc>
-                  <a:txBody>
-                    <a:bodyPr/>
-                    <a:lstStyle/>
-                    <a:p>
-                      <a:r>
-                        <a:rPr sz="1500" b="0">
-                          <a:solidFill>
-                            <a:srgbClr val="3D4757"/>
-                          </a:solidFill>
-                          <a:latin typeface="微软雅黑"/>
-                          <a:ea typeface="微软雅黑"/>
-                          <a:cs typeface="微软雅黑"/>
-                        </a:rPr>
-                        <a:t>模型表现得好不好</a:t>
-                      </a:r>
-                    </a:p>
-                  </a:txBody>
-                  <a:tcPr anchor="ctr" marL="182880">
-                    <a:solidFill>
-                      <a:srgbClr val="FFFFFF"/>
-                    </a:solidFill>
-                  </a:tcPr>
-                </a:tc>
-                <a:tc>
-                  <a:txBody>
-                    <a:bodyPr/>
-                    <a:lstStyle/>
-                    <a:p>
-                      <a:r>
-                        <a:rPr sz="1500" b="1">
-                          <a:solidFill>
-                            <a:srgbClr val="287DFA"/>
-                          </a:solidFill>
-                          <a:latin typeface="微软雅黑"/>
-                          <a:ea typeface="微软雅黑"/>
-                          <a:cs typeface="微软雅黑"/>
-                        </a:rPr>
-                        <a:t>票量这样的业务结果</a:t>
-                      </a:r>
-                    </a:p>
-                  </a:txBody>
-                  <a:tcPr anchor="ctr" marL="182880">
-                    <a:solidFill>
-                      <a:srgbClr val="F5F9FF"/>
-                    </a:solidFill>
-                  </a:tcPr>
-                </a:tc>
-              </a:tr>
-            </a:tbl>
-          </a:graphicData>
-        </a:graphic>
-      </p:graphicFrame>
+      <p:sp>
+        <p:nvSpPr>
+          <p:cNvPr id="13" name="TextBox 12"/>
+          <p:cNvSpPr txBox="1"/>
+          <p:nvPr/>
+        </p:nvSpPr>
+        <p:spPr>
+          <a:xfrm>
+            <a:off x="457200" y="2697480"/>
+            <a:ext cx="11274552" cy="320040"/>
+          </a:xfrm>
+          <a:prstGeom prst="rect">
+            <a:avLst/>
+          </a:prstGeom>
+          <a:noFill/>
+        </p:spPr>
+        <p:txBody>
+          <a:bodyPr wrap="square" lIns="0" rIns="0" tIns="0" bIns="0" anchor="t">
+            <a:spAutoFit/>
+          </a:bodyPr>
+          <a:lstStyle/>
+          <a:p>
+            <a:pPr algn="l"/>
+            <a:r>
+              <a:rPr sz="1300" b="1">
+                <a:solidFill>
+                  <a:srgbClr val="7A8599"/>
+                </a:solidFill>
+                <a:latin typeface="微软雅黑"/>
+                <a:ea typeface="微软雅黑"/>
+                <a:cs typeface="微软雅黑"/>
+              </a:rPr>
+              <a:t>AI native：</a:t>
+            </a:r>
+            <a:r>
+              <a:rPr sz="1300" b="0">
+                <a:solidFill>
+                  <a:srgbClr val="7A8599"/>
+                </a:solidFill>
+                <a:latin typeface="微软雅黑"/>
+                <a:ea typeface="微软雅黑"/>
+                <a:cs typeface="微软雅黑"/>
+              </a:rPr>
+              <a:t>模型本身就是产品，衡量的是模型表现　　</a:t>
+            </a:r>
+            <a:r>
+              <a:rPr sz="1300" b="1">
+                <a:solidFill>
+                  <a:srgbClr val="287DFA"/>
+                </a:solidFill>
+                <a:latin typeface="微软雅黑"/>
+                <a:ea typeface="微软雅黑"/>
+                <a:cs typeface="微软雅黑"/>
+              </a:rPr>
+              <a:t>AI × 业务：</a:t>
+            </a:r>
+            <a:r>
+              <a:rPr sz="1300" b="0">
+                <a:solidFill>
+                  <a:srgbClr val="287DFA"/>
+                </a:solidFill>
+                <a:latin typeface="微软雅黑"/>
+                <a:ea typeface="微软雅黑"/>
+                <a:cs typeface="微软雅黑"/>
+              </a:rPr>
+              <a:t>AI 是服务业务的手段</a:t>
+            </a:r>
+          </a:p>
+        </p:txBody>
+      </p:sp>
       <p:sp>
         <p:nvSpPr>
           <p:cNvPr id="14" name="Rounded Rectangle 13"/>
@@ -15885,8 +15651,8 @@
         </p:nvSpPr>
         <p:spPr>
           <a:xfrm>
-            <a:off x="457200" y="5440680"/>
-            <a:ext cx="11274552" cy="640080"/>
+            <a:off x="457200" y="3200400"/>
+            <a:ext cx="3630168" cy="1828800"/>
           </a:xfrm>
           <a:prstGeom prst="roundRect">
             <a:avLst>
@@ -15894,7 +15660,51 @@
             </a:avLst>
           </a:prstGeom>
           <a:solidFill>
-            <a:srgbClr val="EAF2FF"/>
+            <a:srgbClr val="FFFFFF"/>
+          </a:solidFill>
+          <a:ln w="12700">
+            <a:solidFill>
+              <a:srgbClr val="D3E2FB"/>
+            </a:solidFill>
+          </a:ln>
+          <a:effectLst/>
+        </p:spPr>
+        <p:style>
+          <a:lnRef idx="1">
+            <a:schemeClr val="accent1"/>
+          </a:lnRef>
+          <a:fillRef idx="3">
+            <a:schemeClr val="accent1"/>
+          </a:fillRef>
+          <a:effectRef idx="2">
+            <a:schemeClr val="accent1"/>
+          </a:effectRef>
+          <a:fontRef idx="minor">
+            <a:schemeClr val="lt1"/>
+          </a:fontRef>
+        </p:style>
+        <p:txBody>
+          <a:bodyPr rtlCol="0" anchor="ctr"/>
+          <a:lstStyle/>
+          <a:p/>
+        </p:txBody>
+      </p:sp>
+      <p:sp>
+        <p:nvSpPr>
+          <p:cNvPr id="15" name="icon-circle"/>
+          <p:cNvSpPr/>
+          <p:nvPr/>
+        </p:nvSpPr>
+        <p:spPr>
+          <a:xfrm>
+            <a:off x="731520" y="3429000"/>
+            <a:ext cx="685800" cy="685800"/>
+          </a:xfrm>
+          <a:prstGeom prst="ellipse">
+            <a:avLst/>
+          </a:prstGeom>
+          <a:solidFill>
+            <a:srgbClr val="287DFA"/>
           </a:solidFill>
           <a:ln>
             <a:noFill/>
@@ -15923,7 +15733,7 @@
       </p:sp>
       <p:pic>
         <p:nvPicPr>
-          <p:cNvPr id="15" name="Picture 14" descr="FaLightbulb_b.png"/>
+          <p:cNvPr id="16" name="Picture 15" descr="FaLayerGroup_w.png"/>
           <p:cNvPicPr>
             <a:picLocks noChangeAspect="1"/>
           </p:cNvPicPr>
@@ -15937,8 +15747,8 @@
         </p:blipFill>
         <p:spPr>
           <a:xfrm>
-            <a:off x="685800" y="5577840"/>
-            <a:ext cx="365760" cy="365760"/>
+            <a:off x="902970" y="3600450"/>
+            <a:ext cx="342900" cy="342900"/>
           </a:xfrm>
           <a:prstGeom prst="rect">
             <a:avLst/>
@@ -15947,14 +15757,14 @@
       </p:pic>
       <p:sp>
         <p:nvSpPr>
-          <p:cNvPr id="16" name="TextBox 15"/>
+          <p:cNvPr id="17" name="TextBox 16"/>
           <p:cNvSpPr txBox="1"/>
           <p:nvPr/>
         </p:nvSpPr>
         <p:spPr>
           <a:xfrm>
-            <a:off x="1188720" y="5440680"/>
-            <a:ext cx="10424160" cy="640080"/>
+            <a:off x="1600200" y="3429000"/>
+            <a:ext cx="2377440" cy="685800"/>
           </a:xfrm>
           <a:prstGeom prst="rect">
             <a:avLst/>
@@ -15969,18 +15779,44 @@
           <a:p>
             <a:pPr algn="l"/>
             <a:r>
-              <a:rPr sz="1400" b="1">
-                <a:solidFill>
-                  <a:srgbClr val="287DFA"/>
+              <a:rPr sz="1700" b="1">
+                <a:solidFill>
+                  <a:srgbClr val="15315E"/>
                 </a:solidFill>
                 <a:latin typeface="微软雅黑"/>
                 <a:ea typeface="微软雅黑"/>
                 <a:cs typeface="微软雅黑"/>
               </a:rPr>
-              <a:t>形态要贴合用户习惯　</a:t>
-            </a:r>
-            <a:r>
-              <a:rPr sz="1400" b="0">
+              <a:t>边界由业务来定</a:t>
+            </a:r>
+          </a:p>
+        </p:txBody>
+      </p:sp>
+      <p:sp>
+        <p:nvSpPr>
+          <p:cNvPr id="18" name="TextBox 17"/>
+          <p:cNvSpPr txBox="1"/>
+          <p:nvPr/>
+        </p:nvSpPr>
+        <p:spPr>
+          <a:xfrm>
+            <a:off x="731520" y="4297680"/>
+            <a:ext cx="3108960" cy="640080"/>
+          </a:xfrm>
+          <a:prstGeom prst="rect">
+            <a:avLst/>
+          </a:prstGeom>
+          <a:noFill/>
+        </p:spPr>
+        <p:txBody>
+          <a:bodyPr wrap="square" lIns="0" rIns="0" tIns="0" bIns="0" anchor="t">
+            <a:spAutoFit/>
+          </a:bodyPr>
+          <a:lstStyle/>
+          <a:p>
+            <a:pPr algn="l"/>
+            <a:r>
+              <a:rPr sz="1300" b="0">
                 <a:solidFill>
                   <a:srgbClr val="3D4757"/>
                 </a:solidFill>
@@ -15988,7 +15824,495 @@
                 <a:ea typeface="微软雅黑"/>
                 <a:cs typeface="微软雅黑"/>
               </a:rPr>
-              <a:t>二期把对话改成直接操作列表页后，票量明显提升</a:t>
+              <a:t>什么属于火车、什么不属于</a:t>
+            </a:r>
+          </a:p>
+        </p:txBody>
+      </p:sp>
+      <p:sp>
+        <p:nvSpPr>
+          <p:cNvPr id="19" name="Rounded Rectangle 18"/>
+          <p:cNvSpPr/>
+          <p:nvPr/>
+        </p:nvSpPr>
+        <p:spPr>
+          <a:xfrm>
+            <a:off x="4279392" y="3200400"/>
+            <a:ext cx="3630168" cy="1828800"/>
+          </a:xfrm>
+          <a:prstGeom prst="roundRect">
+            <a:avLst>
+              <a:gd name="adj" fmla="val 6000"/>
+            </a:avLst>
+          </a:prstGeom>
+          <a:solidFill>
+            <a:srgbClr val="FFFFFF"/>
+          </a:solidFill>
+          <a:ln w="12700">
+            <a:solidFill>
+              <a:srgbClr val="D3E2FB"/>
+            </a:solidFill>
+          </a:ln>
+          <a:effectLst/>
+        </p:spPr>
+        <p:style>
+          <a:lnRef idx="1">
+            <a:schemeClr val="accent1"/>
+          </a:lnRef>
+          <a:fillRef idx="3">
+            <a:schemeClr val="accent1"/>
+          </a:fillRef>
+          <a:effectRef idx="2">
+            <a:schemeClr val="accent1"/>
+          </a:effectRef>
+          <a:fontRef idx="minor">
+            <a:schemeClr val="lt1"/>
+          </a:fontRef>
+        </p:style>
+        <p:txBody>
+          <a:bodyPr rtlCol="0" anchor="ctr"/>
+          <a:lstStyle/>
+          <a:p/>
+        </p:txBody>
+      </p:sp>
+      <p:sp>
+        <p:nvSpPr>
+          <p:cNvPr id="20" name="icon-circle"/>
+          <p:cNvSpPr/>
+          <p:nvPr/>
+        </p:nvSpPr>
+        <p:spPr>
+          <a:xfrm>
+            <a:off x="4553712" y="3429000"/>
+            <a:ext cx="685800" cy="685800"/>
+          </a:xfrm>
+          <a:prstGeom prst="ellipse">
+            <a:avLst/>
+          </a:prstGeom>
+          <a:solidFill>
+            <a:srgbClr val="287DFA"/>
+          </a:solidFill>
+          <a:ln>
+            <a:noFill/>
+          </a:ln>
+          <a:effectLst/>
+        </p:spPr>
+        <p:style>
+          <a:lnRef idx="1">
+            <a:schemeClr val="accent1"/>
+          </a:lnRef>
+          <a:fillRef idx="3">
+            <a:schemeClr val="accent1"/>
+          </a:fillRef>
+          <a:effectRef idx="2">
+            <a:schemeClr val="accent1"/>
+          </a:effectRef>
+          <a:fontRef idx="minor">
+            <a:schemeClr val="lt1"/>
+          </a:fontRef>
+        </p:style>
+        <p:txBody>
+          <a:bodyPr rtlCol="0" anchor="ctr"/>
+          <a:lstStyle/>
+          <a:p/>
+        </p:txBody>
+      </p:sp>
+      <p:pic>
+        <p:nvPicPr>
+          <p:cNvPr id="21" name="Picture 20" descr="FaHandshake_w.png"/>
+          <p:cNvPicPr>
+            <a:picLocks noChangeAspect="1"/>
+          </p:cNvPicPr>
+          <p:nvPr/>
+        </p:nvPicPr>
+        <p:blipFill>
+          <a:blip r:embed="rId6"/>
+          <a:stretch>
+            <a:fillRect/>
+          </a:stretch>
+        </p:blipFill>
+        <p:spPr>
+          <a:xfrm>
+            <a:off x="4725162" y="3600450"/>
+            <a:ext cx="342900" cy="342900"/>
+          </a:xfrm>
+          <a:prstGeom prst="rect">
+            <a:avLst/>
+          </a:prstGeom>
+        </p:spPr>
+      </p:pic>
+      <p:sp>
+        <p:nvSpPr>
+          <p:cNvPr id="22" name="TextBox 21"/>
+          <p:cNvSpPr txBox="1"/>
+          <p:nvPr/>
+        </p:nvSpPr>
+        <p:spPr>
+          <a:xfrm>
+            <a:off x="5422392" y="3429000"/>
+            <a:ext cx="2377440" cy="685800"/>
+          </a:xfrm>
+          <a:prstGeom prst="rect">
+            <a:avLst/>
+          </a:prstGeom>
+          <a:noFill/>
+        </p:spPr>
+        <p:txBody>
+          <a:bodyPr wrap="square" lIns="0" rIns="0" tIns="0" bIns="0" anchor="ctr">
+            <a:spAutoFit/>
+          </a:bodyPr>
+          <a:lstStyle/>
+          <a:p>
+            <a:pPr algn="l"/>
+            <a:r>
+              <a:rPr sz="1700" b="1">
+                <a:solidFill>
+                  <a:srgbClr val="15315E"/>
+                </a:solidFill>
+                <a:latin typeface="微软雅黑"/>
+                <a:ea typeface="微软雅黑"/>
+                <a:cs typeface="微软雅黑"/>
+              </a:rPr>
+              <a:t>形态贴合用户习惯</a:t>
+            </a:r>
+          </a:p>
+        </p:txBody>
+      </p:sp>
+      <p:sp>
+        <p:nvSpPr>
+          <p:cNvPr id="23" name="TextBox 22"/>
+          <p:cNvSpPr txBox="1"/>
+          <p:nvPr/>
+        </p:nvSpPr>
+        <p:spPr>
+          <a:xfrm>
+            <a:off x="4553712" y="4297680"/>
+            <a:ext cx="3108960" cy="640080"/>
+          </a:xfrm>
+          <a:prstGeom prst="rect">
+            <a:avLst/>
+          </a:prstGeom>
+          <a:noFill/>
+        </p:spPr>
+        <p:txBody>
+          <a:bodyPr wrap="square" lIns="0" rIns="0" tIns="0" bIns="0" anchor="t">
+            <a:spAutoFit/>
+          </a:bodyPr>
+          <a:lstStyle/>
+          <a:p>
+            <a:pPr algn="l"/>
+            <a:r>
+              <a:rPr sz="1300" b="0">
+                <a:solidFill>
+                  <a:srgbClr val="3D4757"/>
+                </a:solidFill>
+                <a:latin typeface="微软雅黑"/>
+                <a:ea typeface="微软雅黑"/>
+                <a:cs typeface="微软雅黑"/>
+              </a:rPr>
+              <a:t>二期把对话改成直接操作列表页，票量明显提升</a:t>
+            </a:r>
+          </a:p>
+        </p:txBody>
+      </p:sp>
+      <p:sp>
+        <p:nvSpPr>
+          <p:cNvPr id="24" name="Rounded Rectangle 23"/>
+          <p:cNvSpPr/>
+          <p:nvPr/>
+        </p:nvSpPr>
+        <p:spPr>
+          <a:xfrm>
+            <a:off x="8101583" y="3200400"/>
+            <a:ext cx="3630168" cy="1828800"/>
+          </a:xfrm>
+          <a:prstGeom prst="roundRect">
+            <a:avLst>
+              <a:gd name="adj" fmla="val 6000"/>
+            </a:avLst>
+          </a:prstGeom>
+          <a:solidFill>
+            <a:srgbClr val="FFFFFF"/>
+          </a:solidFill>
+          <a:ln w="12700">
+            <a:solidFill>
+              <a:srgbClr val="D3E2FB"/>
+            </a:solidFill>
+          </a:ln>
+          <a:effectLst/>
+        </p:spPr>
+        <p:style>
+          <a:lnRef idx="1">
+            <a:schemeClr val="accent1"/>
+          </a:lnRef>
+          <a:fillRef idx="3">
+            <a:schemeClr val="accent1"/>
+          </a:fillRef>
+          <a:effectRef idx="2">
+            <a:schemeClr val="accent1"/>
+          </a:effectRef>
+          <a:fontRef idx="minor">
+            <a:schemeClr val="lt1"/>
+          </a:fontRef>
+        </p:style>
+        <p:txBody>
+          <a:bodyPr rtlCol="0" anchor="ctr"/>
+          <a:lstStyle/>
+          <a:p/>
+        </p:txBody>
+      </p:sp>
+      <p:sp>
+        <p:nvSpPr>
+          <p:cNvPr id="25" name="icon-circle"/>
+          <p:cNvSpPr/>
+          <p:nvPr/>
+        </p:nvSpPr>
+        <p:spPr>
+          <a:xfrm>
+            <a:off x="8375904" y="3429000"/>
+            <a:ext cx="685800" cy="685800"/>
+          </a:xfrm>
+          <a:prstGeom prst="ellipse">
+            <a:avLst/>
+          </a:prstGeom>
+          <a:solidFill>
+            <a:srgbClr val="287DFA"/>
+          </a:solidFill>
+          <a:ln>
+            <a:noFill/>
+          </a:ln>
+          <a:effectLst/>
+        </p:spPr>
+        <p:style>
+          <a:lnRef idx="1">
+            <a:schemeClr val="accent1"/>
+          </a:lnRef>
+          <a:fillRef idx="3">
+            <a:schemeClr val="accent1"/>
+          </a:fillRef>
+          <a:effectRef idx="2">
+            <a:schemeClr val="accent1"/>
+          </a:effectRef>
+          <a:fontRef idx="minor">
+            <a:schemeClr val="lt1"/>
+          </a:fontRef>
+        </p:style>
+        <p:txBody>
+          <a:bodyPr rtlCol="0" anchor="ctr"/>
+          <a:lstStyle/>
+          <a:p/>
+        </p:txBody>
+      </p:sp>
+      <p:pic>
+        <p:nvPicPr>
+          <p:cNvPr id="26" name="Picture 25" descr="FaChartLine_w.png"/>
+          <p:cNvPicPr>
+            <a:picLocks noChangeAspect="1"/>
+          </p:cNvPicPr>
+          <p:nvPr/>
+        </p:nvPicPr>
+        <p:blipFill>
+          <a:blip r:embed="rId7"/>
+          <a:stretch>
+            <a:fillRect/>
+          </a:stretch>
+        </p:blipFill>
+        <p:spPr>
+          <a:xfrm>
+            <a:off x="8547354" y="3600450"/>
+            <a:ext cx="342900" cy="342900"/>
+          </a:xfrm>
+          <a:prstGeom prst="rect">
+            <a:avLst/>
+          </a:prstGeom>
+        </p:spPr>
+      </p:pic>
+      <p:sp>
+        <p:nvSpPr>
+          <p:cNvPr id="27" name="TextBox 26"/>
+          <p:cNvSpPr txBox="1"/>
+          <p:nvPr/>
+        </p:nvSpPr>
+        <p:spPr>
+          <a:xfrm>
+            <a:off x="9244584" y="3429000"/>
+            <a:ext cx="2377440" cy="685800"/>
+          </a:xfrm>
+          <a:prstGeom prst="rect">
+            <a:avLst/>
+          </a:prstGeom>
+          <a:noFill/>
+        </p:spPr>
+        <p:txBody>
+          <a:bodyPr wrap="square" lIns="0" rIns="0" tIns="0" bIns="0" anchor="ctr">
+            <a:spAutoFit/>
+          </a:bodyPr>
+          <a:lstStyle/>
+          <a:p>
+            <a:pPr algn="l"/>
+            <a:r>
+              <a:rPr sz="1700" b="1">
+                <a:solidFill>
+                  <a:srgbClr val="15315E"/>
+                </a:solidFill>
+                <a:latin typeface="微软雅黑"/>
+                <a:ea typeface="微软雅黑"/>
+                <a:cs typeface="微软雅黑"/>
+              </a:rPr>
+              <a:t>用业务结果衡量</a:t>
+            </a:r>
+          </a:p>
+        </p:txBody>
+      </p:sp>
+      <p:sp>
+        <p:nvSpPr>
+          <p:cNvPr id="28" name="TextBox 27"/>
+          <p:cNvSpPr txBox="1"/>
+          <p:nvPr/>
+        </p:nvSpPr>
+        <p:spPr>
+          <a:xfrm>
+            <a:off x="8375904" y="4297680"/>
+            <a:ext cx="3108960" cy="640080"/>
+          </a:xfrm>
+          <a:prstGeom prst="rect">
+            <a:avLst/>
+          </a:prstGeom>
+          <a:noFill/>
+        </p:spPr>
+        <p:txBody>
+          <a:bodyPr wrap="square" lIns="0" rIns="0" tIns="0" bIns="0" anchor="t">
+            <a:spAutoFit/>
+          </a:bodyPr>
+          <a:lstStyle/>
+          <a:p>
+            <a:pPr algn="l"/>
+            <a:r>
+              <a:rPr sz="1300" b="0">
+                <a:solidFill>
+                  <a:srgbClr val="3D4757"/>
+                </a:solidFill>
+                <a:latin typeface="微软雅黑"/>
+                <a:ea typeface="微软雅黑"/>
+                <a:cs typeface="微软雅黑"/>
+              </a:rPr>
+              <a:t>最终看的是票量这样的业务结果</a:t>
+            </a:r>
+          </a:p>
+        </p:txBody>
+      </p:sp>
+      <p:sp>
+        <p:nvSpPr>
+          <p:cNvPr id="29" name="Rounded Rectangle 28"/>
+          <p:cNvSpPr/>
+          <p:nvPr/>
+        </p:nvSpPr>
+        <p:spPr>
+          <a:xfrm>
+            <a:off x="457200" y="5257800"/>
+            <a:ext cx="11274552" cy="822960"/>
+          </a:xfrm>
+          <a:prstGeom prst="roundRect">
+            <a:avLst>
+              <a:gd name="adj" fmla="val 6000"/>
+            </a:avLst>
+          </a:prstGeom>
+          <a:solidFill>
+            <a:srgbClr val="287DFA"/>
+          </a:solidFill>
+          <a:ln>
+            <a:noFill/>
+          </a:ln>
+          <a:effectLst/>
+        </p:spPr>
+        <p:style>
+          <a:lnRef idx="1">
+            <a:schemeClr val="accent1"/>
+          </a:lnRef>
+          <a:fillRef idx="3">
+            <a:schemeClr val="accent1"/>
+          </a:fillRef>
+          <a:effectRef idx="2">
+            <a:schemeClr val="accent1"/>
+          </a:effectRef>
+          <a:fontRef idx="minor">
+            <a:schemeClr val="lt1"/>
+          </a:fontRef>
+        </p:style>
+        <p:txBody>
+          <a:bodyPr rtlCol="0" anchor="ctr"/>
+          <a:lstStyle/>
+          <a:p/>
+        </p:txBody>
+      </p:sp>
+      <p:pic>
+        <p:nvPicPr>
+          <p:cNvPr id="30" name="Picture 29" descr="FaLightbulb_w.png"/>
+          <p:cNvPicPr>
+            <a:picLocks noChangeAspect="1"/>
+          </p:cNvPicPr>
+          <p:nvPr/>
+        </p:nvPicPr>
+        <p:blipFill>
+          <a:blip r:embed="rId8"/>
+          <a:stretch>
+            <a:fillRect/>
+          </a:stretch>
+        </p:blipFill>
+        <p:spPr>
+          <a:xfrm>
+            <a:off x="777240" y="5458968"/>
+            <a:ext cx="420624" cy="420624"/>
+          </a:xfrm>
+          <a:prstGeom prst="rect">
+            <a:avLst/>
+          </a:prstGeom>
+        </p:spPr>
+      </p:pic>
+      <p:sp>
+        <p:nvSpPr>
+          <p:cNvPr id="31" name="TextBox 30"/>
+          <p:cNvSpPr txBox="1"/>
+          <p:nvPr/>
+        </p:nvSpPr>
+        <p:spPr>
+          <a:xfrm>
+            <a:off x="1417320" y="5257800"/>
+            <a:ext cx="10149840" cy="822960"/>
+          </a:xfrm>
+          <a:prstGeom prst="rect">
+            <a:avLst/>
+          </a:prstGeom>
+          <a:noFill/>
+        </p:spPr>
+        <p:txBody>
+          <a:bodyPr wrap="square" lIns="0" rIns="0" tIns="0" bIns="0" anchor="ctr">
+            <a:spAutoFit/>
+          </a:bodyPr>
+          <a:lstStyle/>
+          <a:p>
+            <a:pPr algn="l"/>
+            <a:r>
+              <a:rPr sz="1800" b="1">
+                <a:solidFill>
+                  <a:srgbClr val="D6E6FF"/>
+                </a:solidFill>
+                <a:latin typeface="微软雅黑"/>
+                <a:ea typeface="微软雅黑"/>
+                <a:cs typeface="微软雅黑"/>
+              </a:rPr>
+              <a:t>探索 AI + 业务时，先想清楚：</a:t>
+            </a:r>
+            <a:r>
+              <a:rPr sz="1800" b="1">
+                <a:solidFill>
+                  <a:srgbClr val="FFFFFF"/>
+                </a:solidFill>
+                <a:latin typeface="微软雅黑"/>
+                <a:ea typeface="微软雅黑"/>
+                <a:cs typeface="微软雅黑"/>
+              </a:rPr>
+              <a:t>业务需要它解决什么？用户习惯怎么用？</a:t>
             </a:r>
           </a:p>
         </p:txBody>

</xml_diff>

<commit_message>
Refine intro slide profile card and timeline
Co-Authored-By: Claude Opus 5.5 <noreply@anthropic.com>
Claude-Session: https://claude.ai/code/session_011iFrL2Hfizgp6kYckDtNGc
</commit_message>
<xml_diff>
--- a/答辩PPT.pptx
+++ b/答辩PPT.pptx
@@ -19803,7 +19803,7 @@
         <p:spPr>
           <a:xfrm>
             <a:off x="457200" y="1481328"/>
-            <a:ext cx="2514600" cy="4572000"/>
+            <a:ext cx="2926080" cy="4599432"/>
           </a:xfrm>
           <a:prstGeom prst="roundRect">
             <a:avLst>
@@ -19840,14 +19840,451 @@
       </p:sp>
       <p:sp>
         <p:nvSpPr>
-          <p:cNvPr id="5" name="icon-circle"/>
+          <p:cNvPr id="5" name="TextBox 4"/>
+          <p:cNvSpPr txBox="1"/>
+          <p:nvPr/>
+        </p:nvSpPr>
+        <p:spPr>
+          <a:xfrm>
+            <a:off x="731520" y="1645920"/>
+            <a:ext cx="2377440" cy="548640"/>
+          </a:xfrm>
+          <a:prstGeom prst="rect">
+            <a:avLst/>
+          </a:prstGeom>
+          <a:noFill/>
+        </p:spPr>
+        <p:txBody>
+          <a:bodyPr wrap="square" lIns="0" rIns="0" tIns="0" bIns="0" anchor="t">
+            <a:spAutoFit/>
+          </a:bodyPr>
+          <a:lstStyle/>
+          <a:p>
+            <a:pPr algn="l"/>
+            <a:r>
+              <a:rPr sz="2800" b="1">
+                <a:solidFill>
+                  <a:srgbClr val="15315E"/>
+                </a:solidFill>
+                <a:latin typeface="微软雅黑"/>
+                <a:ea typeface="微软雅黑"/>
+                <a:cs typeface="微软雅黑"/>
+              </a:rPr>
+              <a:t>罗蕴文</a:t>
+            </a:r>
+          </a:p>
+        </p:txBody>
+      </p:sp>
+      <p:pic>
+        <p:nvPicPr>
+          <p:cNvPr id="6" name="Picture 5" descr="FaGraduationCap_b.png"/>
+          <p:cNvPicPr>
+            <a:picLocks noChangeAspect="1"/>
+          </p:cNvPicPr>
+          <p:nvPr/>
+        </p:nvPicPr>
+        <p:blipFill>
+          <a:blip r:embed="rId3"/>
+          <a:stretch>
+            <a:fillRect/>
+          </a:stretch>
+        </p:blipFill>
+        <p:spPr>
+          <a:xfrm>
+            <a:off x="749808" y="2368296"/>
+            <a:ext cx="274320" cy="274320"/>
+          </a:xfrm>
+          <a:prstGeom prst="rect">
+            <a:avLst/>
+          </a:prstGeom>
+        </p:spPr>
+      </p:pic>
+      <p:sp>
+        <p:nvSpPr>
+          <p:cNvPr id="7" name="TextBox 6"/>
+          <p:cNvSpPr txBox="1"/>
+          <p:nvPr/>
+        </p:nvSpPr>
+        <p:spPr>
+          <a:xfrm>
+            <a:off x="1143000" y="2331720"/>
+            <a:ext cx="2057400" cy="347472"/>
+          </a:xfrm>
+          <a:prstGeom prst="rect">
+            <a:avLst/>
+          </a:prstGeom>
+          <a:noFill/>
+        </p:spPr>
+        <p:txBody>
+          <a:bodyPr wrap="square" lIns="0" rIns="0" tIns="0" bIns="0" anchor="ctr">
+            <a:spAutoFit/>
+          </a:bodyPr>
+          <a:lstStyle/>
+          <a:p>
+            <a:pPr algn="l"/>
+            <a:r>
+              <a:rPr sz="1300" b="0">
+                <a:solidFill>
+                  <a:srgbClr val="3D4757"/>
+                </a:solidFill>
+                <a:latin typeface="微软雅黑"/>
+                <a:ea typeface="微软雅黑"/>
+                <a:cs typeface="微软雅黑"/>
+              </a:rPr>
+              <a:t>复旦大学 外国哲学硕士</a:t>
+            </a:r>
+          </a:p>
+        </p:txBody>
+      </p:sp>
+      <p:pic>
+        <p:nvPicPr>
+          <p:cNvPr id="8" name="Picture 7" descr="FaCalendarCheck_b.png"/>
+          <p:cNvPicPr>
+            <a:picLocks noChangeAspect="1"/>
+          </p:cNvPicPr>
+          <p:nvPr/>
+        </p:nvPicPr>
+        <p:blipFill>
+          <a:blip r:embed="rId4"/>
+          <a:stretch>
+            <a:fillRect/>
+          </a:stretch>
+        </p:blipFill>
+        <p:spPr>
+          <a:xfrm>
+            <a:off x="749808" y="2807208"/>
+            <a:ext cx="274320" cy="274320"/>
+          </a:xfrm>
+          <a:prstGeom prst="rect">
+            <a:avLst/>
+          </a:prstGeom>
+        </p:spPr>
+      </p:pic>
+      <p:sp>
+        <p:nvSpPr>
+          <p:cNvPr id="9" name="TextBox 8"/>
+          <p:cNvSpPr txBox="1"/>
+          <p:nvPr/>
+        </p:nvSpPr>
+        <p:spPr>
+          <a:xfrm>
+            <a:off x="1143000" y="2770632"/>
+            <a:ext cx="2057400" cy="347472"/>
+          </a:xfrm>
+          <a:prstGeom prst="rect">
+            <a:avLst/>
+          </a:prstGeom>
+          <a:noFill/>
+        </p:spPr>
+        <p:txBody>
+          <a:bodyPr wrap="square" lIns="0" rIns="0" tIns="0" bIns="0" anchor="ctr">
+            <a:spAutoFit/>
+          </a:bodyPr>
+          <a:lstStyle/>
+          <a:p>
+            <a:pPr algn="l"/>
+            <a:r>
+              <a:rPr sz="1300" b="0">
+                <a:solidFill>
+                  <a:srgbClr val="3D4757"/>
+                </a:solidFill>
+                <a:latin typeface="微软雅黑"/>
+                <a:ea typeface="微软雅黑"/>
+                <a:cs typeface="微软雅黑"/>
+              </a:rPr>
+              <a:t>2027 年 6 月毕业</a:t>
+            </a:r>
+          </a:p>
+        </p:txBody>
+      </p:sp>
+      <p:cxnSp>
+        <p:nvCxnSpPr>
+          <p:cNvPr id="10" name="Connector 9"/>
+          <p:cNvCxnSpPr/>
+          <p:nvPr/>
+        </p:nvCxnSpPr>
+        <p:spPr>
+          <a:xfrm>
+            <a:off x="731520" y="3310128"/>
+            <a:ext cx="2377440" cy="0"/>
+          </a:xfrm>
+          <a:prstGeom prst="line">
+            <a:avLst/>
+          </a:prstGeom>
+          <a:ln w="12700">
+            <a:solidFill>
+              <a:srgbClr val="D3E2FB"/>
+            </a:solidFill>
+          </a:ln>
+        </p:spPr>
+        <p:style>
+          <a:lnRef idx="2">
+            <a:schemeClr val="accent1"/>
+          </a:lnRef>
+          <a:fillRef idx="0">
+            <a:schemeClr val="accent1"/>
+          </a:fillRef>
+          <a:effectRef idx="1">
+            <a:schemeClr val="accent1"/>
+          </a:effectRef>
+          <a:fontRef idx="minor">
+            <a:schemeClr val="tx1"/>
+          </a:fontRef>
+        </p:style>
+      </p:cxnSp>
+      <p:sp>
+        <p:nvSpPr>
+          <p:cNvPr id="11" name="TextBox 10"/>
+          <p:cNvSpPr txBox="1"/>
+          <p:nvPr/>
+        </p:nvSpPr>
+        <p:spPr>
+          <a:xfrm>
+            <a:off x="731520" y="3429000"/>
+            <a:ext cx="2377440" cy="292608"/>
+          </a:xfrm>
+          <a:prstGeom prst="rect">
+            <a:avLst/>
+          </a:prstGeom>
+          <a:noFill/>
+        </p:spPr>
+        <p:txBody>
+          <a:bodyPr wrap="square" lIns="0" rIns="0" tIns="0" bIns="0" anchor="t">
+            <a:spAutoFit/>
+          </a:bodyPr>
+          <a:lstStyle/>
+          <a:p>
+            <a:pPr algn="l"/>
+            <a:r>
+              <a:rPr sz="1200" b="1">
+                <a:solidFill>
+                  <a:srgbClr val="7A8599"/>
+                </a:solidFill>
+                <a:latin typeface="微软雅黑"/>
+                <a:ea typeface="微软雅黑"/>
+                <a:cs typeface="微软雅黑"/>
+              </a:rPr>
+              <a:t>实习经历</a:t>
+            </a:r>
+          </a:p>
+        </p:txBody>
+      </p:sp>
+      <p:cxnSp>
+        <p:nvCxnSpPr>
+          <p:cNvPr id="12" name="Connector 11"/>
+          <p:cNvCxnSpPr/>
+          <p:nvPr/>
+        </p:nvCxnSpPr>
+        <p:spPr>
+          <a:xfrm>
+            <a:off x="841247" y="3886200"/>
+            <a:ext cx="0" cy="1371600"/>
+          </a:xfrm>
+          <a:prstGeom prst="line">
+            <a:avLst/>
+          </a:prstGeom>
+          <a:ln w="19050">
+            <a:solidFill>
+              <a:srgbClr val="D3E2FB"/>
+            </a:solidFill>
+          </a:ln>
+        </p:spPr>
+        <p:style>
+          <a:lnRef idx="2">
+            <a:schemeClr val="accent1"/>
+          </a:lnRef>
+          <a:fillRef idx="0">
+            <a:schemeClr val="accent1"/>
+          </a:fillRef>
+          <a:effectRef idx="1">
+            <a:schemeClr val="accent1"/>
+          </a:effectRef>
+          <a:fontRef idx="minor">
+            <a:schemeClr val="tx1"/>
+          </a:fontRef>
+        </p:style>
+      </p:cxnSp>
+      <p:sp>
+        <p:nvSpPr>
+          <p:cNvPr id="13" name="Oval 12"/>
           <p:cNvSpPr/>
           <p:nvPr/>
         </p:nvSpPr>
         <p:spPr>
           <a:xfrm>
-            <a:off x="731520" y="1737360"/>
-            <a:ext cx="868680" cy="868680"/>
+            <a:off x="768096" y="3831336"/>
+            <a:ext cx="146304" cy="146304"/>
+          </a:xfrm>
+          <a:prstGeom prst="ellipse">
+            <a:avLst/>
+          </a:prstGeom>
+          <a:solidFill>
+            <a:srgbClr val="7A8599"/>
+          </a:solidFill>
+          <a:ln>
+            <a:noFill/>
+          </a:ln>
+          <a:effectLst/>
+        </p:spPr>
+        <p:style>
+          <a:lnRef idx="1">
+            <a:schemeClr val="accent1"/>
+          </a:lnRef>
+          <a:fillRef idx="3">
+            <a:schemeClr val="accent1"/>
+          </a:fillRef>
+          <a:effectRef idx="2">
+            <a:schemeClr val="accent1"/>
+          </a:effectRef>
+          <a:fontRef idx="minor">
+            <a:schemeClr val="lt1"/>
+          </a:fontRef>
+        </p:style>
+        <p:txBody>
+          <a:bodyPr rtlCol="0" anchor="ctr"/>
+          <a:lstStyle/>
+          <a:p/>
+        </p:txBody>
+      </p:sp>
+      <p:sp>
+        <p:nvSpPr>
+          <p:cNvPr id="14" name="TextBox 13"/>
+          <p:cNvSpPr txBox="1"/>
+          <p:nvPr/>
+        </p:nvSpPr>
+        <p:spPr>
+          <a:xfrm>
+            <a:off x="1051560" y="3767328"/>
+            <a:ext cx="2194560" cy="292608"/>
+          </a:xfrm>
+          <a:prstGeom prst="rect">
+            <a:avLst/>
+          </a:prstGeom>
+          <a:noFill/>
+        </p:spPr>
+        <p:txBody>
+          <a:bodyPr wrap="square" lIns="0" rIns="0" tIns="0" bIns="0" anchor="t">
+            <a:spAutoFit/>
+          </a:bodyPr>
+          <a:lstStyle/>
+          <a:p>
+            <a:pPr algn="l"/>
+            <a:r>
+              <a:rPr sz="1300" b="1">
+                <a:solidFill>
+                  <a:srgbClr val="15315E"/>
+                </a:solidFill>
+                <a:latin typeface="微软雅黑"/>
+                <a:ea typeface="微软雅黑"/>
+                <a:cs typeface="微软雅黑"/>
+              </a:rPr>
+              <a:t>小红书 · 产品经理实习生</a:t>
+            </a:r>
+          </a:p>
+        </p:txBody>
+      </p:sp>
+      <p:sp>
+        <p:nvSpPr>
+          <p:cNvPr id="15" name="TextBox 14"/>
+          <p:cNvSpPr txBox="1"/>
+          <p:nvPr/>
+        </p:nvSpPr>
+        <p:spPr>
+          <a:xfrm>
+            <a:off x="1051560" y="4041648"/>
+            <a:ext cx="2194560" cy="256032"/>
+          </a:xfrm>
+          <a:prstGeom prst="rect">
+            <a:avLst/>
+          </a:prstGeom>
+          <a:noFill/>
+        </p:spPr>
+        <p:txBody>
+          <a:bodyPr wrap="square" lIns="0" rIns="0" tIns="0" bIns="0" anchor="t">
+            <a:spAutoFit/>
+          </a:bodyPr>
+          <a:lstStyle/>
+          <a:p>
+            <a:pPr algn="l"/>
+            <a:r>
+              <a:rPr sz="1100" b="0">
+                <a:solidFill>
+                  <a:srgbClr val="7A8599"/>
+                </a:solidFill>
+                <a:latin typeface="微软雅黑"/>
+                <a:ea typeface="微软雅黑"/>
+                <a:cs typeface="微软雅黑"/>
+              </a:rPr>
+              <a:t>2025.7 – 2025.9</a:t>
+            </a:r>
+          </a:p>
+        </p:txBody>
+      </p:sp>
+      <p:sp>
+        <p:nvSpPr>
+          <p:cNvPr id="16" name="TextBox 15"/>
+          <p:cNvSpPr txBox="1"/>
+          <p:nvPr/>
+        </p:nvSpPr>
+        <p:spPr>
+          <a:xfrm>
+            <a:off x="1024128" y="4297680"/>
+            <a:ext cx="2267712" cy="548640"/>
+          </a:xfrm>
+          <a:prstGeom prst="rect">
+            <a:avLst/>
+          </a:prstGeom>
+          <a:noFill/>
+        </p:spPr>
+        <p:txBody>
+          <a:bodyPr wrap="square" lIns="0" rIns="0" tIns="0" bIns="0" anchor="t">
+            <a:spAutoFit/>
+          </a:bodyPr>
+          <a:lstStyle/>
+          <a:p>
+            <a:pPr algn="l"/>
+            <a:r>
+              <a:rPr sz="1050" b="0">
+                <a:solidFill>
+                  <a:srgbClr val="3D4757"/>
+                </a:solidFill>
+                <a:latin typeface="微软雅黑"/>
+                <a:ea typeface="微软雅黑"/>
+                <a:cs typeface="微软雅黑"/>
+              </a:rPr>
+              <a:t>大模型“点点”幽默语境评测与优化</a:t>
+            </a:r>
+          </a:p>
+          <a:p>
+            <a:pPr algn="l">
+              <a:spcBef>
+                <a:spcPts val="100"/>
+              </a:spcBef>
+            </a:pPr>
+            <a:r>
+              <a:rPr sz="1050" b="0">
+                <a:solidFill>
+                  <a:srgbClr val="3D4757"/>
+                </a:solidFill>
+                <a:latin typeface="微软雅黑"/>
+                <a:ea typeface="微软雅黑"/>
+                <a:cs typeface="微软雅黑"/>
+              </a:rPr>
+              <a:t>可复用 Workflow 搭建</a:t>
+            </a:r>
+          </a:p>
+        </p:txBody>
+      </p:sp>
+      <p:sp>
+        <p:nvSpPr>
+          <p:cNvPr id="17" name="Oval 16"/>
+          <p:cNvSpPr/>
+          <p:nvPr/>
+        </p:nvSpPr>
+        <p:spPr>
+          <a:xfrm>
+            <a:off x="768096" y="5148072"/>
+            <a:ext cx="146304" cy="146304"/>
           </a:xfrm>
           <a:prstGeom prst="ellipse">
             <a:avLst/>
@@ -19880,40 +20317,16 @@
           <a:p/>
         </p:txBody>
       </p:sp>
-      <p:pic>
-        <p:nvPicPr>
-          <p:cNvPr id="6" name="Picture 5" descr="FaUserGraduate_w.png"/>
-          <p:cNvPicPr>
-            <a:picLocks noChangeAspect="1"/>
-          </p:cNvPicPr>
-          <p:nvPr/>
-        </p:nvPicPr>
-        <p:blipFill>
-          <a:blip r:embed="rId3"/>
-          <a:stretch>
-            <a:fillRect/>
-          </a:stretch>
-        </p:blipFill>
-        <p:spPr>
-          <a:xfrm>
-            <a:off x="948690" y="1954529"/>
-            <a:ext cx="434340" cy="434340"/>
-          </a:xfrm>
-          <a:prstGeom prst="rect">
-            <a:avLst/>
-          </a:prstGeom>
-        </p:spPr>
-      </p:pic>
-      <p:sp>
-        <p:nvSpPr>
-          <p:cNvPr id="7" name="TextBox 6"/>
+      <p:sp>
+        <p:nvSpPr>
+          <p:cNvPr id="18" name="TextBox 17"/>
           <p:cNvSpPr txBox="1"/>
           <p:nvPr/>
         </p:nvSpPr>
         <p:spPr>
           <a:xfrm>
-            <a:off x="731520" y="2743200"/>
-            <a:ext cx="2103120" cy="548640"/>
+            <a:off x="1051560" y="5084064"/>
+            <a:ext cx="2194560" cy="292608"/>
           </a:xfrm>
           <a:prstGeom prst="rect">
             <a:avLst/>
@@ -19928,7 +20341,7 @@
           <a:p>
             <a:pPr algn="l"/>
             <a:r>
-              <a:rPr sz="2800" b="1">
+              <a:rPr sz="1300" b="1">
                 <a:solidFill>
                   <a:srgbClr val="15315E"/>
                 </a:solidFill>
@@ -19936,117 +20349,58 @@
                 <a:ea typeface="微软雅黑"/>
                 <a:cs typeface="微软雅黑"/>
               </a:rPr>
-              <a:t>罗蕴文</a:t>
-            </a:r>
-          </a:p>
-        </p:txBody>
-      </p:sp>
-      <p:pic>
-        <p:nvPicPr>
-          <p:cNvPr id="8" name="Picture 7" descr="FaCalendarCheck_b.png"/>
-          <p:cNvPicPr>
-            <a:picLocks noChangeAspect="1"/>
-          </p:cNvPicPr>
-          <p:nvPr/>
-        </p:nvPicPr>
-        <p:blipFill>
-          <a:blip r:embed="rId4"/>
-          <a:stretch>
-            <a:fillRect/>
-          </a:stretch>
-        </p:blipFill>
-        <p:spPr>
-          <a:xfrm>
-            <a:off x="749808" y="3456432"/>
-            <a:ext cx="292608" cy="292608"/>
+              <a:t>携程 · 产品经理实习生</a:t>
+            </a:r>
+          </a:p>
+        </p:txBody>
+      </p:sp>
+      <p:sp>
+        <p:nvSpPr>
+          <p:cNvPr id="19" name="TextBox 18"/>
+          <p:cNvSpPr txBox="1"/>
+          <p:nvPr/>
+        </p:nvSpPr>
+        <p:spPr>
+          <a:xfrm>
+            <a:off x="1051560" y="5358384"/>
+            <a:ext cx="2194560" cy="256032"/>
           </a:xfrm>
           <a:prstGeom prst="rect">
             <a:avLst/>
           </a:prstGeom>
-        </p:spPr>
-      </p:pic>
-      <p:sp>
-        <p:nvSpPr>
-          <p:cNvPr id="9" name="TextBox 8"/>
-          <p:cNvSpPr txBox="1"/>
-          <p:nvPr/>
-        </p:nvSpPr>
-        <p:spPr>
-          <a:xfrm>
-            <a:off x="1161288" y="3401568"/>
-            <a:ext cx="1737360" cy="384048"/>
-          </a:xfrm>
-          <a:prstGeom prst="rect">
-            <a:avLst/>
-          </a:prstGeom>
           <a:noFill/>
         </p:spPr>
         <p:txBody>
-          <a:bodyPr wrap="square" lIns="0" rIns="0" tIns="0" bIns="0" anchor="ctr">
+          <a:bodyPr wrap="square" lIns="0" rIns="0" tIns="0" bIns="0" anchor="t">
             <a:spAutoFit/>
           </a:bodyPr>
           <a:lstStyle/>
           <a:p>
             <a:pPr algn="l"/>
             <a:r>
-              <a:rPr sz="1400" b="0">
-                <a:solidFill>
-                  <a:srgbClr val="3D4757"/>
+              <a:rPr sz="1100" b="0">
+                <a:solidFill>
+                  <a:srgbClr val="7A8599"/>
                 </a:solidFill>
                 <a:latin typeface="微软雅黑"/>
                 <a:ea typeface="微软雅黑"/>
                 <a:cs typeface="微软雅黑"/>
               </a:rPr>
-              <a:t>2027 年 6 月毕业</a:t>
-            </a:r>
-          </a:p>
-        </p:txBody>
-      </p:sp>
-      <p:cxnSp>
-        <p:nvCxnSpPr>
-          <p:cNvPr id="10" name="Connector 9"/>
-          <p:cNvCxnSpPr/>
-          <p:nvPr/>
-        </p:nvCxnSpPr>
-        <p:spPr>
-          <a:xfrm>
-            <a:off x="731520" y="4069080"/>
-            <a:ext cx="1965960" cy="0"/>
-          </a:xfrm>
-          <a:prstGeom prst="line">
-            <a:avLst/>
-          </a:prstGeom>
-          <a:ln w="12700">
-            <a:solidFill>
-              <a:srgbClr val="D3E2FB"/>
-            </a:solidFill>
-          </a:ln>
-        </p:spPr>
-        <p:style>
-          <a:lnRef idx="2">
-            <a:schemeClr val="accent1"/>
-          </a:lnRef>
-          <a:fillRef idx="0">
-            <a:schemeClr val="accent1"/>
-          </a:fillRef>
-          <a:effectRef idx="1">
-            <a:schemeClr val="accent1"/>
-          </a:effectRef>
-          <a:fontRef idx="minor">
-            <a:schemeClr val="tx1"/>
-          </a:fontRef>
-        </p:style>
-      </p:cxnSp>
-      <p:sp>
-        <p:nvSpPr>
-          <p:cNvPr id="11" name="TextBox 10"/>
+              <a:t>2026.4 – 至今</a:t>
+            </a:r>
+          </a:p>
+        </p:txBody>
+      </p:sp>
+      <p:sp>
+        <p:nvSpPr>
+          <p:cNvPr id="20" name="TextBox 19"/>
           <p:cNvSpPr txBox="1"/>
           <p:nvPr/>
         </p:nvSpPr>
         <p:spPr>
           <a:xfrm>
-            <a:off x="731520" y="4251960"/>
-            <a:ext cx="2103120" cy="320040"/>
+            <a:off x="1024128" y="5614416"/>
+            <a:ext cx="2267712" cy="274320"/>
           </a:xfrm>
           <a:prstGeom prst="rect">
             <a:avLst/>
@@ -20061,103 +20415,29 @@
           <a:p>
             <a:pPr algn="l"/>
             <a:r>
-              <a:rPr sz="1200" b="0">
-                <a:solidFill>
-                  <a:srgbClr val="7A8599"/>
+              <a:rPr sz="1050" b="0">
+                <a:solidFill>
+                  <a:srgbClr val="3D4757"/>
                 </a:solidFill>
                 <a:latin typeface="微软雅黑"/>
                 <a:ea typeface="微软雅黑"/>
                 <a:cs typeface="微软雅黑"/>
               </a:rPr>
-              <a:t>此前经历</a:t>
-            </a:r>
-          </a:p>
-        </p:txBody>
-      </p:sp>
-      <p:sp>
-        <p:nvSpPr>
-          <p:cNvPr id="12" name="TextBox 11"/>
-          <p:cNvSpPr txBox="1"/>
-          <p:nvPr/>
-        </p:nvSpPr>
-        <p:spPr>
-          <a:xfrm>
-            <a:off x="731520" y="4553712"/>
-            <a:ext cx="2103120" cy="365760"/>
-          </a:xfrm>
-          <a:prstGeom prst="rect">
-            <a:avLst/>
-          </a:prstGeom>
-          <a:noFill/>
-        </p:spPr>
-        <p:txBody>
-          <a:bodyPr wrap="square" lIns="0" rIns="0" tIns="0" bIns="0" anchor="t">
-            <a:spAutoFit/>
-          </a:bodyPr>
-          <a:lstStyle/>
-          <a:p>
-            <a:pPr algn="l"/>
-            <a:r>
-              <a:rPr sz="1400" b="1">
-                <a:solidFill>
-                  <a:srgbClr val="15315E"/>
-                </a:solidFill>
-                <a:latin typeface="微软雅黑"/>
-                <a:ea typeface="微软雅黑"/>
-                <a:cs typeface="微软雅黑"/>
-              </a:rPr>
-              <a:t>小红书 · 产品实习</a:t>
-            </a:r>
-          </a:p>
-        </p:txBody>
-      </p:sp>
-      <p:sp>
-        <p:nvSpPr>
-          <p:cNvPr id="13" name="TextBox 12"/>
-          <p:cNvSpPr txBox="1"/>
-          <p:nvPr/>
-        </p:nvSpPr>
-        <p:spPr>
-          <a:xfrm>
-            <a:off x="731520" y="4956048"/>
-            <a:ext cx="2057400" cy="822960"/>
-          </a:xfrm>
-          <a:prstGeom prst="rect">
-            <a:avLst/>
-          </a:prstGeom>
-          <a:noFill/>
-        </p:spPr>
-        <p:txBody>
-          <a:bodyPr wrap="square" lIns="0" rIns="0" tIns="0" bIns="0" anchor="t">
-            <a:spAutoFit/>
-          </a:bodyPr>
-          <a:lstStyle/>
-          <a:p>
-            <a:pPr algn="l"/>
-            <a:r>
-              <a:rPr sz="1300" b="0">
-                <a:solidFill>
-                  <a:srgbClr val="3D4757"/>
-                </a:solidFill>
-                <a:latin typeface="微软雅黑"/>
-                <a:ea typeface="微软雅黑"/>
-                <a:cs typeface="微软雅黑"/>
-              </a:rPr>
-              <a:t>大模型“点点”幽默语境下的测评与优化</a:t>
-            </a:r>
-          </a:p>
-        </p:txBody>
-      </p:sp>
-      <p:sp>
-        <p:nvSpPr>
-          <p:cNvPr id="14" name="Rounded Rectangle 13"/>
+              <a:t>火车票 Agent · 抢票业务</a:t>
+            </a:r>
+          </a:p>
+        </p:txBody>
+      </p:sp>
+      <p:sp>
+        <p:nvSpPr>
+          <p:cNvPr id="21" name="Rounded Rectangle 20"/>
           <p:cNvSpPr/>
           <p:nvPr/>
         </p:nvSpPr>
         <p:spPr>
           <a:xfrm>
-            <a:off x="4343400" y="1481328"/>
-            <a:ext cx="3977639" cy="384048"/>
+            <a:off x="4663440" y="1481328"/>
+            <a:ext cx="3412776" cy="384048"/>
           </a:xfrm>
           <a:prstGeom prst="roundRect">
             <a:avLst>
@@ -20194,14 +20474,14 @@
       </p:sp>
       <p:sp>
         <p:nvSpPr>
-          <p:cNvPr id="15" name="TextBox 14"/>
+          <p:cNvPr id="22" name="TextBox 21"/>
           <p:cNvSpPr txBox="1"/>
           <p:nvPr/>
         </p:nvSpPr>
         <p:spPr>
           <a:xfrm>
-            <a:off x="4343400" y="1481328"/>
-            <a:ext cx="3977639" cy="384048"/>
+            <a:off x="4663440" y="1481328"/>
+            <a:ext cx="3412776" cy="384048"/>
           </a:xfrm>
           <a:prstGeom prst="rect">
             <a:avLst/>
@@ -20231,14 +20511,14 @@
       </p:sp>
       <p:sp>
         <p:nvSpPr>
-          <p:cNvPr id="16" name="Pentagon 15"/>
+          <p:cNvPr id="23" name="Pentagon 22"/>
           <p:cNvSpPr/>
           <p:nvPr/>
         </p:nvSpPr>
         <p:spPr>
           <a:xfrm>
-            <a:off x="7680959" y="1481328"/>
-            <a:ext cx="3985014" cy="384048"/>
+            <a:off x="7498079" y="1481328"/>
+            <a:ext cx="4251960" cy="384048"/>
           </a:xfrm>
           <a:prstGeom prst="homePlate">
             <a:avLst/>
@@ -20273,14 +20553,14 @@
       </p:sp>
       <p:sp>
         <p:nvSpPr>
-          <p:cNvPr id="17" name="TextBox 16"/>
+          <p:cNvPr id="24" name="TextBox 23"/>
           <p:cNvSpPr txBox="1"/>
           <p:nvPr/>
         </p:nvSpPr>
         <p:spPr>
           <a:xfrm>
-            <a:off x="7680959" y="1481328"/>
-            <a:ext cx="3985014" cy="384048"/>
+            <a:off x="7498079" y="1481328"/>
+            <a:ext cx="4251960" cy="384048"/>
           </a:xfrm>
           <a:prstGeom prst="rect">
             <a:avLst/>
@@ -20310,14 +20590,14 @@
       </p:sp>
       <p:cxnSp>
         <p:nvCxnSpPr>
-          <p:cNvPr id="18" name="Connector 17"/>
+          <p:cNvPr id="25" name="Connector 24"/>
           <p:cNvCxnSpPr/>
           <p:nvPr/>
         </p:nvCxnSpPr>
         <p:spPr>
           <a:xfrm>
-            <a:off x="4343400" y="2240280"/>
-            <a:ext cx="7322574" cy="0"/>
+            <a:off x="4663440" y="2240280"/>
+            <a:ext cx="7040880" cy="0"/>
           </a:xfrm>
           <a:prstGeom prst="line">
             <a:avLst/>
@@ -20345,14 +20625,14 @@
       </p:cxnSp>
       <p:sp>
         <p:nvSpPr>
-          <p:cNvPr id="19" name="TextBox 18"/>
+          <p:cNvPr id="26" name="TextBox 25"/>
           <p:cNvSpPr txBox="1"/>
           <p:nvPr/>
         </p:nvSpPr>
         <p:spPr>
           <a:xfrm>
-            <a:off x="4023359" y="1938528"/>
-            <a:ext cx="731520" cy="237744"/>
+            <a:off x="4096511" y="2121408"/>
+            <a:ext cx="457200" cy="237744"/>
           </a:xfrm>
           <a:prstGeom prst="rect">
             <a:avLst/>
@@ -20365,7 +20645,7 @@
           </a:bodyPr>
           <a:lstStyle/>
           <a:p>
-            <a:pPr algn="ctr"/>
+            <a:pPr algn="r"/>
             <a:r>
               <a:rPr sz="1100" b="0">
                 <a:solidFill>
@@ -20375,20 +20655,20 @@
                 <a:ea typeface="微软雅黑"/>
                 <a:cs typeface="微软雅黑"/>
               </a:rPr>
-              <a:t>5月</a:t>
-            </a:r>
-          </a:p>
-        </p:txBody>
-      </p:sp>
-      <p:sp>
-        <p:nvSpPr>
-          <p:cNvPr id="20" name="Oval 19"/>
+              <a:t>4月</a:t>
+            </a:r>
+          </a:p>
+        </p:txBody>
+      </p:sp>
+      <p:sp>
+        <p:nvSpPr>
+          <p:cNvPr id="27" name="Oval 26"/>
           <p:cNvSpPr/>
           <p:nvPr/>
         </p:nvSpPr>
         <p:spPr>
           <a:xfrm>
-            <a:off x="4343400" y="2194560"/>
+            <a:off x="4617720" y="2194560"/>
             <a:ext cx="91440" cy="91440"/>
           </a:xfrm>
           <a:prstGeom prst="ellipse">
@@ -20426,14 +20706,14 @@
       </p:sp>
       <p:cxnSp>
         <p:nvCxnSpPr>
-          <p:cNvPr id="21" name="Connector 20"/>
+          <p:cNvPr id="28" name="Connector 27"/>
           <p:cNvCxnSpPr/>
           <p:nvPr/>
         </p:nvCxnSpPr>
         <p:spPr>
           <a:xfrm>
-            <a:off x="4389120" y="2313432"/>
-            <a:ext cx="0" cy="3721608"/>
+            <a:off x="4663440" y="2313432"/>
+            <a:ext cx="0" cy="3739896"/>
           </a:xfrm>
           <a:prstGeom prst="line">
             <a:avLst/>
@@ -20462,14 +20742,14 @@
       </p:cxnSp>
       <p:sp>
         <p:nvSpPr>
-          <p:cNvPr id="22" name="TextBox 21"/>
+          <p:cNvPr id="29" name="TextBox 28"/>
           <p:cNvSpPr txBox="1"/>
           <p:nvPr/>
         </p:nvSpPr>
         <p:spPr>
           <a:xfrm>
-            <a:off x="5074919" y="1938528"/>
-            <a:ext cx="731520" cy="237744"/>
+            <a:off x="4526280" y="1938528"/>
+            <a:ext cx="640080" cy="237744"/>
           </a:xfrm>
           <a:prstGeom prst="rect">
             <a:avLst/>
@@ -20492,20 +20772,20 @@
                 <a:ea typeface="微软雅黑"/>
                 <a:cs typeface="微软雅黑"/>
               </a:rPr>
-              <a:t>6月</a:t>
-            </a:r>
-          </a:p>
-        </p:txBody>
-      </p:sp>
-      <p:sp>
-        <p:nvSpPr>
-          <p:cNvPr id="23" name="Oval 22"/>
+              <a:t>5月</a:t>
+            </a:r>
+          </a:p>
+        </p:txBody>
+      </p:sp>
+      <p:sp>
+        <p:nvSpPr>
+          <p:cNvPr id="30" name="Oval 29"/>
           <p:cNvSpPr/>
           <p:nvPr/>
         </p:nvSpPr>
         <p:spPr>
           <a:xfrm>
-            <a:off x="5394959" y="2194560"/>
+            <a:off x="4800600" y="2194560"/>
             <a:ext cx="91440" cy="91440"/>
           </a:xfrm>
           <a:prstGeom prst="ellipse">
@@ -20543,14 +20823,14 @@
       </p:sp>
       <p:cxnSp>
         <p:nvCxnSpPr>
-          <p:cNvPr id="24" name="Connector 23"/>
+          <p:cNvPr id="31" name="Connector 30"/>
           <p:cNvCxnSpPr/>
           <p:nvPr/>
         </p:nvCxnSpPr>
         <p:spPr>
           <a:xfrm>
-            <a:off x="5440679" y="2313432"/>
-            <a:ext cx="0" cy="3721608"/>
+            <a:off x="4846320" y="2313432"/>
+            <a:ext cx="0" cy="3739896"/>
           </a:xfrm>
           <a:prstGeom prst="line">
             <a:avLst/>
@@ -20579,14 +20859,14 @@
       </p:cxnSp>
       <p:sp>
         <p:nvSpPr>
-          <p:cNvPr id="25" name="TextBox 24"/>
+          <p:cNvPr id="32" name="TextBox 31"/>
           <p:cNvSpPr txBox="1"/>
           <p:nvPr/>
         </p:nvSpPr>
         <p:spPr>
           <a:xfrm>
-            <a:off x="6263639" y="1938528"/>
-            <a:ext cx="731520" cy="237744"/>
+            <a:off x="5394960" y="1938528"/>
+            <a:ext cx="640080" cy="237744"/>
           </a:xfrm>
           <a:prstGeom prst="rect">
             <a:avLst/>
@@ -20609,20 +20889,20 @@
                 <a:ea typeface="微软雅黑"/>
                 <a:cs typeface="微软雅黑"/>
               </a:rPr>
-              <a:t>7月</a:t>
-            </a:r>
-          </a:p>
-        </p:txBody>
-      </p:sp>
-      <p:sp>
-        <p:nvSpPr>
-          <p:cNvPr id="26" name="Oval 25"/>
+              <a:t>6月</a:t>
+            </a:r>
+          </a:p>
+        </p:txBody>
+      </p:sp>
+      <p:sp>
+        <p:nvSpPr>
+          <p:cNvPr id="33" name="Oval 32"/>
           <p:cNvSpPr/>
           <p:nvPr/>
         </p:nvSpPr>
         <p:spPr>
           <a:xfrm>
-            <a:off x="6583679" y="2194560"/>
+            <a:off x="5669280" y="2194560"/>
             <a:ext cx="91440" cy="91440"/>
           </a:xfrm>
           <a:prstGeom prst="ellipse">
@@ -20660,14 +20940,14 @@
       </p:sp>
       <p:cxnSp>
         <p:nvCxnSpPr>
-          <p:cNvPr id="27" name="Connector 26"/>
+          <p:cNvPr id="34" name="Connector 33"/>
           <p:cNvCxnSpPr/>
           <p:nvPr/>
         </p:nvCxnSpPr>
         <p:spPr>
           <a:xfrm>
-            <a:off x="6629399" y="2313432"/>
-            <a:ext cx="0" cy="3721608"/>
+            <a:off x="5715000" y="2313432"/>
+            <a:ext cx="0" cy="3739896"/>
           </a:xfrm>
           <a:prstGeom prst="line">
             <a:avLst/>
@@ -20696,14 +20976,14 @@
       </p:cxnSp>
       <p:sp>
         <p:nvSpPr>
-          <p:cNvPr id="28" name="TextBox 27"/>
+          <p:cNvPr id="35" name="TextBox 34"/>
           <p:cNvSpPr txBox="1"/>
           <p:nvPr/>
         </p:nvSpPr>
         <p:spPr>
           <a:xfrm>
-            <a:off x="7315199" y="1938528"/>
-            <a:ext cx="731520" cy="237744"/>
+            <a:off x="6263640" y="1938528"/>
+            <a:ext cx="640080" cy="237744"/>
           </a:xfrm>
           <a:prstGeom prst="rect">
             <a:avLst/>
@@ -20726,20 +21006,20 @@
                 <a:ea typeface="微软雅黑"/>
                 <a:cs typeface="微软雅黑"/>
               </a:rPr>
-              <a:t>8月</a:t>
-            </a:r>
-          </a:p>
-        </p:txBody>
-      </p:sp>
-      <p:sp>
-        <p:nvSpPr>
-          <p:cNvPr id="29" name="Oval 28"/>
+              <a:t>7月</a:t>
+            </a:r>
+          </a:p>
+        </p:txBody>
+      </p:sp>
+      <p:sp>
+        <p:nvSpPr>
+          <p:cNvPr id="36" name="Oval 35"/>
           <p:cNvSpPr/>
           <p:nvPr/>
         </p:nvSpPr>
         <p:spPr>
           <a:xfrm>
-            <a:off x="7635239" y="2194560"/>
+            <a:off x="6537960" y="2194560"/>
             <a:ext cx="91440" cy="91440"/>
           </a:xfrm>
           <a:prstGeom prst="ellipse">
@@ -20777,14 +21057,14 @@
       </p:sp>
       <p:cxnSp>
         <p:nvCxnSpPr>
-          <p:cNvPr id="30" name="Connector 29"/>
+          <p:cNvPr id="37" name="Connector 36"/>
           <p:cNvCxnSpPr/>
           <p:nvPr/>
         </p:nvCxnSpPr>
         <p:spPr>
           <a:xfrm>
-            <a:off x="7680959" y="2313432"/>
-            <a:ext cx="0" cy="3721608"/>
+            <a:off x="6583680" y="2313432"/>
+            <a:ext cx="0" cy="3739896"/>
           </a:xfrm>
           <a:prstGeom prst="line">
             <a:avLst/>
@@ -20813,14 +21093,14 @@
       </p:cxnSp>
       <p:sp>
         <p:nvSpPr>
-          <p:cNvPr id="31" name="TextBox 30"/>
+          <p:cNvPr id="38" name="TextBox 37"/>
           <p:cNvSpPr txBox="1"/>
           <p:nvPr/>
         </p:nvSpPr>
         <p:spPr>
           <a:xfrm>
-            <a:off x="8732519" y="1938528"/>
-            <a:ext cx="731520" cy="237744"/>
+            <a:off x="7178040" y="1938528"/>
+            <a:ext cx="640080" cy="237744"/>
           </a:xfrm>
           <a:prstGeom prst="rect">
             <a:avLst/>
@@ -20843,20 +21123,20 @@
                 <a:ea typeface="微软雅黑"/>
                 <a:cs typeface="微软雅黑"/>
               </a:rPr>
-              <a:t>9月</a:t>
-            </a:r>
-          </a:p>
-        </p:txBody>
-      </p:sp>
-      <p:sp>
-        <p:nvSpPr>
-          <p:cNvPr id="32" name="Oval 31"/>
+              <a:t>8月</a:t>
+            </a:r>
+          </a:p>
+        </p:txBody>
+      </p:sp>
+      <p:sp>
+        <p:nvSpPr>
+          <p:cNvPr id="39" name="Oval 38"/>
           <p:cNvSpPr/>
           <p:nvPr/>
         </p:nvSpPr>
         <p:spPr>
           <a:xfrm>
-            <a:off x="9052559" y="2194560"/>
+            <a:off x="7452359" y="2194560"/>
             <a:ext cx="91440" cy="91440"/>
           </a:xfrm>
           <a:prstGeom prst="ellipse">
@@ -20894,14 +21174,14 @@
       </p:sp>
       <p:cxnSp>
         <p:nvCxnSpPr>
-          <p:cNvPr id="33" name="Connector 32"/>
+          <p:cNvPr id="40" name="Connector 39"/>
           <p:cNvCxnSpPr/>
           <p:nvPr/>
         </p:nvCxnSpPr>
         <p:spPr>
           <a:xfrm>
-            <a:off x="9098280" y="2313432"/>
-            <a:ext cx="0" cy="3721608"/>
+            <a:off x="7498079" y="2313432"/>
+            <a:ext cx="0" cy="3739896"/>
           </a:xfrm>
           <a:prstGeom prst="line">
             <a:avLst/>
@@ -20930,14 +21210,14 @@
       </p:cxnSp>
       <p:sp>
         <p:nvSpPr>
-          <p:cNvPr id="34" name="TextBox 33"/>
+          <p:cNvPr id="41" name="TextBox 40"/>
           <p:cNvSpPr txBox="1"/>
           <p:nvPr/>
         </p:nvSpPr>
         <p:spPr>
           <a:xfrm>
-            <a:off x="10149840" y="1938528"/>
-            <a:ext cx="731520" cy="237744"/>
+            <a:off x="8458200" y="1938528"/>
+            <a:ext cx="640080" cy="237744"/>
           </a:xfrm>
           <a:prstGeom prst="rect">
             <a:avLst/>
@@ -20960,20 +21240,20 @@
                 <a:ea typeface="微软雅黑"/>
                 <a:cs typeface="微软雅黑"/>
               </a:rPr>
-              <a:t>10月</a:t>
-            </a:r>
-          </a:p>
-        </p:txBody>
-      </p:sp>
-      <p:sp>
-        <p:nvSpPr>
-          <p:cNvPr id="35" name="Oval 34"/>
+              <a:t>9月</a:t>
+            </a:r>
+          </a:p>
+        </p:txBody>
+      </p:sp>
+      <p:sp>
+        <p:nvSpPr>
+          <p:cNvPr id="42" name="Oval 41"/>
           <p:cNvSpPr/>
           <p:nvPr/>
         </p:nvSpPr>
         <p:spPr>
           <a:xfrm>
-            <a:off x="10469880" y="2194560"/>
+            <a:off x="8732519" y="2194560"/>
             <a:ext cx="91440" cy="91440"/>
           </a:xfrm>
           <a:prstGeom prst="ellipse">
@@ -21011,14 +21291,14 @@
       </p:sp>
       <p:cxnSp>
         <p:nvCxnSpPr>
-          <p:cNvPr id="36" name="Connector 35"/>
+          <p:cNvPr id="43" name="Connector 42"/>
           <p:cNvCxnSpPr/>
           <p:nvPr/>
         </p:nvCxnSpPr>
         <p:spPr>
           <a:xfrm>
-            <a:off x="10515600" y="2313432"/>
-            <a:ext cx="0" cy="3721608"/>
+            <a:off x="8778240" y="2313432"/>
+            <a:ext cx="0" cy="3739896"/>
           </a:xfrm>
           <a:prstGeom prst="line">
             <a:avLst/>
@@ -21047,14 +21327,248 @@
       </p:cxnSp>
       <p:sp>
         <p:nvSpPr>
-          <p:cNvPr id="37" name="Rounded Rectangle 36"/>
+          <p:cNvPr id="44" name="TextBox 43"/>
+          <p:cNvSpPr txBox="1"/>
+          <p:nvPr/>
+        </p:nvSpPr>
+        <p:spPr>
+          <a:xfrm>
+            <a:off x="9738360" y="1938528"/>
+            <a:ext cx="640080" cy="237744"/>
+          </a:xfrm>
+          <a:prstGeom prst="rect">
+            <a:avLst/>
+          </a:prstGeom>
+          <a:noFill/>
+        </p:spPr>
+        <p:txBody>
+          <a:bodyPr wrap="square" lIns="0" rIns="0" tIns="0" bIns="0" anchor="t">
+            <a:spAutoFit/>
+          </a:bodyPr>
+          <a:lstStyle/>
+          <a:p>
+            <a:pPr algn="ctr"/>
+            <a:r>
+              <a:rPr sz="1100" b="0">
+                <a:solidFill>
+                  <a:srgbClr val="3D4757"/>
+                </a:solidFill>
+                <a:latin typeface="微软雅黑"/>
+                <a:ea typeface="微软雅黑"/>
+                <a:cs typeface="微软雅黑"/>
+              </a:rPr>
+              <a:t>10月</a:t>
+            </a:r>
+          </a:p>
+        </p:txBody>
+      </p:sp>
+      <p:sp>
+        <p:nvSpPr>
+          <p:cNvPr id="45" name="Oval 44"/>
           <p:cNvSpPr/>
           <p:nvPr/>
         </p:nvSpPr>
         <p:spPr>
           <a:xfrm>
-            <a:off x="3200400" y="2450592"/>
-            <a:ext cx="1005840" cy="1060704"/>
+            <a:off x="10012680" y="2194560"/>
+            <a:ext cx="91440" cy="91440"/>
+          </a:xfrm>
+          <a:prstGeom prst="ellipse">
+            <a:avLst/>
+          </a:prstGeom>
+          <a:solidFill>
+            <a:srgbClr val="FFFFFF"/>
+          </a:solidFill>
+          <a:ln w="12700">
+            <a:solidFill>
+              <a:srgbClr val="287DFA"/>
+            </a:solidFill>
+          </a:ln>
+          <a:effectLst/>
+        </p:spPr>
+        <p:style>
+          <a:lnRef idx="1">
+            <a:schemeClr val="accent1"/>
+          </a:lnRef>
+          <a:fillRef idx="3">
+            <a:schemeClr val="accent1"/>
+          </a:fillRef>
+          <a:effectRef idx="2">
+            <a:schemeClr val="accent1"/>
+          </a:effectRef>
+          <a:fontRef idx="minor">
+            <a:schemeClr val="lt1"/>
+          </a:fontRef>
+        </p:style>
+        <p:txBody>
+          <a:bodyPr rtlCol="0" anchor="ctr"/>
+          <a:lstStyle/>
+          <a:p/>
+        </p:txBody>
+      </p:sp>
+      <p:cxnSp>
+        <p:nvCxnSpPr>
+          <p:cNvPr id="46" name="Connector 45"/>
+          <p:cNvCxnSpPr/>
+          <p:nvPr/>
+        </p:nvCxnSpPr>
+        <p:spPr>
+          <a:xfrm>
+            <a:off x="10058400" y="2313432"/>
+            <a:ext cx="0" cy="3739896"/>
+          </a:xfrm>
+          <a:prstGeom prst="line">
+            <a:avLst/>
+          </a:prstGeom>
+          <a:ln w="9525">
+            <a:solidFill>
+              <a:srgbClr val="E3EBF8"/>
+            </a:solidFill>
+            <a:prstDash val="dash"/>
+          </a:ln>
+        </p:spPr>
+        <p:style>
+          <a:lnRef idx="2">
+            <a:schemeClr val="accent1"/>
+          </a:lnRef>
+          <a:fillRef idx="0">
+            <a:schemeClr val="accent1"/>
+          </a:fillRef>
+          <a:effectRef idx="1">
+            <a:schemeClr val="accent1"/>
+          </a:effectRef>
+          <a:fontRef idx="minor">
+            <a:schemeClr val="tx1"/>
+          </a:fontRef>
+        </p:style>
+      </p:cxnSp>
+      <p:sp>
+        <p:nvSpPr>
+          <p:cNvPr id="47" name="TextBox 46"/>
+          <p:cNvSpPr txBox="1"/>
+          <p:nvPr/>
+        </p:nvSpPr>
+        <p:spPr>
+          <a:xfrm>
+            <a:off x="11155680" y="1938528"/>
+            <a:ext cx="640080" cy="237744"/>
+          </a:xfrm>
+          <a:prstGeom prst="rect">
+            <a:avLst/>
+          </a:prstGeom>
+          <a:noFill/>
+        </p:spPr>
+        <p:txBody>
+          <a:bodyPr wrap="square" lIns="0" rIns="0" tIns="0" bIns="0" anchor="t">
+            <a:spAutoFit/>
+          </a:bodyPr>
+          <a:lstStyle/>
+          <a:p>
+            <a:pPr algn="ctr"/>
+            <a:r>
+              <a:rPr sz="1100" b="0">
+                <a:solidFill>
+                  <a:srgbClr val="3D4757"/>
+                </a:solidFill>
+                <a:latin typeface="微软雅黑"/>
+                <a:ea typeface="微软雅黑"/>
+                <a:cs typeface="微软雅黑"/>
+              </a:rPr>
+              <a:t>11月</a:t>
+            </a:r>
+          </a:p>
+        </p:txBody>
+      </p:sp>
+      <p:sp>
+        <p:nvSpPr>
+          <p:cNvPr id="48" name="Oval 47"/>
+          <p:cNvSpPr/>
+          <p:nvPr/>
+        </p:nvSpPr>
+        <p:spPr>
+          <a:xfrm>
+            <a:off x="11430000" y="2194560"/>
+            <a:ext cx="91440" cy="91440"/>
+          </a:xfrm>
+          <a:prstGeom prst="ellipse">
+            <a:avLst/>
+          </a:prstGeom>
+          <a:solidFill>
+            <a:srgbClr val="FFFFFF"/>
+          </a:solidFill>
+          <a:ln w="12700">
+            <a:solidFill>
+              <a:srgbClr val="287DFA"/>
+            </a:solidFill>
+          </a:ln>
+          <a:effectLst/>
+        </p:spPr>
+        <p:style>
+          <a:lnRef idx="1">
+            <a:schemeClr val="accent1"/>
+          </a:lnRef>
+          <a:fillRef idx="3">
+            <a:schemeClr val="accent1"/>
+          </a:fillRef>
+          <a:effectRef idx="2">
+            <a:schemeClr val="accent1"/>
+          </a:effectRef>
+          <a:fontRef idx="minor">
+            <a:schemeClr val="lt1"/>
+          </a:fontRef>
+        </p:style>
+        <p:txBody>
+          <a:bodyPr rtlCol="0" anchor="ctr"/>
+          <a:lstStyle/>
+          <a:p/>
+        </p:txBody>
+      </p:sp>
+      <p:cxnSp>
+        <p:nvCxnSpPr>
+          <p:cNvPr id="49" name="Connector 48"/>
+          <p:cNvCxnSpPr/>
+          <p:nvPr/>
+        </p:nvCxnSpPr>
+        <p:spPr>
+          <a:xfrm>
+            <a:off x="11475720" y="2313432"/>
+            <a:ext cx="0" cy="3739896"/>
+          </a:xfrm>
+          <a:prstGeom prst="line">
+            <a:avLst/>
+          </a:prstGeom>
+          <a:ln w="9525">
+            <a:solidFill>
+              <a:srgbClr val="E3EBF8"/>
+            </a:solidFill>
+            <a:prstDash val="dash"/>
+          </a:ln>
+        </p:spPr>
+        <p:style>
+          <a:lnRef idx="2">
+            <a:schemeClr val="accent1"/>
+          </a:lnRef>
+          <a:fillRef idx="0">
+            <a:schemeClr val="accent1"/>
+          </a:fillRef>
+          <a:effectRef idx="1">
+            <a:schemeClr val="accent1"/>
+          </a:effectRef>
+          <a:fontRef idx="minor">
+            <a:schemeClr val="tx1"/>
+          </a:fontRef>
+        </p:style>
+      </p:cxnSp>
+      <p:sp>
+        <p:nvSpPr>
+          <p:cNvPr id="50" name="Rounded Rectangle 49"/>
+          <p:cNvSpPr/>
+          <p:nvPr/>
+        </p:nvSpPr>
+        <p:spPr>
+          <a:xfrm>
+            <a:off x="3547872" y="2432304"/>
+            <a:ext cx="1005840" cy="941831"/>
           </a:xfrm>
           <a:prstGeom prst="roundRect">
             <a:avLst>
@@ -21091,14 +21605,14 @@
       </p:sp>
       <p:sp>
         <p:nvSpPr>
-          <p:cNvPr id="38" name="TextBox 37"/>
+          <p:cNvPr id="51" name="TextBox 50"/>
           <p:cNvSpPr txBox="1"/>
           <p:nvPr/>
         </p:nvSpPr>
         <p:spPr>
           <a:xfrm>
-            <a:off x="3200400" y="2450592"/>
-            <a:ext cx="1005840" cy="1060704"/>
+            <a:off x="3547872" y="2432304"/>
+            <a:ext cx="1005840" cy="941831"/>
           </a:xfrm>
           <a:prstGeom prst="rect">
             <a:avLst/>
@@ -21146,14 +21660,14 @@
       </p:sp>
       <p:sp>
         <p:nvSpPr>
-          <p:cNvPr id="39" name="Rounded Rectangle 38"/>
+          <p:cNvPr id="52" name="Rounded Rectangle 51"/>
           <p:cNvSpPr/>
           <p:nvPr/>
         </p:nvSpPr>
         <p:spPr>
           <a:xfrm>
-            <a:off x="4343400" y="2450592"/>
-            <a:ext cx="1063358" cy="292607"/>
+            <a:off x="4663440" y="2432304"/>
+            <a:ext cx="795528" cy="265176"/>
           </a:xfrm>
           <a:prstGeom prst="roundRect">
             <a:avLst>
@@ -21190,14 +21704,14 @@
       </p:sp>
       <p:sp>
         <p:nvSpPr>
-          <p:cNvPr id="40" name="TextBox 39"/>
+          <p:cNvPr id="53" name="TextBox 52"/>
           <p:cNvSpPr txBox="1"/>
           <p:nvPr/>
         </p:nvSpPr>
         <p:spPr>
           <a:xfrm>
-            <a:off x="4343400" y="2450592"/>
-            <a:ext cx="1063358" cy="292607"/>
+            <a:off x="4663440" y="2432304"/>
+            <a:ext cx="795528" cy="265176"/>
           </a:xfrm>
           <a:prstGeom prst="rect">
             <a:avLst/>
@@ -21227,14 +21741,14 @@
       </p:sp>
       <p:sp>
         <p:nvSpPr>
-          <p:cNvPr id="41" name="Rounded Rectangle 40"/>
+          <p:cNvPr id="54" name="Rounded Rectangle 53"/>
           <p:cNvSpPr/>
           <p:nvPr/>
         </p:nvSpPr>
         <p:spPr>
           <a:xfrm>
-            <a:off x="5440679" y="2834640"/>
-            <a:ext cx="1426169" cy="292607"/>
+            <a:off x="4846320" y="2770632"/>
+            <a:ext cx="1810511" cy="265176"/>
           </a:xfrm>
           <a:prstGeom prst="roundRect">
             <a:avLst>
@@ -21271,14 +21785,14 @@
       </p:sp>
       <p:sp>
         <p:nvSpPr>
-          <p:cNvPr id="42" name="TextBox 41"/>
+          <p:cNvPr id="55" name="TextBox 54"/>
           <p:cNvSpPr txBox="1"/>
           <p:nvPr/>
         </p:nvSpPr>
         <p:spPr>
           <a:xfrm>
-            <a:off x="5440679" y="2834640"/>
-            <a:ext cx="1426169" cy="292607"/>
+            <a:off x="4846320" y="2770632"/>
+            <a:ext cx="1810511" cy="265176"/>
           </a:xfrm>
           <a:prstGeom prst="rect">
             <a:avLst/>
@@ -21301,21 +21815,21 @@
                 <a:ea typeface="微软雅黑"/>
                 <a:cs typeface="微软雅黑"/>
               </a:rPr>
-              <a:t>一期：意图识别</a:t>
-            </a:r>
-          </a:p>
-        </p:txBody>
-      </p:sp>
-      <p:sp>
-        <p:nvSpPr>
-          <p:cNvPr id="43" name="Rounded Rectangle 42"/>
+              <a:t>Agent 1.0 意图识别优化</a:t>
+            </a:r>
+          </a:p>
+        </p:txBody>
+      </p:sp>
+      <p:sp>
+        <p:nvSpPr>
+          <p:cNvPr id="56" name="Rounded Rectangle 55"/>
           <p:cNvSpPr/>
           <p:nvPr/>
         </p:nvSpPr>
         <p:spPr>
           <a:xfrm>
-            <a:off x="6900770" y="3218688"/>
-            <a:ext cx="1648869" cy="292607"/>
+            <a:off x="6583680" y="3108960"/>
+            <a:ext cx="2235707" cy="265176"/>
           </a:xfrm>
           <a:prstGeom prst="roundRect">
             <a:avLst>
@@ -21352,14 +21866,14 @@
       </p:sp>
       <p:sp>
         <p:nvSpPr>
-          <p:cNvPr id="44" name="TextBox 43"/>
+          <p:cNvPr id="57" name="TextBox 56"/>
           <p:cNvSpPr txBox="1"/>
           <p:nvPr/>
         </p:nvSpPr>
         <p:spPr>
           <a:xfrm>
-            <a:off x="6900770" y="3218688"/>
-            <a:ext cx="1648869" cy="292607"/>
+            <a:off x="6583680" y="3108960"/>
+            <a:ext cx="2235707" cy="265176"/>
           </a:xfrm>
           <a:prstGeom prst="rect">
             <a:avLst/>
@@ -21382,21 +21896,21 @@
                 <a:ea typeface="微软雅黑"/>
                 <a:cs typeface="微软雅黑"/>
               </a:rPr>
-              <a:t>二期：验收与拒答治理</a:t>
-            </a:r>
-          </a:p>
-        </p:txBody>
-      </p:sp>
-      <p:sp>
-        <p:nvSpPr>
-          <p:cNvPr id="45" name="Rounded Rectangle 44"/>
+              <a:t>Agent 2.0 拒答治理与数据回收</a:t>
+            </a:r>
+          </a:p>
+        </p:txBody>
+      </p:sp>
+      <p:sp>
+        <p:nvSpPr>
+          <p:cNvPr id="58" name="Rounded Rectangle 57"/>
           <p:cNvSpPr/>
           <p:nvPr/>
         </p:nvSpPr>
         <p:spPr>
           <a:xfrm>
-            <a:off x="3200400" y="3803904"/>
-            <a:ext cx="1005840" cy="2212848"/>
+            <a:off x="3547872" y="3611880"/>
+            <a:ext cx="1005840" cy="2295144"/>
           </a:xfrm>
           <a:prstGeom prst="roundRect">
             <a:avLst>
@@ -21433,14 +21947,14 @@
       </p:sp>
       <p:sp>
         <p:nvSpPr>
-          <p:cNvPr id="46" name="TextBox 45"/>
+          <p:cNvPr id="59" name="TextBox 58"/>
           <p:cNvSpPr txBox="1"/>
           <p:nvPr/>
         </p:nvSpPr>
         <p:spPr>
           <a:xfrm>
-            <a:off x="3200400" y="3803904"/>
-            <a:ext cx="1005840" cy="2212848"/>
+            <a:off x="3547872" y="3611880"/>
+            <a:ext cx="1005840" cy="2295144"/>
           </a:xfrm>
           <a:prstGeom prst="rect">
             <a:avLst/>
@@ -21470,14 +21984,14 @@
       </p:sp>
       <p:sp>
         <p:nvSpPr>
-          <p:cNvPr id="47" name="Rounded Rectangle 46"/>
+          <p:cNvPr id="60" name="Rounded Rectangle 59"/>
           <p:cNvSpPr/>
           <p:nvPr/>
         </p:nvSpPr>
         <p:spPr>
           <a:xfrm>
-            <a:off x="7138219" y="3803904"/>
-            <a:ext cx="2054548" cy="292607"/>
+            <a:off x="7026131" y="3611880"/>
+            <a:ext cx="1837452" cy="265176"/>
           </a:xfrm>
           <a:prstGeom prst="roundRect">
             <a:avLst>
@@ -21514,14 +22028,14 @@
       </p:sp>
       <p:sp>
         <p:nvSpPr>
-          <p:cNvPr id="48" name="TextBox 47"/>
+          <p:cNvPr id="61" name="TextBox 60"/>
           <p:cNvSpPr txBox="1"/>
           <p:nvPr/>
         </p:nvSpPr>
         <p:spPr>
           <a:xfrm>
-            <a:off x="7138219" y="3803904"/>
-            <a:ext cx="2054548" cy="292607"/>
+            <a:off x="7026131" y="3611880"/>
+            <a:ext cx="1837452" cy="265176"/>
           </a:xfrm>
           <a:prstGeom prst="rect">
             <a:avLst/>
@@ -21551,14 +22065,14 @@
       </p:sp>
       <p:sp>
         <p:nvSpPr>
-          <p:cNvPr id="49" name="Rounded Rectangle 48"/>
+          <p:cNvPr id="62" name="Rounded Rectangle 61"/>
           <p:cNvSpPr/>
           <p:nvPr/>
         </p:nvSpPr>
         <p:spPr>
           <a:xfrm>
-            <a:off x="7680959" y="4187952"/>
-            <a:ext cx="2409444" cy="292607"/>
+            <a:off x="7498079" y="3950208"/>
+            <a:ext cx="2354579" cy="265176"/>
           </a:xfrm>
           <a:prstGeom prst="roundRect">
             <a:avLst>
@@ -21595,14 +22109,14 @@
       </p:sp>
       <p:sp>
         <p:nvSpPr>
-          <p:cNvPr id="50" name="TextBox 49"/>
+          <p:cNvPr id="63" name="TextBox 62"/>
           <p:cNvSpPr txBox="1"/>
           <p:nvPr/>
         </p:nvSpPr>
         <p:spPr>
           <a:xfrm>
-            <a:off x="7680959" y="4187952"/>
-            <a:ext cx="2409444" cy="292607"/>
+            <a:off x="7498079" y="3950208"/>
+            <a:ext cx="2354579" cy="265176"/>
           </a:xfrm>
           <a:prstGeom prst="rect">
             <a:avLst/>
@@ -21625,21 +22139,21 @@
                 <a:ea typeface="微软雅黑"/>
                 <a:cs typeface="微软雅黑"/>
               </a:rPr>
-              <a:t>智能第二程接直付 · 口径修正</a:t>
-            </a:r>
-          </a:p>
-        </p:txBody>
-      </p:sp>
-      <p:sp>
-        <p:nvSpPr>
-          <p:cNvPr id="51" name="Rounded Rectangle 50"/>
+              <a:t>智能第二程接直付与直付标记修复</a:t>
+            </a:r>
+          </a:p>
+        </p:txBody>
+      </p:sp>
+      <p:sp>
+        <p:nvSpPr>
+          <p:cNvPr id="64" name="Rounded Rectangle 63"/>
           <p:cNvSpPr/>
           <p:nvPr/>
         </p:nvSpPr>
         <p:spPr>
           <a:xfrm>
-            <a:off x="7909559" y="4572000"/>
-            <a:ext cx="1897380" cy="292607"/>
+            <a:off x="7704557" y="4288536"/>
+            <a:ext cx="2673882" cy="265176"/>
           </a:xfrm>
           <a:prstGeom prst="roundRect">
             <a:avLst>
@@ -21676,14 +22190,14 @@
       </p:sp>
       <p:sp>
         <p:nvSpPr>
-          <p:cNvPr id="52" name="TextBox 51"/>
+          <p:cNvPr id="65" name="TextBox 64"/>
           <p:cNvSpPr txBox="1"/>
           <p:nvPr/>
         </p:nvSpPr>
         <p:spPr>
           <a:xfrm>
-            <a:off x="7909559" y="4572000"/>
-            <a:ext cx="1897380" cy="292607"/>
+            <a:off x="7704557" y="4288536"/>
+            <a:ext cx="2673882" cy="265176"/>
           </a:xfrm>
           <a:prstGeom prst="rect">
             <a:avLst/>
@@ -21713,14 +22227,14 @@
       </p:sp>
       <p:sp>
         <p:nvSpPr>
-          <p:cNvPr id="53" name="Rounded Rectangle 52"/>
+          <p:cNvPr id="66" name="Rounded Rectangle 65"/>
           <p:cNvSpPr/>
           <p:nvPr/>
         </p:nvSpPr>
         <p:spPr>
           <a:xfrm>
-            <a:off x="8412480" y="4956048"/>
-            <a:ext cx="2055875" cy="292607"/>
+            <a:off x="8158807" y="4626864"/>
+            <a:ext cx="1856920" cy="265176"/>
           </a:xfrm>
           <a:prstGeom prst="roundRect">
             <a:avLst>
@@ -21757,14 +22271,14 @@
       </p:sp>
       <p:sp>
         <p:nvSpPr>
-          <p:cNvPr id="54" name="TextBox 53"/>
+          <p:cNvPr id="67" name="TextBox 66"/>
           <p:cNvSpPr txBox="1"/>
           <p:nvPr/>
         </p:nvSpPr>
         <p:spPr>
           <a:xfrm>
-            <a:off x="8412480" y="4956048"/>
-            <a:ext cx="2055875" cy="292607"/>
+            <a:off x="8158807" y="4626864"/>
+            <a:ext cx="1856920" cy="265176"/>
           </a:xfrm>
           <a:prstGeom prst="rect">
             <a:avLst/>
@@ -21794,14 +22308,14 @@
       </p:sp>
       <p:sp>
         <p:nvSpPr>
-          <p:cNvPr id="55" name="Rounded Rectangle 54"/>
+          <p:cNvPr id="68" name="Rounded Rectangle 67"/>
           <p:cNvSpPr/>
           <p:nvPr/>
         </p:nvSpPr>
         <p:spPr>
           <a:xfrm>
-            <a:off x="9523476" y="5340096"/>
-            <a:ext cx="1490619" cy="292607"/>
+            <a:off x="9162288" y="4965192"/>
+            <a:ext cx="1490472" cy="265176"/>
           </a:xfrm>
           <a:prstGeom prst="roundRect">
             <a:avLst>
@@ -21838,14 +22352,14 @@
       </p:sp>
       <p:sp>
         <p:nvSpPr>
-          <p:cNvPr id="56" name="TextBox 55"/>
+          <p:cNvPr id="69" name="TextBox 68"/>
           <p:cNvSpPr txBox="1"/>
           <p:nvPr/>
         </p:nvSpPr>
         <p:spPr>
           <a:xfrm>
-            <a:off x="9523476" y="5340096"/>
-            <a:ext cx="1490619" cy="292607"/>
+            <a:off x="9162288" y="4965192"/>
+            <a:ext cx="1490472" cy="265176"/>
           </a:xfrm>
           <a:prstGeom prst="rect">
             <a:avLst/>
@@ -21875,14 +22389,14 @@
       </p:sp>
       <p:sp>
         <p:nvSpPr>
-          <p:cNvPr id="57" name="Rounded Rectangle 56"/>
+          <p:cNvPr id="70" name="Rounded Rectangle 69"/>
           <p:cNvSpPr/>
           <p:nvPr/>
         </p:nvSpPr>
         <p:spPr>
           <a:xfrm>
-            <a:off x="9712452" y="5724144"/>
-            <a:ext cx="1362456" cy="292607"/>
+            <a:off x="9332976" y="5303520"/>
+            <a:ext cx="1362456" cy="265176"/>
           </a:xfrm>
           <a:prstGeom prst="roundRect">
             <a:avLst>
@@ -21919,14 +22433,14 @@
       </p:sp>
       <p:sp>
         <p:nvSpPr>
-          <p:cNvPr id="58" name="TextBox 57"/>
+          <p:cNvPr id="71" name="TextBox 70"/>
           <p:cNvSpPr txBox="1"/>
           <p:nvPr/>
         </p:nvSpPr>
         <p:spPr>
           <a:xfrm>
-            <a:off x="9712452" y="5724144"/>
-            <a:ext cx="1362456" cy="292607"/>
+            <a:off x="9332976" y="5303520"/>
+            <a:ext cx="1362456" cy="265176"/>
           </a:xfrm>
           <a:prstGeom prst="rect">
             <a:avLst/>
@@ -21950,6 +22464,87 @@
                 <a:cs typeface="微软雅黑"/>
               </a:rPr>
               <a:t>在线换座体验优化</a:t>
+            </a:r>
+          </a:p>
+        </p:txBody>
+      </p:sp>
+      <p:sp>
+        <p:nvSpPr>
+          <p:cNvPr id="72" name="Rounded Rectangle 71"/>
+          <p:cNvSpPr/>
+          <p:nvPr/>
+        </p:nvSpPr>
+        <p:spPr>
+          <a:xfrm>
+            <a:off x="10698480" y="5641848"/>
+            <a:ext cx="1014983" cy="265176"/>
+          </a:xfrm>
+          <a:prstGeom prst="roundRect">
+            <a:avLst>
+              <a:gd name="adj" fmla="val 30000"/>
+            </a:avLst>
+          </a:prstGeom>
+          <a:solidFill>
+            <a:srgbClr val="15315E"/>
+          </a:solidFill>
+          <a:ln>
+            <a:noFill/>
+          </a:ln>
+          <a:effectLst/>
+        </p:spPr>
+        <p:style>
+          <a:lnRef idx="1">
+            <a:schemeClr val="accent1"/>
+          </a:lnRef>
+          <a:fillRef idx="3">
+            <a:schemeClr val="accent1"/>
+          </a:fillRef>
+          <a:effectRef idx="2">
+            <a:schemeClr val="accent1"/>
+          </a:effectRef>
+          <a:fontRef idx="minor">
+            <a:schemeClr val="lt1"/>
+          </a:fontRef>
+        </p:style>
+        <p:txBody>
+          <a:bodyPr rtlCol="0" anchor="ctr"/>
+          <a:lstStyle/>
+          <a:p/>
+        </p:txBody>
+      </p:sp>
+      <p:sp>
+        <p:nvSpPr>
+          <p:cNvPr id="73" name="TextBox 72"/>
+          <p:cNvSpPr txBox="1"/>
+          <p:nvPr/>
+        </p:nvSpPr>
+        <p:spPr>
+          <a:xfrm>
+            <a:off x="10698480" y="5641848"/>
+            <a:ext cx="1014983" cy="265176"/>
+          </a:xfrm>
+          <a:prstGeom prst="rect">
+            <a:avLst/>
+          </a:prstGeom>
+          <a:noFill/>
+        </p:spPr>
+        <p:txBody>
+          <a:bodyPr wrap="square" lIns="0" rIns="0" tIns="0" bIns="0" anchor="ctr">
+            <a:spAutoFit/>
+          </a:bodyPr>
+          <a:lstStyle/>
+          <a:p>
+            <a:pPr algn="ctr"/>
+            <a:r>
+              <a:rPr sz="1100" b="1">
+                <a:solidFill>
+                  <a:srgbClr val="FFFFFF"/>
+                </a:solidFill>
+                <a:latin typeface="微软雅黑"/>
+                <a:ea typeface="微软雅黑"/>
+                <a:cs typeface="微软雅黑"/>
+              </a:rPr>
+              <a:t>微信直付 V1</a:t>
             </a:r>
           </a:p>
         </p:txBody>

</xml_diff>